<commit_message>
Propagate F13 fully: 13 findings, and 64 tables was never right
F13's own commit missed two things it should have fixed:

- The deck still said '12 findings' (slide 1) and 'Twelve findings' (slide 16).
  There are 13. Corrected in the deck and the PPT prompt.
- 'Untested at 64 tables' appeared in the deck, architecture doc, FINDINGS and
  the prompt. 64 was the stale statement count AND the wrong unit - the estate
  is 52 tables / 70 CREATE statements. Corrected to full-estate scale everywhere.

Full sweep now clean: no stale count remains in any doc or the deck.

Co-Authored-By: Claude Opus 4.8 <noreply@anthropic.com>
Claude-Session: https://claude.ai/code/session_01K8zkg1ABYKGv6DLUxPXUSx
</commit_message>
<xml_diff>
--- a/docs/DCM_Presentation.pptx
+++ b/docs/DCM_Presentation.pptx
@@ -3337,7 +3337,7 @@
                 </a:solidFill>
                 <a:latin typeface="DejaVu Sans"/>
               </a:rPr>
-              <a:t>DCM Projects  ·  8 tables  ·  53 columns  ·  12 findings</a:t>
+              <a:t>DCM Projects  ·  8 tables  ·  53 columns  ·  13 findings</a:t>
             </a:r>
           </a:p>
           <a:p>
@@ -7943,7 +7943,7 @@
                 </a:solidFill>
                 <a:latin typeface="DejaVu Sans"/>
               </a:rPr>
-              <a:t>Twelve findings. Four came from deliberate sabotage.</a:t>
+              <a:t>Thirteen findings. Four came from deliberate sabotage.</a:t>
             </a:r>
           </a:p>
         </p:txBody>
@@ -10110,7 +10110,7 @@
                 </a:solidFill>
                 <a:latin typeface="DejaVu Sans"/>
               </a:rPr>
-              <a:t>Untested at 64 tables</a:t>
+              <a:t>Untested at full-estate scale (52 tables, 70 statements)</a:t>
             </a:r>
           </a:p>
         </p:txBody>

</xml_diff>

<commit_message>
Add two deck slides on expectations (data-quality gates)
Both decks now 15 -> 17 slides, inserted after the demo agenda and before the
close so they bridge into 'where this goes next'.

Slide 15 (concept): the same declarative project that proves the schema matches
can prove the data passes. Two-guarantee diagram - structure (PLAN, this POC)
and data quality (snow dcm test, not yet used) converging on the same table.

Slide 16 (examples): real ATTACH DATA METRIC FUNCTION ... EXPECTATION syntax
verified against the docs (left side is always keyword VALUE; no subqueries,
casts or arithmetic), plus a snow dcm test pass/fail result. Examples use system
DMFs NULL_COUNT and DUPLICATE_COUNT on the capacities dimension.

Layout self-check CLEAN on the .pptx; HTML counters 01-17 sequential, tags balanced.

Co-Authored-By: Claude Opus 4.8 <noreply@anthropic.com>
Claude-Session: https://claude.ai/code/session_01K8zkg1ABYKGv6DLUxPXUSx
</commit_message>
<xml_diff>
--- a/docs/DCM_Presentation.pptx
+++ b/docs/DCM_Presentation.pptx
@@ -20,6 +20,8 @@
     <p:sldId id="268" r:id="rId19"/>
     <p:sldId id="269" r:id="rId20"/>
     <p:sldId id="270" r:id="rId21"/>
+    <p:sldId id="271" r:id="rId22"/>
+    <p:sldId id="272" r:id="rId23"/>
   </p:sldIdLst>
   <p:sldSz cx="12191695" cy="6858000" type="screen4x3"/>
   <p:notesSz cx="6858000" cy="9144000"/>
@@ -3684,7 +3686,7 @@
                 </a:solidFill>
                 <a:latin typeface="DejaVu Sans Mono"/>
               </a:rPr>
-              <a:t> / 15</a:t>
+              <a:t> / 17</a:t>
             </a:r>
           </a:p>
         </p:txBody>
@@ -4715,7 +4717,7 @@
                 </a:solidFill>
                 <a:latin typeface="DejaVu Sans Mono"/>
               </a:rPr>
-              <a:t> / 15</a:t>
+              <a:t> / 17</a:t>
             </a:r>
           </a:p>
         </p:txBody>
@@ -6153,7 +6155,7 @@
                 </a:solidFill>
                 <a:latin typeface="DejaVu Sans Mono"/>
               </a:rPr>
-              <a:t> / 15</a:t>
+              <a:t> / 17</a:t>
             </a:r>
           </a:p>
         </p:txBody>
@@ -7020,7 +7022,7 @@
                 </a:solidFill>
                 <a:latin typeface="DejaVu Sans Mono"/>
               </a:rPr>
-              <a:t> / 15</a:t>
+              <a:t> / 17</a:t>
             </a:r>
           </a:p>
         </p:txBody>
@@ -8096,7 +8098,7 @@
                 </a:solidFill>
                 <a:latin typeface="DejaVu Sans Mono"/>
               </a:rPr>
-              <a:t> / 15</a:t>
+              <a:t> / 17</a:t>
             </a:r>
           </a:p>
         </p:txBody>
@@ -9037,7 +9039,7 @@
                 </a:solidFill>
                 <a:latin typeface="DejaVu Sans Mono"/>
               </a:rPr>
-              <a:t> / 15</a:t>
+              <a:t> / 17</a:t>
             </a:r>
           </a:p>
         </p:txBody>
@@ -9193,6 +9195,1989 @@
                 </a:solidFill>
                 <a:latin typeface="DejaVu Sans Mono"/>
               </a:rPr>
+              <a:t>BEYOND SCHEMA · WHAT'S NEXT</a:t>
+            </a:r>
+          </a:p>
+        </p:txBody>
+      </p:sp>
+      <p:sp>
+        <p:nvSpPr>
+          <p:cNvPr id="5" name="Rectangle 4"/>
+          <p:cNvSpPr/>
+          <p:nvPr/>
+        </p:nvSpPr>
+        <p:spPr>
+          <a:xfrm>
+            <a:off x="960120" y="2743200"/>
+            <a:ext cx="2468880" cy="777240"/>
+          </a:xfrm>
+          <a:prstGeom prst="rect">
+            <a:avLst/>
+          </a:prstGeom>
+          <a:solidFill>
+            <a:srgbClr val="FFFFFF"/>
+          </a:solidFill>
+          <a:ln w="12700">
+            <a:solidFill>
+              <a:srgbClr val="C2CAD1"/>
+            </a:solidFill>
+          </a:ln>
+          <a:effectLst/>
+        </p:spPr>
+        <p:style>
+          <a:lnRef idx="1">
+            <a:schemeClr val="accent1"/>
+          </a:lnRef>
+          <a:fillRef idx="3">
+            <a:schemeClr val="accent1"/>
+          </a:fillRef>
+          <a:effectRef idx="2">
+            <a:schemeClr val="accent1"/>
+          </a:effectRef>
+          <a:fontRef idx="minor">
+            <a:schemeClr val="lt1"/>
+          </a:fontRef>
+        </p:style>
+        <p:txBody>
+          <a:bodyPr rtlCol="0" anchor="ctr"/>
+          <a:lstStyle/>
+          <a:p>
+            <a:pPr algn="ctr"/>
+          </a:p>
+        </p:txBody>
+      </p:sp>
+      <p:sp>
+        <p:nvSpPr>
+          <p:cNvPr id="6" name="TextBox 5"/>
+          <p:cNvSpPr txBox="1"/>
+          <p:nvPr/>
+        </p:nvSpPr>
+        <p:spPr>
+          <a:xfrm>
+            <a:off x="960120" y="2839212"/>
+            <a:ext cx="2468880" cy="777240"/>
+          </a:xfrm>
+          <a:prstGeom prst="rect">
+            <a:avLst/>
+          </a:prstGeom>
+          <a:noFill/>
+        </p:spPr>
+        <p:txBody>
+          <a:bodyPr wrap="square" anchor="t" lIns="0" rIns="0" tIns="0" bIns="0">
+            <a:spAutoFit/>
+          </a:bodyPr>
+          <a:lstStyle/>
+          <a:p>
+            <a:pPr algn="ctr">
+              <a:spcBef>
+                <a:spcPts val="0"/>
+              </a:spcBef>
+              <a:spcAft>
+                <a:spcPts val="300"/>
+              </a:spcAft>
+            </a:pPr>
+            <a:r>
+              <a:rPr sz="1250" b="1">
+                <a:solidFill>
+                  <a:srgbClr val="25313A"/>
+                </a:solidFill>
+                <a:latin typeface="DejaVu Sans Mono"/>
+              </a:rPr>
+              <a:t>does it MATCH?</a:t>
+            </a:r>
+          </a:p>
+          <a:p>
+            <a:pPr algn="ctr">
+              <a:spcBef>
+                <a:spcPts val="0"/>
+              </a:spcBef>
+              <a:spcAft>
+                <a:spcPts val="300"/>
+              </a:spcAft>
+            </a:pPr>
+            <a:r>
+              <a:rPr sz="1000" b="0">
+                <a:solidFill>
+                  <a:srgbClr val="6C7B88"/>
+                </a:solidFill>
+                <a:latin typeface="DejaVu Sans Mono"/>
+              </a:rPr>
+              <a:t>PLAN · structure</a:t>
+            </a:r>
+          </a:p>
+        </p:txBody>
+      </p:sp>
+      <p:sp>
+        <p:nvSpPr>
+          <p:cNvPr id="7" name="Rectangle 6"/>
+          <p:cNvSpPr/>
+          <p:nvPr/>
+        </p:nvSpPr>
+        <p:spPr>
+          <a:xfrm>
+            <a:off x="960120" y="4297680"/>
+            <a:ext cx="2468880" cy="777240"/>
+          </a:xfrm>
+          <a:prstGeom prst="rect">
+            <a:avLst/>
+          </a:prstGeom>
+          <a:solidFill>
+            <a:srgbClr val="F6E9D6"/>
+          </a:solidFill>
+          <a:ln w="12700">
+            <a:solidFill>
+              <a:srgbClr val="E3B173"/>
+            </a:solidFill>
+          </a:ln>
+          <a:effectLst/>
+        </p:spPr>
+        <p:style>
+          <a:lnRef idx="1">
+            <a:schemeClr val="accent1"/>
+          </a:lnRef>
+          <a:fillRef idx="3">
+            <a:schemeClr val="accent1"/>
+          </a:fillRef>
+          <a:effectRef idx="2">
+            <a:schemeClr val="accent1"/>
+          </a:effectRef>
+          <a:fontRef idx="minor">
+            <a:schemeClr val="lt1"/>
+          </a:fontRef>
+        </p:style>
+        <p:txBody>
+          <a:bodyPr rtlCol="0" anchor="ctr"/>
+          <a:lstStyle/>
+          <a:p>
+            <a:pPr algn="ctr"/>
+          </a:p>
+        </p:txBody>
+      </p:sp>
+      <p:sp>
+        <p:nvSpPr>
+          <p:cNvPr id="8" name="TextBox 7"/>
+          <p:cNvSpPr txBox="1"/>
+          <p:nvPr/>
+        </p:nvSpPr>
+        <p:spPr>
+          <a:xfrm>
+            <a:off x="960120" y="4393692"/>
+            <a:ext cx="2468880" cy="777240"/>
+          </a:xfrm>
+          <a:prstGeom prst="rect">
+            <a:avLst/>
+          </a:prstGeom>
+          <a:noFill/>
+        </p:spPr>
+        <p:txBody>
+          <a:bodyPr wrap="square" anchor="t" lIns="0" rIns="0" tIns="0" bIns="0">
+            <a:spAutoFit/>
+          </a:bodyPr>
+          <a:lstStyle/>
+          <a:p>
+            <a:pPr algn="ctr">
+              <a:spcBef>
+                <a:spcPts val="0"/>
+              </a:spcBef>
+              <a:spcAft>
+                <a:spcPts val="300"/>
+              </a:spcAft>
+            </a:pPr>
+            <a:r>
+              <a:rPr sz="1250" b="1">
+                <a:solidFill>
+                  <a:srgbClr val="8A5210"/>
+                </a:solidFill>
+                <a:latin typeface="DejaVu Sans Mono"/>
+              </a:rPr>
+              <a:t>does the data PASS?</a:t>
+            </a:r>
+          </a:p>
+          <a:p>
+            <a:pPr algn="ctr">
+              <a:spcBef>
+                <a:spcPts val="0"/>
+              </a:spcBef>
+              <a:spcAft>
+                <a:spcPts val="300"/>
+              </a:spcAft>
+            </a:pPr>
+            <a:r>
+              <a:rPr sz="1000" b="0">
+                <a:solidFill>
+                  <a:srgbClr val="8A5210"/>
+                </a:solidFill>
+                <a:latin typeface="DejaVu Sans Mono"/>
+              </a:rPr>
+              <a:t>snow dcm test</a:t>
+            </a:r>
+          </a:p>
+        </p:txBody>
+      </p:sp>
+      <p:sp>
+        <p:nvSpPr>
+          <p:cNvPr id="9" name="Rectangle 8"/>
+          <p:cNvSpPr/>
+          <p:nvPr/>
+        </p:nvSpPr>
+        <p:spPr>
+          <a:xfrm>
+            <a:off x="4892040" y="3520440"/>
+            <a:ext cx="2194560" cy="868680"/>
+          </a:xfrm>
+          <a:prstGeom prst="rect">
+            <a:avLst/>
+          </a:prstGeom>
+          <a:solidFill>
+            <a:srgbClr val="36454F"/>
+          </a:solidFill>
+          <a:ln w="12700">
+            <a:solidFill>
+              <a:srgbClr val="C2CAD1"/>
+            </a:solidFill>
+          </a:ln>
+          <a:effectLst/>
+        </p:spPr>
+        <p:style>
+          <a:lnRef idx="1">
+            <a:schemeClr val="accent1"/>
+          </a:lnRef>
+          <a:fillRef idx="3">
+            <a:schemeClr val="accent1"/>
+          </a:fillRef>
+          <a:effectRef idx="2">
+            <a:schemeClr val="accent1"/>
+          </a:effectRef>
+          <a:fontRef idx="minor">
+            <a:schemeClr val="lt1"/>
+          </a:fontRef>
+        </p:style>
+        <p:txBody>
+          <a:bodyPr rtlCol="0" anchor="ctr"/>
+          <a:lstStyle/>
+          <a:p>
+            <a:pPr algn="ctr"/>
+          </a:p>
+        </p:txBody>
+      </p:sp>
+      <p:sp>
+        <p:nvSpPr>
+          <p:cNvPr id="10" name="TextBox 9"/>
+          <p:cNvSpPr txBox="1"/>
+          <p:nvPr/>
+        </p:nvSpPr>
+        <p:spPr>
+          <a:xfrm>
+            <a:off x="4892040" y="3662172"/>
+            <a:ext cx="2194560" cy="868680"/>
+          </a:xfrm>
+          <a:prstGeom prst="rect">
+            <a:avLst/>
+          </a:prstGeom>
+          <a:noFill/>
+        </p:spPr>
+        <p:txBody>
+          <a:bodyPr wrap="square" anchor="t" lIns="0" rIns="0" tIns="0" bIns="0">
+            <a:spAutoFit/>
+          </a:bodyPr>
+          <a:lstStyle/>
+          <a:p>
+            <a:pPr algn="ctr">
+              <a:spcBef>
+                <a:spcPts val="0"/>
+              </a:spcBef>
+              <a:spcAft>
+                <a:spcPts val="300"/>
+              </a:spcAft>
+            </a:pPr>
+            <a:r>
+              <a:rPr sz="1300" b="1">
+                <a:solidFill>
+                  <a:srgbClr val="FFFFFF"/>
+                </a:solidFill>
+                <a:latin typeface="DejaVu Sans Mono"/>
+              </a:rPr>
+              <a:t>the table</a:t>
+            </a:r>
+          </a:p>
+          <a:p>
+            <a:pPr algn="ctr">
+              <a:spcBef>
+                <a:spcPts val="0"/>
+              </a:spcBef>
+              <a:spcAft>
+                <a:spcPts val="300"/>
+              </a:spcAft>
+            </a:pPr>
+            <a:r>
+              <a:rPr sz="1050" b="0">
+                <a:solidFill>
+                  <a:srgbClr val="B9C4CC"/>
+                </a:solidFill>
+                <a:latin typeface="DejaVu Sans Mono"/>
+              </a:rPr>
+              <a:t>PRE.DIM_PBI_…</a:t>
+            </a:r>
+          </a:p>
+        </p:txBody>
+      </p:sp>
+      <p:cxnSp>
+        <p:nvCxnSpPr>
+          <p:cNvPr id="11" name="Connector 10"/>
+          <p:cNvCxnSpPr/>
+          <p:nvPr/>
+        </p:nvCxnSpPr>
+        <p:spPr>
+          <a:xfrm>
+            <a:off x="3429000" y="3127248"/>
+            <a:ext cx="1444752" cy="576072"/>
+          </a:xfrm>
+          <a:prstGeom prst="bentConnector3">
+            <a:avLst/>
+          </a:prstGeom>
+          <a:ln w="17780">
+            <a:solidFill>
+              <a:srgbClr val="6C7B88"/>
+            </a:solidFill>
+            <a:tailEnd type="triangle" w="med" len="med"/>
+          </a:ln>
+          <a:effectLst/>
+        </p:spPr>
+        <p:style>
+          <a:lnRef idx="2">
+            <a:schemeClr val="accent1"/>
+          </a:lnRef>
+          <a:fillRef idx="0">
+            <a:schemeClr val="accent1"/>
+          </a:fillRef>
+          <a:effectRef idx="1">
+            <a:schemeClr val="accent1"/>
+          </a:effectRef>
+          <a:fontRef idx="minor">
+            <a:schemeClr val="tx1"/>
+          </a:fontRef>
+        </p:style>
+      </p:cxnSp>
+      <p:cxnSp>
+        <p:nvCxnSpPr>
+          <p:cNvPr id="12" name="Connector 11"/>
+          <p:cNvCxnSpPr/>
+          <p:nvPr/>
+        </p:nvCxnSpPr>
+        <p:spPr>
+          <a:xfrm flipV="1">
+            <a:off x="3429000" y="4160520"/>
+            <a:ext cx="1444752" cy="521208"/>
+          </a:xfrm>
+          <a:prstGeom prst="bentConnector3">
+            <a:avLst/>
+          </a:prstGeom>
+          <a:ln w="17780">
+            <a:solidFill>
+              <a:srgbClr val="B26B12"/>
+            </a:solidFill>
+            <a:tailEnd type="triangle" w="med" len="med"/>
+          </a:ln>
+          <a:effectLst/>
+        </p:spPr>
+        <p:style>
+          <a:lnRef idx="2">
+            <a:schemeClr val="accent1"/>
+          </a:lnRef>
+          <a:fillRef idx="0">
+            <a:schemeClr val="accent1"/>
+          </a:fillRef>
+          <a:effectRef idx="1">
+            <a:schemeClr val="accent1"/>
+          </a:effectRef>
+          <a:fontRef idx="minor">
+            <a:schemeClr val="tx1"/>
+          </a:fontRef>
+        </p:style>
+      </p:cxnSp>
+      <p:sp>
+        <p:nvSpPr>
+          <p:cNvPr id="13" name="TextBox 12"/>
+          <p:cNvSpPr txBox="1"/>
+          <p:nvPr/>
+        </p:nvSpPr>
+        <p:spPr>
+          <a:xfrm>
+            <a:off x="3611880" y="3611880"/>
+            <a:ext cx="1371600" cy="274320"/>
+          </a:xfrm>
+          <a:prstGeom prst="rect">
+            <a:avLst/>
+          </a:prstGeom>
+          <a:noFill/>
+        </p:spPr>
+        <p:txBody>
+          <a:bodyPr wrap="square" anchor="t" lIns="0" rIns="0" tIns="0" bIns="0">
+            <a:spAutoFit/>
+          </a:bodyPr>
+          <a:lstStyle/>
+          <a:p>
+            <a:pPr algn="l">
+              <a:spcBef>
+                <a:spcPts val="0"/>
+              </a:spcBef>
+              <a:spcAft>
+                <a:spcPts val="400"/>
+              </a:spcAft>
+            </a:pPr>
+            <a:r>
+              <a:rPr sz="950" b="0">
+                <a:solidFill>
+                  <a:srgbClr val="9AA8B3"/>
+                </a:solidFill>
+                <a:latin typeface="DejaVu Sans Mono"/>
+              </a:rPr>
+              <a:t>this POC</a:t>
+            </a:r>
+          </a:p>
+        </p:txBody>
+      </p:sp>
+      <p:sp>
+        <p:nvSpPr>
+          <p:cNvPr id="14" name="TextBox 13"/>
+          <p:cNvSpPr txBox="1"/>
+          <p:nvPr/>
+        </p:nvSpPr>
+        <p:spPr>
+          <a:xfrm>
+            <a:off x="3611880" y="4224528"/>
+            <a:ext cx="1554480" cy="274320"/>
+          </a:xfrm>
+          <a:prstGeom prst="rect">
+            <a:avLst/>
+          </a:prstGeom>
+          <a:noFill/>
+        </p:spPr>
+        <p:txBody>
+          <a:bodyPr wrap="square" anchor="t" lIns="0" rIns="0" tIns="0" bIns="0">
+            <a:spAutoFit/>
+          </a:bodyPr>
+          <a:lstStyle/>
+          <a:p>
+            <a:pPr algn="l">
+              <a:spcBef>
+                <a:spcPts val="0"/>
+              </a:spcBef>
+              <a:spcAft>
+                <a:spcPts val="400"/>
+              </a:spcAft>
+            </a:pPr>
+            <a:r>
+              <a:rPr sz="950" b="0">
+                <a:solidFill>
+                  <a:srgbClr val="B26B12"/>
+                </a:solidFill>
+                <a:latin typeface="DejaVu Sans Mono"/>
+              </a:rPr>
+              <a:t>not yet used</a:t>
+            </a:r>
+          </a:p>
+        </p:txBody>
+      </p:sp>
+      <p:sp>
+        <p:nvSpPr>
+          <p:cNvPr id="15" name="TextBox 14"/>
+          <p:cNvSpPr txBox="1"/>
+          <p:nvPr/>
+        </p:nvSpPr>
+        <p:spPr>
+          <a:xfrm>
+            <a:off x="7543800" y="2468880"/>
+            <a:ext cx="3687775" cy="1463040"/>
+          </a:xfrm>
+          <a:prstGeom prst="rect">
+            <a:avLst/>
+          </a:prstGeom>
+          <a:noFill/>
+        </p:spPr>
+        <p:txBody>
+          <a:bodyPr wrap="square">
+            <a:spAutoFit/>
+          </a:bodyPr>
+          <a:lstStyle/>
+          <a:p>
+            <a:pPr>
+              <a:lnSpc>
+                <a:spcPct val="102000"/>
+              </a:lnSpc>
+            </a:pPr>
+            <a:r>
+              <a:rPr sz="2800" b="1">
+                <a:solidFill>
+                  <a:srgbClr val="25313A"/>
+                </a:solidFill>
+                <a:latin typeface="DejaVu Sans"/>
+              </a:rPr>
+              <a:t>Gate the </a:t>
+            </a:r>
+            <a:r>
+              <a:rPr sz="2800" b="1">
+                <a:solidFill>
+                  <a:srgbClr val="B26B12"/>
+                </a:solidFill>
+                <a:latin typeface="DejaVu Sans"/>
+              </a:rPr>
+              <a:t>data</a:t>
+            </a:r>
+            <a:r>
+              <a:rPr sz="2800" b="1">
+                <a:solidFill>
+                  <a:srgbClr val="25313A"/>
+                </a:solidFill>
+                <a:latin typeface="DejaVu Sans"/>
+              </a:rPr>
+              <a:t>,</a:t>
+            </a:r>
+          </a:p>
+        </p:txBody>
+      </p:sp>
+      <p:sp>
+        <p:nvSpPr>
+          <p:cNvPr id="16" name="TextBox 15"/>
+          <p:cNvSpPr txBox="1"/>
+          <p:nvPr/>
+        </p:nvSpPr>
+        <p:spPr>
+          <a:xfrm>
+            <a:off x="7543800" y="3154680"/>
+            <a:ext cx="3687775" cy="1463040"/>
+          </a:xfrm>
+          <a:prstGeom prst="rect">
+            <a:avLst/>
+          </a:prstGeom>
+          <a:noFill/>
+        </p:spPr>
+        <p:txBody>
+          <a:bodyPr wrap="square">
+            <a:spAutoFit/>
+          </a:bodyPr>
+          <a:lstStyle/>
+          <a:p>
+            <a:pPr>
+              <a:lnSpc>
+                <a:spcPct val="102000"/>
+              </a:lnSpc>
+            </a:pPr>
+            <a:r>
+              <a:rPr sz="2800" b="1">
+                <a:solidFill>
+                  <a:srgbClr val="25313A"/>
+                </a:solidFill>
+                <a:latin typeface="DejaVu Sans"/>
+              </a:rPr>
+              <a:t>not just the shape</a:t>
+            </a:r>
+          </a:p>
+        </p:txBody>
+      </p:sp>
+      <p:sp>
+        <p:nvSpPr>
+          <p:cNvPr id="17" name="TextBox 16"/>
+          <p:cNvSpPr txBox="1"/>
+          <p:nvPr/>
+        </p:nvSpPr>
+        <p:spPr>
+          <a:xfrm>
+            <a:off x="7543800" y="4023360"/>
+            <a:ext cx="3687775" cy="1005840"/>
+          </a:xfrm>
+          <a:prstGeom prst="rect">
+            <a:avLst/>
+          </a:prstGeom>
+          <a:noFill/>
+        </p:spPr>
+        <p:txBody>
+          <a:bodyPr wrap="square" anchor="t" lIns="0" rIns="0" tIns="0" bIns="0">
+            <a:spAutoFit/>
+          </a:bodyPr>
+          <a:lstStyle/>
+          <a:p>
+            <a:pPr algn="l">
+              <a:lnSpc>
+                <a:spcPct val="140000"/>
+              </a:lnSpc>
+              <a:spcBef>
+                <a:spcPts val="0"/>
+              </a:spcBef>
+              <a:spcAft>
+                <a:spcPts val="400"/>
+              </a:spcAft>
+            </a:pPr>
+            <a:r>
+              <a:rPr sz="1350" b="0">
+                <a:solidFill>
+                  <a:srgbClr val="6C7B88"/>
+                </a:solidFill>
+                <a:latin typeface="DejaVu Sans"/>
+              </a:rPr>
+              <a:t>This POC proved the database matches the repo. The same declarative project can prove the data passes — quality checks declared beside the schema.</a:t>
+            </a:r>
+          </a:p>
+        </p:txBody>
+      </p:sp>
+      <p:sp>
+        <p:nvSpPr>
+          <p:cNvPr id="18" name="TextBox 17"/>
+          <p:cNvSpPr txBox="1"/>
+          <p:nvPr/>
+        </p:nvSpPr>
+        <p:spPr>
+          <a:xfrm>
+            <a:off x="7543800" y="5257800"/>
+            <a:ext cx="3687775" cy="914400"/>
+          </a:xfrm>
+          <a:prstGeom prst="rect">
+            <a:avLst/>
+          </a:prstGeom>
+          <a:noFill/>
+        </p:spPr>
+        <p:txBody>
+          <a:bodyPr wrap="square" anchor="t" lIns="0" rIns="0" tIns="0" bIns="0">
+            <a:spAutoFit/>
+          </a:bodyPr>
+          <a:lstStyle/>
+          <a:p>
+            <a:pPr algn="l">
+              <a:lnSpc>
+                <a:spcPct val="140000"/>
+              </a:lnSpc>
+              <a:spcBef>
+                <a:spcPts val="0"/>
+              </a:spcBef>
+              <a:spcAft>
+                <a:spcPts val="400"/>
+              </a:spcAft>
+            </a:pPr>
+            <a:r>
+              <a:rPr sz="1350" b="0">
+                <a:solidFill>
+                  <a:srgbClr val="6C7B88"/>
+                </a:solidFill>
+                <a:latin typeface="DejaVu Sans"/>
+              </a:rPr>
+              <a:t>ATTACH a data metric function with an EXPECTATION, then </a:t>
+            </a:r>
+            <a:r>
+              <a:rPr sz="1150" b="0">
+                <a:solidFill>
+                  <a:srgbClr val="36454F"/>
+                </a:solidFill>
+                <a:latin typeface="DejaVu Sans Mono"/>
+              </a:rPr>
+              <a:t>snow dcm test</a:t>
+            </a:r>
+            <a:r>
+              <a:rPr sz="1350" b="1">
+                <a:solidFill>
+                  <a:srgbClr val="25313A"/>
+                </a:solidFill>
+                <a:latin typeface="DejaVu Sans"/>
+              </a:rPr>
+              <a:t>. A GA capability we never used.</a:t>
+            </a:r>
+          </a:p>
+        </p:txBody>
+      </p:sp>
+      <p:sp>
+        <p:nvSpPr>
+          <p:cNvPr id="19" name="TextBox 18"/>
+          <p:cNvSpPr txBox="1"/>
+          <p:nvPr/>
+        </p:nvSpPr>
+        <p:spPr>
+          <a:xfrm>
+            <a:off x="960120" y="6071616"/>
+            <a:ext cx="4572000" cy="274320"/>
+          </a:xfrm>
+          <a:prstGeom prst="rect">
+            <a:avLst/>
+          </a:prstGeom>
+          <a:noFill/>
+        </p:spPr>
+        <p:txBody>
+          <a:bodyPr wrap="square" anchor="t" lIns="0" rIns="0" tIns="0" bIns="0">
+            <a:spAutoFit/>
+          </a:bodyPr>
+          <a:lstStyle/>
+          <a:p>
+            <a:pPr algn="l">
+              <a:spcBef>
+                <a:spcPts val="0"/>
+              </a:spcBef>
+              <a:spcAft>
+                <a:spcPts val="400"/>
+              </a:spcAft>
+            </a:pPr>
+            <a:r>
+              <a:rPr sz="950" b="0">
+                <a:solidFill>
+                  <a:srgbClr val="9AA8B3"/>
+                </a:solidFill>
+                <a:latin typeface="DejaVu Sans Mono"/>
+              </a:rPr>
+              <a:t>BEYOND SCHEMA</a:t>
+            </a:r>
+          </a:p>
+        </p:txBody>
+      </p:sp>
+      <p:sp>
+        <p:nvSpPr>
+          <p:cNvPr id="20" name="TextBox 19"/>
+          <p:cNvSpPr txBox="1"/>
+          <p:nvPr/>
+        </p:nvSpPr>
+        <p:spPr>
+          <a:xfrm>
+            <a:off x="9037015" y="6071616"/>
+            <a:ext cx="2194560" cy="274320"/>
+          </a:xfrm>
+          <a:prstGeom prst="rect">
+            <a:avLst/>
+          </a:prstGeom>
+          <a:noFill/>
+        </p:spPr>
+        <p:txBody>
+          <a:bodyPr wrap="square" anchor="t" lIns="0" rIns="0" tIns="0" bIns="0">
+            <a:spAutoFit/>
+          </a:bodyPr>
+          <a:lstStyle/>
+          <a:p>
+            <a:pPr algn="r">
+              <a:spcBef>
+                <a:spcPts val="0"/>
+              </a:spcBef>
+              <a:spcAft>
+                <a:spcPts val="400"/>
+              </a:spcAft>
+            </a:pPr>
+            <a:r>
+              <a:rPr sz="950" b="1">
+                <a:solidFill>
+                  <a:srgbClr val="36454F"/>
+                </a:solidFill>
+                <a:latin typeface="DejaVu Sans Mono"/>
+              </a:rPr>
+              <a:t>15</a:t>
+            </a:r>
+            <a:r>
+              <a:rPr sz="950" b="0">
+                <a:solidFill>
+                  <a:srgbClr val="9AA8B3"/>
+                </a:solidFill>
+                <a:latin typeface="DejaVu Sans Mono"/>
+              </a:rPr>
+              <a:t> / 17</a:t>
+            </a:r>
+          </a:p>
+        </p:txBody>
+      </p:sp>
+    </p:spTree>
+  </p:cSld>
+  <p:clrMapOvr>
+    <a:masterClrMapping/>
+  </p:clrMapOvr>
+</p:sld>
+</file>
+
+<file path=ppt/slides/slide16.xml><?xml version="1.0" encoding="utf-8"?>
+<p:sld xmlns:a="http://schemas.openxmlformats.org/drawingml/2006/main" xmlns:p="http://schemas.openxmlformats.org/presentationml/2006/main" xmlns:r="http://schemas.openxmlformats.org/officeDocument/2006/relationships">
+  <p:cSld>
+    <p:bg>
+      <p:bgPr>
+        <a:solidFill>
+          <a:srgbClr val="FBFBFC"/>
+        </a:solidFill>
+        <a:effectLst/>
+      </p:bgPr>
+    </p:bg>
+    <p:spTree>
+      <p:nvGrpSpPr>
+        <p:cNvPr id="1" name=""/>
+        <p:cNvGrpSpPr/>
+        <p:nvPr/>
+      </p:nvGrpSpPr>
+      <p:grpSpPr/>
+      <p:sp>
+        <p:nvSpPr>
+          <p:cNvPr id="2" name="Rectangle 1"/>
+          <p:cNvSpPr/>
+          <p:nvPr/>
+        </p:nvSpPr>
+        <p:spPr>
+          <a:xfrm>
+            <a:off x="384048" y="384048"/>
+            <a:ext cx="11423599" cy="6089904"/>
+          </a:xfrm>
+          <a:prstGeom prst="rect">
+            <a:avLst/>
+          </a:prstGeom>
+          <a:noFill/>
+          <a:ln w="12700">
+            <a:solidFill>
+              <a:srgbClr val="D3D8DD"/>
+            </a:solidFill>
+          </a:ln>
+          <a:effectLst/>
+        </p:spPr>
+        <p:style>
+          <a:lnRef idx="1">
+            <a:schemeClr val="accent1"/>
+          </a:lnRef>
+          <a:fillRef idx="3">
+            <a:schemeClr val="accent1"/>
+          </a:fillRef>
+          <a:effectRef idx="2">
+            <a:schemeClr val="accent1"/>
+          </a:effectRef>
+          <a:fontRef idx="minor">
+            <a:schemeClr val="lt1"/>
+          </a:fontRef>
+        </p:style>
+        <p:txBody>
+          <a:bodyPr rtlCol="0" anchor="ctr"/>
+          <a:lstStyle/>
+          <a:p>
+            <a:pPr algn="ctr"/>
+          </a:p>
+        </p:txBody>
+      </p:sp>
+      <p:sp>
+        <p:nvSpPr>
+          <p:cNvPr id="3" name="Rectangle 2"/>
+          <p:cNvSpPr/>
+          <p:nvPr/>
+        </p:nvSpPr>
+        <p:spPr>
+          <a:xfrm>
+            <a:off x="960120" y="658368"/>
+            <a:ext cx="256032" cy="25603"/>
+          </a:xfrm>
+          <a:prstGeom prst="rect">
+            <a:avLst/>
+          </a:prstGeom>
+          <a:solidFill>
+            <a:srgbClr val="B26B12"/>
+          </a:solidFill>
+          <a:ln>
+            <a:noFill/>
+          </a:ln>
+          <a:effectLst/>
+        </p:spPr>
+        <p:style>
+          <a:lnRef idx="1">
+            <a:schemeClr val="accent1"/>
+          </a:lnRef>
+          <a:fillRef idx="3">
+            <a:schemeClr val="accent1"/>
+          </a:fillRef>
+          <a:effectRef idx="2">
+            <a:schemeClr val="accent1"/>
+          </a:effectRef>
+          <a:fontRef idx="minor">
+            <a:schemeClr val="lt1"/>
+          </a:fontRef>
+        </p:style>
+        <p:txBody>
+          <a:bodyPr rtlCol="0" anchor="ctr"/>
+          <a:lstStyle/>
+          <a:p>
+            <a:pPr algn="ctr"/>
+          </a:p>
+        </p:txBody>
+      </p:sp>
+      <p:sp>
+        <p:nvSpPr>
+          <p:cNvPr id="4" name="TextBox 3"/>
+          <p:cNvSpPr txBox="1"/>
+          <p:nvPr/>
+        </p:nvSpPr>
+        <p:spPr>
+          <a:xfrm>
+            <a:off x="1325880" y="548640"/>
+            <a:ext cx="10271455" cy="365760"/>
+          </a:xfrm>
+          <a:prstGeom prst="rect">
+            <a:avLst/>
+          </a:prstGeom>
+          <a:noFill/>
+        </p:spPr>
+        <p:txBody>
+          <a:bodyPr wrap="square" anchor="t" lIns="0" rIns="0" tIns="0" bIns="0">
+            <a:spAutoFit/>
+          </a:bodyPr>
+          <a:lstStyle/>
+          <a:p>
+            <a:pPr algn="l">
+              <a:spcBef>
+                <a:spcPts val="0"/>
+              </a:spcBef>
+              <a:spcAft>
+                <a:spcPts val="400"/>
+              </a:spcAft>
+            </a:pPr>
+            <a:r>
+              <a:rPr sz="1100" b="0">
+                <a:solidFill>
+                  <a:srgbClr val="6C7B88"/>
+                </a:solidFill>
+                <a:latin typeface="DejaVu Sans Mono"/>
+              </a:rPr>
+              <a:t>BEYOND SCHEMA · EXAMPLES</a:t>
+            </a:r>
+          </a:p>
+        </p:txBody>
+      </p:sp>
+      <p:sp>
+        <p:nvSpPr>
+          <p:cNvPr id="5" name="TextBox 4"/>
+          <p:cNvSpPr txBox="1"/>
+          <p:nvPr/>
+        </p:nvSpPr>
+        <p:spPr>
+          <a:xfrm>
+            <a:off x="960120" y="1371600"/>
+            <a:ext cx="10271455" cy="1463040"/>
+          </a:xfrm>
+          <a:prstGeom prst="rect">
+            <a:avLst/>
+          </a:prstGeom>
+          <a:noFill/>
+        </p:spPr>
+        <p:txBody>
+          <a:bodyPr wrap="square">
+            <a:spAutoFit/>
+          </a:bodyPr>
+          <a:lstStyle/>
+          <a:p>
+            <a:pPr>
+              <a:lnSpc>
+                <a:spcPct val="102000"/>
+              </a:lnSpc>
+            </a:pPr>
+            <a:r>
+              <a:rPr sz="3300" b="1">
+                <a:solidFill>
+                  <a:srgbClr val="25313A"/>
+                </a:solidFill>
+                <a:latin typeface="DejaVu Sans"/>
+              </a:rPr>
+              <a:t>Quality gates, declared beside the schema</a:t>
+            </a:r>
+          </a:p>
+        </p:txBody>
+      </p:sp>
+      <p:sp>
+        <p:nvSpPr>
+          <p:cNvPr id="6" name="Rectangle 5"/>
+          <p:cNvSpPr/>
+          <p:nvPr/>
+        </p:nvSpPr>
+        <p:spPr>
+          <a:xfrm>
+            <a:off x="960120" y="2514600"/>
+            <a:ext cx="5943600" cy="2342896"/>
+          </a:xfrm>
+          <a:prstGeom prst="rect">
+            <a:avLst/>
+          </a:prstGeom>
+          <a:solidFill>
+            <a:srgbClr val="EEF1F3"/>
+          </a:solidFill>
+          <a:ln>
+            <a:noFill/>
+          </a:ln>
+          <a:effectLst/>
+        </p:spPr>
+        <p:style>
+          <a:lnRef idx="1">
+            <a:schemeClr val="accent1"/>
+          </a:lnRef>
+          <a:fillRef idx="3">
+            <a:schemeClr val="accent1"/>
+          </a:fillRef>
+          <a:effectRef idx="2">
+            <a:schemeClr val="accent1"/>
+          </a:effectRef>
+          <a:fontRef idx="minor">
+            <a:schemeClr val="lt1"/>
+          </a:fontRef>
+        </p:style>
+        <p:txBody>
+          <a:bodyPr rtlCol="0" anchor="ctr"/>
+          <a:lstStyle/>
+          <a:p>
+            <a:pPr algn="ctr"/>
+          </a:p>
+        </p:txBody>
+      </p:sp>
+      <p:sp>
+        <p:nvSpPr>
+          <p:cNvPr id="7" name="Rectangle 6"/>
+          <p:cNvSpPr/>
+          <p:nvPr/>
+        </p:nvSpPr>
+        <p:spPr>
+          <a:xfrm>
+            <a:off x="960120" y="2514600"/>
+            <a:ext cx="41148" cy="2342896"/>
+          </a:xfrm>
+          <a:prstGeom prst="rect">
+            <a:avLst/>
+          </a:prstGeom>
+          <a:solidFill>
+            <a:srgbClr val="B26B12"/>
+          </a:solidFill>
+          <a:ln>
+            <a:noFill/>
+          </a:ln>
+          <a:effectLst/>
+        </p:spPr>
+        <p:style>
+          <a:lnRef idx="1">
+            <a:schemeClr val="accent1"/>
+          </a:lnRef>
+          <a:fillRef idx="3">
+            <a:schemeClr val="accent1"/>
+          </a:fillRef>
+          <a:effectRef idx="2">
+            <a:schemeClr val="accent1"/>
+          </a:effectRef>
+          <a:fontRef idx="minor">
+            <a:schemeClr val="lt1"/>
+          </a:fontRef>
+        </p:style>
+        <p:txBody>
+          <a:bodyPr rtlCol="0" anchor="ctr"/>
+          <a:lstStyle/>
+          <a:p>
+            <a:pPr algn="ctr"/>
+          </a:p>
+        </p:txBody>
+      </p:sp>
+      <p:sp>
+        <p:nvSpPr>
+          <p:cNvPr id="8" name="TextBox 7"/>
+          <p:cNvSpPr txBox="1"/>
+          <p:nvPr/>
+        </p:nvSpPr>
+        <p:spPr>
+          <a:xfrm>
+            <a:off x="1188720" y="2660904"/>
+            <a:ext cx="5532120" cy="2068576"/>
+          </a:xfrm>
+          <a:prstGeom prst="rect">
+            <a:avLst/>
+          </a:prstGeom>
+          <a:noFill/>
+        </p:spPr>
+        <p:txBody>
+          <a:bodyPr wrap="square">
+            <a:spAutoFit/>
+          </a:bodyPr>
+          <a:lstStyle/>
+          <a:p>
+            <a:pPr>
+              <a:lnSpc>
+                <a:spcPct val="115000"/>
+              </a:lnSpc>
+              <a:spcAft>
+                <a:spcPts val="200"/>
+              </a:spcAft>
+            </a:pPr>
+            <a:r>
+              <a:rPr sz="1100" b="0">
+                <a:solidFill>
+                  <a:srgbClr val="6C7B88"/>
+                </a:solidFill>
+                <a:latin typeface="DejaVu Sans Mono"/>
+              </a:rPr>
+              <a:t>-- in the same sources/definitions file</a:t>
+            </a:r>
+          </a:p>
+          <a:p>
+            <a:pPr>
+              <a:lnSpc>
+                <a:spcPct val="115000"/>
+              </a:lnSpc>
+              <a:spcAft>
+                <a:spcPts val="200"/>
+              </a:spcAft>
+            </a:pPr>
+            <a:r>
+              <a:rPr sz="1100" b="1">
+                <a:solidFill>
+                  <a:srgbClr val="25313A"/>
+                </a:solidFill>
+                <a:latin typeface="DejaVu Sans Mono"/>
+              </a:rPr>
+              <a:t>ATTACH DATA METRIC FUNCTION</a:t>
+            </a:r>
+            <a:r>
+              <a:rPr sz="1100" b="0">
+                <a:solidFill>
+                  <a:srgbClr val="36454F"/>
+                </a:solidFill>
+                <a:latin typeface="DejaVu Sans Mono"/>
+              </a:rPr>
+              <a:t> SNOWFLAKE.CORE.NULL_COUNT</a:t>
+            </a:r>
+          </a:p>
+          <a:p>
+            <a:pPr>
+              <a:lnSpc>
+                <a:spcPct val="115000"/>
+              </a:lnSpc>
+              <a:spcAft>
+                <a:spcPts val="200"/>
+              </a:spcAft>
+            </a:pPr>
+            <a:r>
+              <a:rPr sz="1100" b="1">
+                <a:solidFill>
+                  <a:srgbClr val="25313A"/>
+                </a:solidFill>
+                <a:latin typeface="DejaVu Sans Mono"/>
+              </a:rPr>
+              <a:t>  TO TABLE</a:t>
+            </a:r>
+            <a:r>
+              <a:rPr sz="1100" b="0">
+                <a:solidFill>
+                  <a:srgbClr val="36454F"/>
+                </a:solidFill>
+                <a:latin typeface="DejaVu Sans Mono"/>
+              </a:rPr>
+              <a:t> DEVELOP.PRE.DIM_PBI_CAPACITIES </a:t>
+            </a:r>
+            <a:r>
+              <a:rPr sz="1100" b="1">
+                <a:solidFill>
+                  <a:srgbClr val="25313A"/>
+                </a:solidFill>
+                <a:latin typeface="DejaVu Sans Mono"/>
+              </a:rPr>
+              <a:t>ON</a:t>
+            </a:r>
+            <a:r>
+              <a:rPr sz="1100" b="0">
+                <a:solidFill>
+                  <a:srgbClr val="36454F"/>
+                </a:solidFill>
+                <a:latin typeface="DejaVu Sans Mono"/>
+              </a:rPr>
+              <a:t> (ID)</a:t>
+            </a:r>
+          </a:p>
+          <a:p>
+            <a:pPr>
+              <a:lnSpc>
+                <a:spcPct val="115000"/>
+              </a:lnSpc>
+              <a:spcAft>
+                <a:spcPts val="200"/>
+              </a:spcAft>
+            </a:pPr>
+            <a:r>
+              <a:rPr sz="1100" b="1">
+                <a:solidFill>
+                  <a:srgbClr val="25313A"/>
+                </a:solidFill>
+                <a:latin typeface="DejaVu Sans Mono"/>
+              </a:rPr>
+              <a:t>  EXPECTATION</a:t>
+            </a:r>
+            <a:r>
+              <a:rPr sz="1100" b="0">
+                <a:solidFill>
+                  <a:srgbClr val="36454F"/>
+                </a:solidFill>
+                <a:latin typeface="DejaVu Sans Mono"/>
+              </a:rPr>
+              <a:t> no_null_ids ( </a:t>
+            </a:r>
+            <a:r>
+              <a:rPr sz="1100" b="1">
+                <a:solidFill>
+                  <a:srgbClr val="B26B12"/>
+                </a:solidFill>
+                <a:latin typeface="DejaVu Sans Mono"/>
+              </a:rPr>
+              <a:t>VALUE = 0</a:t>
+            </a:r>
+            <a:r>
+              <a:rPr sz="1100" b="0">
+                <a:solidFill>
+                  <a:srgbClr val="36454F"/>
+                </a:solidFill>
+                <a:latin typeface="DejaVu Sans Mono"/>
+              </a:rPr>
+              <a:t> );</a:t>
+            </a:r>
+          </a:p>
+          <a:p>
+            <a:pPr>
+              <a:lnSpc>
+                <a:spcPct val="115000"/>
+              </a:lnSpc>
+              <a:spcAft>
+                <a:spcPts val="200"/>
+              </a:spcAft>
+            </a:pPr>
+            <a:r>
+              <a:rPr sz="1100" b="0">
+                <a:solidFill>
+                  <a:srgbClr val="36454F"/>
+                </a:solidFill>
+                <a:latin typeface="DejaVu Sans Mono"/>
+              </a:rPr>
+              <a:t/>
+            </a:r>
+          </a:p>
+          <a:p>
+            <a:pPr>
+              <a:lnSpc>
+                <a:spcPct val="115000"/>
+              </a:lnSpc>
+              <a:spcAft>
+                <a:spcPts val="200"/>
+              </a:spcAft>
+            </a:pPr>
+            <a:r>
+              <a:rPr sz="1100" b="1">
+                <a:solidFill>
+                  <a:srgbClr val="25313A"/>
+                </a:solidFill>
+                <a:latin typeface="DejaVu Sans Mono"/>
+              </a:rPr>
+              <a:t>ATTACH DATA METRIC FUNCTION</a:t>
+            </a:r>
+            <a:r>
+              <a:rPr sz="1100" b="0">
+                <a:solidFill>
+                  <a:srgbClr val="36454F"/>
+                </a:solidFill>
+                <a:latin typeface="DejaVu Sans Mono"/>
+              </a:rPr>
+              <a:t> SNOWFLAKE.CORE.DUPLICATE_COUNT</a:t>
+            </a:r>
+          </a:p>
+          <a:p>
+            <a:pPr>
+              <a:lnSpc>
+                <a:spcPct val="115000"/>
+              </a:lnSpc>
+              <a:spcAft>
+                <a:spcPts val="200"/>
+              </a:spcAft>
+            </a:pPr>
+            <a:r>
+              <a:rPr sz="1100" b="1">
+                <a:solidFill>
+                  <a:srgbClr val="25313A"/>
+                </a:solidFill>
+                <a:latin typeface="DejaVu Sans Mono"/>
+              </a:rPr>
+              <a:t>  TO TABLE</a:t>
+            </a:r>
+            <a:r>
+              <a:rPr sz="1100" b="0">
+                <a:solidFill>
+                  <a:srgbClr val="36454F"/>
+                </a:solidFill>
+                <a:latin typeface="DejaVu Sans Mono"/>
+              </a:rPr>
+              <a:t> DEVELOP.PRE.DIM_PBI_CAPACITIES </a:t>
+            </a:r>
+            <a:r>
+              <a:rPr sz="1100" b="1">
+                <a:solidFill>
+                  <a:srgbClr val="25313A"/>
+                </a:solidFill>
+                <a:latin typeface="DejaVu Sans Mono"/>
+              </a:rPr>
+              <a:t>ON</a:t>
+            </a:r>
+            <a:r>
+              <a:rPr sz="1100" b="0">
+                <a:solidFill>
+                  <a:srgbClr val="36454F"/>
+                </a:solidFill>
+                <a:latin typeface="DejaVu Sans Mono"/>
+              </a:rPr>
+              <a:t> (ID)</a:t>
+            </a:r>
+          </a:p>
+          <a:p>
+            <a:pPr>
+              <a:lnSpc>
+                <a:spcPct val="115000"/>
+              </a:lnSpc>
+              <a:spcAft>
+                <a:spcPts val="200"/>
+              </a:spcAft>
+            </a:pPr>
+            <a:r>
+              <a:rPr sz="1100" b="1">
+                <a:solidFill>
+                  <a:srgbClr val="25313A"/>
+                </a:solidFill>
+                <a:latin typeface="DejaVu Sans Mono"/>
+              </a:rPr>
+              <a:t>  EXPECTATION</a:t>
+            </a:r>
+            <a:r>
+              <a:rPr sz="1100" b="0">
+                <a:solidFill>
+                  <a:srgbClr val="36454F"/>
+                </a:solidFill>
+                <a:latin typeface="DejaVu Sans Mono"/>
+              </a:rPr>
+              <a:t> unique_ids ( </a:t>
+            </a:r>
+            <a:r>
+              <a:rPr sz="1100" b="1">
+                <a:solidFill>
+                  <a:srgbClr val="B26B12"/>
+                </a:solidFill>
+                <a:latin typeface="DejaVu Sans Mono"/>
+              </a:rPr>
+              <a:t>VALUE = 0</a:t>
+            </a:r>
+            <a:r>
+              <a:rPr sz="1100" b="0">
+                <a:solidFill>
+                  <a:srgbClr val="36454F"/>
+                </a:solidFill>
+                <a:latin typeface="DejaVu Sans Mono"/>
+              </a:rPr>
+              <a:t> );</a:t>
+            </a:r>
+          </a:p>
+        </p:txBody>
+      </p:sp>
+      <p:sp>
+        <p:nvSpPr>
+          <p:cNvPr id="9" name="TextBox 8"/>
+          <p:cNvSpPr txBox="1"/>
+          <p:nvPr/>
+        </p:nvSpPr>
+        <p:spPr>
+          <a:xfrm>
+            <a:off x="960120" y="4709160"/>
+            <a:ext cx="5943600" cy="640080"/>
+          </a:xfrm>
+          <a:prstGeom prst="rect">
+            <a:avLst/>
+          </a:prstGeom>
+          <a:noFill/>
+        </p:spPr>
+        <p:txBody>
+          <a:bodyPr wrap="square" anchor="t" lIns="0" rIns="0" tIns="0" bIns="0">
+            <a:spAutoFit/>
+          </a:bodyPr>
+          <a:lstStyle/>
+          <a:p>
+            <a:pPr algn="l">
+              <a:lnSpc>
+                <a:spcPct val="135000"/>
+              </a:lnSpc>
+              <a:spcBef>
+                <a:spcPts val="0"/>
+              </a:spcBef>
+              <a:spcAft>
+                <a:spcPts val="400"/>
+              </a:spcAft>
+            </a:pPr>
+            <a:r>
+              <a:rPr sz="1250" b="0">
+                <a:solidFill>
+                  <a:srgbClr val="6C7B88"/>
+                </a:solidFill>
+                <a:latin typeface="DejaVu Sans"/>
+              </a:rPr>
+              <a:t>The left side is always the keyword </a:t>
+            </a:r>
+            <a:r>
+              <a:rPr sz="1100" b="0">
+                <a:solidFill>
+                  <a:srgbClr val="36454F"/>
+                </a:solidFill>
+                <a:latin typeface="DejaVu Sans Mono"/>
+              </a:rPr>
+              <a:t>VALUE</a:t>
+            </a:r>
+            <a:r>
+              <a:rPr sz="1250" b="0">
+                <a:solidFill>
+                  <a:srgbClr val="6C7B88"/>
+                </a:solidFill>
+                <a:latin typeface="DejaVu Sans"/>
+              </a:rPr>
+              <a:t>. No subqueries, casts or arithmetic — a check, not a query.</a:t>
+            </a:r>
+          </a:p>
+        </p:txBody>
+      </p:sp>
+      <p:sp>
+        <p:nvSpPr>
+          <p:cNvPr id="10" name="TextBox 9"/>
+          <p:cNvSpPr txBox="1"/>
+          <p:nvPr/>
+        </p:nvSpPr>
+        <p:spPr>
+          <a:xfrm>
+            <a:off x="7315200" y="2468880"/>
+            <a:ext cx="3916375" cy="274320"/>
+          </a:xfrm>
+          <a:prstGeom prst="rect">
+            <a:avLst/>
+          </a:prstGeom>
+          <a:noFill/>
+        </p:spPr>
+        <p:txBody>
+          <a:bodyPr wrap="square" anchor="t" lIns="0" rIns="0" tIns="0" bIns="0">
+            <a:spAutoFit/>
+          </a:bodyPr>
+          <a:lstStyle/>
+          <a:p>
+            <a:pPr algn="l">
+              <a:spcBef>
+                <a:spcPts val="0"/>
+              </a:spcBef>
+              <a:spcAft>
+                <a:spcPts val="400"/>
+              </a:spcAft>
+            </a:pPr>
+            <a:r>
+              <a:rPr sz="1050" b="1">
+                <a:solidFill>
+                  <a:srgbClr val="9AA8B3"/>
+                </a:solidFill>
+                <a:latin typeface="DejaVu Sans Mono"/>
+              </a:rPr>
+              <a:t>ONE COMMAND RUNS THEM ALL</a:t>
+            </a:r>
+          </a:p>
+        </p:txBody>
+      </p:sp>
+      <p:sp>
+        <p:nvSpPr>
+          <p:cNvPr id="11" name="Rectangle 10"/>
+          <p:cNvSpPr/>
+          <p:nvPr/>
+        </p:nvSpPr>
+        <p:spPr>
+          <a:xfrm>
+            <a:off x="7315200" y="2788920"/>
+            <a:ext cx="3916375" cy="1644396"/>
+          </a:xfrm>
+          <a:prstGeom prst="rect">
+            <a:avLst/>
+          </a:prstGeom>
+          <a:solidFill>
+            <a:srgbClr val="EEF1F3"/>
+          </a:solidFill>
+          <a:ln>
+            <a:noFill/>
+          </a:ln>
+          <a:effectLst/>
+        </p:spPr>
+        <p:style>
+          <a:lnRef idx="1">
+            <a:schemeClr val="accent1"/>
+          </a:lnRef>
+          <a:fillRef idx="3">
+            <a:schemeClr val="accent1"/>
+          </a:fillRef>
+          <a:effectRef idx="2">
+            <a:schemeClr val="accent1"/>
+          </a:effectRef>
+          <a:fontRef idx="minor">
+            <a:schemeClr val="lt1"/>
+          </a:fontRef>
+        </p:style>
+        <p:txBody>
+          <a:bodyPr rtlCol="0" anchor="ctr"/>
+          <a:lstStyle/>
+          <a:p>
+            <a:pPr algn="ctr"/>
+          </a:p>
+        </p:txBody>
+      </p:sp>
+      <p:sp>
+        <p:nvSpPr>
+          <p:cNvPr id="12" name="Rectangle 11"/>
+          <p:cNvSpPr/>
+          <p:nvPr/>
+        </p:nvSpPr>
+        <p:spPr>
+          <a:xfrm>
+            <a:off x="7315200" y="2788920"/>
+            <a:ext cx="41148" cy="1644396"/>
+          </a:xfrm>
+          <a:prstGeom prst="rect">
+            <a:avLst/>
+          </a:prstGeom>
+          <a:solidFill>
+            <a:srgbClr val="B26B12"/>
+          </a:solidFill>
+          <a:ln>
+            <a:noFill/>
+          </a:ln>
+          <a:effectLst/>
+        </p:spPr>
+        <p:style>
+          <a:lnRef idx="1">
+            <a:schemeClr val="accent1"/>
+          </a:lnRef>
+          <a:fillRef idx="3">
+            <a:schemeClr val="accent1"/>
+          </a:fillRef>
+          <a:effectRef idx="2">
+            <a:schemeClr val="accent1"/>
+          </a:effectRef>
+          <a:fontRef idx="minor">
+            <a:schemeClr val="lt1"/>
+          </a:fontRef>
+        </p:style>
+        <p:txBody>
+          <a:bodyPr rtlCol="0" anchor="ctr"/>
+          <a:lstStyle/>
+          <a:p>
+            <a:pPr algn="ctr"/>
+          </a:p>
+        </p:txBody>
+      </p:sp>
+      <p:sp>
+        <p:nvSpPr>
+          <p:cNvPr id="13" name="TextBox 12"/>
+          <p:cNvSpPr txBox="1"/>
+          <p:nvPr/>
+        </p:nvSpPr>
+        <p:spPr>
+          <a:xfrm>
+            <a:off x="7543800" y="2935224"/>
+            <a:ext cx="3504895" cy="1370076"/>
+          </a:xfrm>
+          <a:prstGeom prst="rect">
+            <a:avLst/>
+          </a:prstGeom>
+          <a:noFill/>
+        </p:spPr>
+        <p:txBody>
+          <a:bodyPr wrap="square">
+            <a:spAutoFit/>
+          </a:bodyPr>
+          <a:lstStyle/>
+          <a:p>
+            <a:pPr>
+              <a:lnSpc>
+                <a:spcPct val="115000"/>
+              </a:lnSpc>
+              <a:spcAft>
+                <a:spcPts val="200"/>
+              </a:spcAft>
+            </a:pPr>
+            <a:r>
+              <a:rPr sz="1200" b="0">
+                <a:solidFill>
+                  <a:srgbClr val="36454F"/>
+                </a:solidFill>
+                <a:latin typeface="DejaVu Sans Mono"/>
+              </a:rPr>
+              <a:t>$ snow dcm test PBI_CAPACITIES</a:t>
+            </a:r>
+          </a:p>
+          <a:p>
+            <a:pPr>
+              <a:lnSpc>
+                <a:spcPct val="115000"/>
+              </a:lnSpc>
+              <a:spcAft>
+                <a:spcPts val="200"/>
+              </a:spcAft>
+            </a:pPr>
+            <a:r>
+              <a:rPr sz="1200" b="0">
+                <a:solidFill>
+                  <a:srgbClr val="36454F"/>
+                </a:solidFill>
+                <a:latin typeface="DejaVu Sans Mono"/>
+              </a:rPr>
+              <a:t/>
+            </a:r>
+          </a:p>
+          <a:p>
+            <a:pPr>
+              <a:lnSpc>
+                <a:spcPct val="115000"/>
+              </a:lnSpc>
+              <a:spcAft>
+                <a:spcPts val="200"/>
+              </a:spcAft>
+            </a:pPr>
+            <a:r>
+              <a:rPr sz="1200" b="1">
+                <a:solidFill>
+                  <a:srgbClr val="4B6650"/>
+                </a:solidFill>
+                <a:latin typeface="DejaVu Sans Mono"/>
+              </a:rPr>
+              <a:t>  PASS  no_null_ids</a:t>
+            </a:r>
+          </a:p>
+          <a:p>
+            <a:pPr>
+              <a:lnSpc>
+                <a:spcPct val="115000"/>
+              </a:lnSpc>
+              <a:spcAft>
+                <a:spcPts val="200"/>
+              </a:spcAft>
+            </a:pPr>
+            <a:r>
+              <a:rPr sz="1200" b="1">
+                <a:solidFill>
+                  <a:srgbClr val="4B6650"/>
+                </a:solidFill>
+                <a:latin typeface="DejaVu Sans Mono"/>
+              </a:rPr>
+              <a:t>  PASS  unique_ids</a:t>
+            </a:r>
+          </a:p>
+          <a:p>
+            <a:pPr>
+              <a:lnSpc>
+                <a:spcPct val="115000"/>
+              </a:lnSpc>
+              <a:spcAft>
+                <a:spcPts val="200"/>
+              </a:spcAft>
+            </a:pPr>
+            <a:r>
+              <a:rPr sz="1200" b="1">
+                <a:solidFill>
+                  <a:srgbClr val="B26B12"/>
+                </a:solidFill>
+                <a:latin typeface="DejaVu Sans Mono"/>
+              </a:rPr>
+              <a:t>  FAIL  fact_not_empty</a:t>
+            </a:r>
+          </a:p>
+        </p:txBody>
+      </p:sp>
+      <p:sp>
+        <p:nvSpPr>
+          <p:cNvPr id="14" name="TextBox 13"/>
+          <p:cNvSpPr txBox="1"/>
+          <p:nvPr/>
+        </p:nvSpPr>
+        <p:spPr>
+          <a:xfrm>
+            <a:off x="7315200" y="4617720"/>
+            <a:ext cx="3916375" cy="1188720"/>
+          </a:xfrm>
+          <a:prstGeom prst="rect">
+            <a:avLst/>
+          </a:prstGeom>
+          <a:noFill/>
+        </p:spPr>
+        <p:txBody>
+          <a:bodyPr wrap="square" anchor="t" lIns="0" rIns="0" tIns="0" bIns="0">
+            <a:spAutoFit/>
+          </a:bodyPr>
+          <a:lstStyle/>
+          <a:p>
+            <a:pPr algn="l">
+              <a:lnSpc>
+                <a:spcPct val="140000"/>
+              </a:lnSpc>
+              <a:spcBef>
+                <a:spcPts val="0"/>
+              </a:spcBef>
+              <a:spcAft>
+                <a:spcPts val="400"/>
+              </a:spcAft>
+            </a:pPr>
+            <a:r>
+              <a:rPr sz="1250" b="0">
+                <a:solidFill>
+                  <a:srgbClr val="6C7B88"/>
+                </a:solidFill>
+                <a:latin typeface="DejaVu Sans"/>
+              </a:rPr>
+              <a:t>Runs on </a:t>
+            </a:r>
+            <a:r>
+              <a:rPr sz="1250" b="1">
+                <a:solidFill>
+                  <a:srgbClr val="25313A"/>
+                </a:solidFill>
+                <a:latin typeface="DejaVu Sans"/>
+              </a:rPr>
+              <a:t>deployed</a:t>
+            </a:r>
+            <a:r>
+              <a:rPr sz="1250" b="0">
+                <a:solidFill>
+                  <a:srgbClr val="6C7B88"/>
+                </a:solidFill>
+                <a:latin typeface="DejaVu Sans"/>
+              </a:rPr>
+              <a:t> objects, after refresh. The same gate sits on landing, staging and presentation — bad data caught where it enters, not three dashboards later.</a:t>
+            </a:r>
+          </a:p>
+        </p:txBody>
+      </p:sp>
+      <p:sp>
+        <p:nvSpPr>
+          <p:cNvPr id="15" name="TextBox 14"/>
+          <p:cNvSpPr txBox="1"/>
+          <p:nvPr/>
+        </p:nvSpPr>
+        <p:spPr>
+          <a:xfrm>
+            <a:off x="960120" y="6071616"/>
+            <a:ext cx="4572000" cy="274320"/>
+          </a:xfrm>
+          <a:prstGeom prst="rect">
+            <a:avLst/>
+          </a:prstGeom>
+          <a:noFill/>
+        </p:spPr>
+        <p:txBody>
+          <a:bodyPr wrap="square" anchor="t" lIns="0" rIns="0" tIns="0" bIns="0">
+            <a:spAutoFit/>
+          </a:bodyPr>
+          <a:lstStyle/>
+          <a:p>
+            <a:pPr algn="l">
+              <a:spcBef>
+                <a:spcPts val="0"/>
+              </a:spcBef>
+              <a:spcAft>
+                <a:spcPts val="400"/>
+              </a:spcAft>
+            </a:pPr>
+            <a:r>
+              <a:rPr sz="950" b="0">
+                <a:solidFill>
+                  <a:srgbClr val="9AA8B3"/>
+                </a:solidFill>
+                <a:latin typeface="DejaVu Sans Mono"/>
+              </a:rPr>
+              <a:t>BEYOND SCHEMA</a:t>
+            </a:r>
+          </a:p>
+        </p:txBody>
+      </p:sp>
+      <p:sp>
+        <p:nvSpPr>
+          <p:cNvPr id="16" name="TextBox 15"/>
+          <p:cNvSpPr txBox="1"/>
+          <p:nvPr/>
+        </p:nvSpPr>
+        <p:spPr>
+          <a:xfrm>
+            <a:off x="9037015" y="6071616"/>
+            <a:ext cx="2194560" cy="274320"/>
+          </a:xfrm>
+          <a:prstGeom prst="rect">
+            <a:avLst/>
+          </a:prstGeom>
+          <a:noFill/>
+        </p:spPr>
+        <p:txBody>
+          <a:bodyPr wrap="square" anchor="t" lIns="0" rIns="0" tIns="0" bIns="0">
+            <a:spAutoFit/>
+          </a:bodyPr>
+          <a:lstStyle/>
+          <a:p>
+            <a:pPr algn="r">
+              <a:spcBef>
+                <a:spcPts val="0"/>
+              </a:spcBef>
+              <a:spcAft>
+                <a:spcPts val="400"/>
+              </a:spcAft>
+            </a:pPr>
+            <a:r>
+              <a:rPr sz="950" b="1">
+                <a:solidFill>
+                  <a:srgbClr val="36454F"/>
+                </a:solidFill>
+                <a:latin typeface="DejaVu Sans Mono"/>
+              </a:rPr>
+              <a:t>16</a:t>
+            </a:r>
+            <a:r>
+              <a:rPr sz="950" b="0">
+                <a:solidFill>
+                  <a:srgbClr val="9AA8B3"/>
+                </a:solidFill>
+                <a:latin typeface="DejaVu Sans Mono"/>
+              </a:rPr>
+              <a:t> / 17</a:t>
+            </a:r>
+          </a:p>
+        </p:txBody>
+      </p:sp>
+    </p:spTree>
+  </p:cSld>
+  <p:clrMapOvr>
+    <a:masterClrMapping/>
+  </p:clrMapOvr>
+</p:sld>
+</file>
+
+<file path=ppt/slides/slide17.xml><?xml version="1.0" encoding="utf-8"?>
+<p:sld xmlns:a="http://schemas.openxmlformats.org/drawingml/2006/main" xmlns:p="http://schemas.openxmlformats.org/presentationml/2006/main" xmlns:r="http://schemas.openxmlformats.org/officeDocument/2006/relationships">
+  <p:cSld>
+    <p:bg>
+      <p:bgPr>
+        <a:solidFill>
+          <a:srgbClr val="FBFBFC"/>
+        </a:solidFill>
+        <a:effectLst/>
+      </p:bgPr>
+    </p:bg>
+    <p:spTree>
+      <p:nvGrpSpPr>
+        <p:cNvPr id="1" name=""/>
+        <p:cNvGrpSpPr/>
+        <p:nvPr/>
+      </p:nvGrpSpPr>
+      <p:grpSpPr/>
+      <p:sp>
+        <p:nvSpPr>
+          <p:cNvPr id="2" name="Rectangle 1"/>
+          <p:cNvSpPr/>
+          <p:nvPr/>
+        </p:nvSpPr>
+        <p:spPr>
+          <a:xfrm>
+            <a:off x="384048" y="384048"/>
+            <a:ext cx="11423599" cy="6089904"/>
+          </a:xfrm>
+          <a:prstGeom prst="rect">
+            <a:avLst/>
+          </a:prstGeom>
+          <a:noFill/>
+          <a:ln w="12700">
+            <a:solidFill>
+              <a:srgbClr val="D3D8DD"/>
+            </a:solidFill>
+          </a:ln>
+          <a:effectLst/>
+        </p:spPr>
+        <p:style>
+          <a:lnRef idx="1">
+            <a:schemeClr val="accent1"/>
+          </a:lnRef>
+          <a:fillRef idx="3">
+            <a:schemeClr val="accent1"/>
+          </a:fillRef>
+          <a:effectRef idx="2">
+            <a:schemeClr val="accent1"/>
+          </a:effectRef>
+          <a:fontRef idx="minor">
+            <a:schemeClr val="lt1"/>
+          </a:fontRef>
+        </p:style>
+        <p:txBody>
+          <a:bodyPr rtlCol="0" anchor="ctr"/>
+          <a:lstStyle/>
+          <a:p>
+            <a:pPr algn="ctr"/>
+          </a:p>
+        </p:txBody>
+      </p:sp>
+      <p:sp>
+        <p:nvSpPr>
+          <p:cNvPr id="3" name="Rectangle 2"/>
+          <p:cNvSpPr/>
+          <p:nvPr/>
+        </p:nvSpPr>
+        <p:spPr>
+          <a:xfrm>
+            <a:off x="960120" y="658368"/>
+            <a:ext cx="256032" cy="25603"/>
+          </a:xfrm>
+          <a:prstGeom prst="rect">
+            <a:avLst/>
+          </a:prstGeom>
+          <a:solidFill>
+            <a:srgbClr val="B26B12"/>
+          </a:solidFill>
+          <a:ln>
+            <a:noFill/>
+          </a:ln>
+          <a:effectLst/>
+        </p:spPr>
+        <p:style>
+          <a:lnRef idx="1">
+            <a:schemeClr val="accent1"/>
+          </a:lnRef>
+          <a:fillRef idx="3">
+            <a:schemeClr val="accent1"/>
+          </a:fillRef>
+          <a:effectRef idx="2">
+            <a:schemeClr val="accent1"/>
+          </a:effectRef>
+          <a:fontRef idx="minor">
+            <a:schemeClr val="lt1"/>
+          </a:fontRef>
+        </p:style>
+        <p:txBody>
+          <a:bodyPr rtlCol="0" anchor="ctr"/>
+          <a:lstStyle/>
+          <a:p>
+            <a:pPr algn="ctr"/>
+          </a:p>
+        </p:txBody>
+      </p:sp>
+      <p:sp>
+        <p:nvSpPr>
+          <p:cNvPr id="4" name="TextBox 3"/>
+          <p:cNvSpPr txBox="1"/>
+          <p:nvPr/>
+        </p:nvSpPr>
+        <p:spPr>
+          <a:xfrm>
+            <a:off x="1325880" y="548640"/>
+            <a:ext cx="10271455" cy="365760"/>
+          </a:xfrm>
+          <a:prstGeom prst="rect">
+            <a:avLst/>
+          </a:prstGeom>
+          <a:noFill/>
+        </p:spPr>
+        <p:txBody>
+          <a:bodyPr wrap="square" anchor="t" lIns="0" rIns="0" tIns="0" bIns="0">
+            <a:spAutoFit/>
+          </a:bodyPr>
+          <a:lstStyle/>
+          <a:p>
+            <a:pPr algn="l">
+              <a:spcBef>
+                <a:spcPts val="0"/>
+              </a:spcBef>
+              <a:spcAft>
+                <a:spcPts val="400"/>
+              </a:spcAft>
+            </a:pPr>
+            <a:r>
+              <a:rPr sz="1100" b="0">
+                <a:solidFill>
+                  <a:srgbClr val="6C7B88"/>
+                </a:solidFill>
+                <a:latin typeface="DejaVu Sans Mono"/>
+              </a:rPr>
               <a:t>HONEST LIMITS</a:t>
             </a:r>
           </a:p>
@@ -9959,7 +11944,7 @@
                 </a:solidFill>
                 <a:latin typeface="DejaVu Sans Mono"/>
               </a:rPr>
-              <a:t>15</a:t>
+              <a:t>17</a:t>
             </a:r>
             <a:r>
               <a:rPr sz="950" b="0">
@@ -9968,7 +11953,7 @@
                 </a:solidFill>
                 <a:latin typeface="DejaVu Sans Mono"/>
               </a:rPr>
-              <a:t> / 15</a:t>
+              <a:t> / 17</a:t>
             </a:r>
           </a:p>
         </p:txBody>
@@ -11206,7 +13191,7 @@
                 </a:solidFill>
                 <a:latin typeface="DejaVu Sans Mono"/>
               </a:rPr>
-              <a:t> / 15</a:t>
+              <a:t> / 17</a:t>
             </a:r>
           </a:p>
         </p:txBody>
@@ -12171,7 +14156,7 @@
                 </a:solidFill>
                 <a:latin typeface="DejaVu Sans Mono"/>
               </a:rPr>
-              <a:t> / 15</a:t>
+              <a:t> / 17</a:t>
             </a:r>
           </a:p>
         </p:txBody>
@@ -13290,7 +15275,7 @@
                 </a:solidFill>
                 <a:latin typeface="DejaVu Sans Mono"/>
               </a:rPr>
-              <a:t> / 15</a:t>
+              <a:t> / 17</a:t>
             </a:r>
           </a:p>
         </p:txBody>
@@ -14546,7 +16531,7 @@
                 </a:solidFill>
                 <a:latin typeface="DejaVu Sans Mono"/>
               </a:rPr>
-              <a:t> / 15</a:t>
+              <a:t> / 17</a:t>
             </a:r>
           </a:p>
         </p:txBody>
@@ -15543,7 +17528,7 @@
                 </a:solidFill>
                 <a:latin typeface="DejaVu Sans Mono"/>
               </a:rPr>
-              <a:t> / 15</a:t>
+              <a:t> / 17</a:t>
             </a:r>
           </a:p>
         </p:txBody>
@@ -17062,7 +19047,7 @@
                 </a:solidFill>
                 <a:latin typeface="DejaVu Sans Mono"/>
               </a:rPr>
-              <a:t> / 15</a:t>
+              <a:t> / 17</a:t>
             </a:r>
           </a:p>
         </p:txBody>
@@ -18186,7 +20171,7 @@
                 </a:solidFill>
                 <a:latin typeface="DejaVu Sans Mono"/>
               </a:rPr>
-              <a:t> / 15</a:t>
+              <a:t> / 17</a:t>
             </a:r>
           </a:p>
         </p:txBody>
@@ -19632,7 +21617,7 @@
                 </a:solidFill>
                 <a:latin typeface="DejaVu Sans Mono"/>
               </a:rPr>
-              <a:t> / 15</a:t>
+              <a:t> / 17</a:t>
             </a:r>
           </a:p>
         </p:txBody>

</xml_diff>

<commit_message>
Fix deck slide 7: dev/prod consistency + overflow, add shape-bounds check
Slide 7 (architecture) still showed the old single-Database model while slide 10
showed dev/prod — inconsistent — and in the .pptx the Alert box overflowed the
right frame edge.

Both fixed in both decks:
- Target is now 'PROD database · …_PROD · from git'; deploy arrow labelled
  'DEPLOY · from git'; caption notes dev deploys from the workspace (slide 10)
  and the nightly check watches prod. Consistent with slide 10 and the
  architecture doc §2.
- pptx boxes repositioned inside the frame; monitor row pulled left.

Root cause of the missed overflow: the layout self-check only inspected
textboxes, not autoshapes, so a rectangle crossing the boundary passed. Added a
frame-bounds check for ALL shapes to _validate(); rebuild now CLEAN including
that check.

Co-Authored-By: Claude Opus 4.8 <noreply@anthropic.com>
Claude-Session: https://claude.ai/code/session_01K8zkg1ABYKGv6DLUxPXUSx
</commit_message>
<xml_diff>
--- a/docs/DCM_Presentation.pptx
+++ b/docs/DCM_Presentation.pptx
@@ -18800,7 +18800,7 @@
         <p:spPr>
           <a:xfrm>
             <a:off x="960120" y="2468880"/>
-            <a:ext cx="1828800" cy="868680"/>
+            <a:ext cx="1737360" cy="868680"/>
           </a:xfrm>
           <a:prstGeom prst="rect">
             <a:avLst/>
@@ -18846,7 +18846,7 @@
         <p:spPr>
           <a:xfrm>
             <a:off x="960120" y="2610612"/>
-            <a:ext cx="1828800" cy="868680"/>
+            <a:ext cx="1737360" cy="868680"/>
           </a:xfrm>
           <a:prstGeom prst="rect">
             <a:avLst/>
@@ -18906,8 +18906,8 @@
         </p:nvSpPr>
         <p:spPr>
           <a:xfrm>
-            <a:off x="3611880" y="2468880"/>
-            <a:ext cx="2103120" cy="868680"/>
+            <a:off x="3337560" y="2468880"/>
+            <a:ext cx="1965960" cy="868680"/>
           </a:xfrm>
           <a:prstGeom prst="rect">
             <a:avLst/>
@@ -18952,8 +18952,8 @@
         </p:nvSpPr>
         <p:spPr>
           <a:xfrm>
-            <a:off x="3611880" y="2610612"/>
-            <a:ext cx="2103120" cy="868680"/>
+            <a:off x="3337560" y="2610612"/>
+            <a:ext cx="1965960" cy="868680"/>
           </a:xfrm>
           <a:prstGeom prst="rect">
             <a:avLst/>
@@ -18975,7 +18975,7 @@
               </a:spcAft>
             </a:pPr>
             <a:r>
-              <a:rPr sz="1300" b="1">
+              <a:rPr sz="1250" b="1">
                 <a:solidFill>
                   <a:srgbClr val="25313A"/>
                 </a:solidFill>
@@ -19000,7 +19000,7 @@
                 </a:solidFill>
                 <a:latin typeface="DejaVu Sans Mono"/>
               </a:rPr>
-              <a:t>account-level clone</a:t>
+              <a:t>account clone</a:t>
             </a:r>
           </a:p>
         </p:txBody>
@@ -19013,8 +19013,8 @@
         </p:nvSpPr>
         <p:spPr>
           <a:xfrm>
-            <a:off x="6537959" y="2468880"/>
-            <a:ext cx="1920240" cy="868680"/>
+            <a:off x="5897880" y="2468880"/>
+            <a:ext cx="1828800" cy="868680"/>
           </a:xfrm>
           <a:prstGeom prst="rect">
             <a:avLst/>
@@ -19059,8 +19059,8 @@
         </p:nvSpPr>
         <p:spPr>
           <a:xfrm>
-            <a:off x="6537959" y="2610612"/>
-            <a:ext cx="1920240" cy="868680"/>
+            <a:off x="5897880" y="2610612"/>
+            <a:ext cx="1828800" cy="868680"/>
           </a:xfrm>
           <a:prstGeom prst="rect">
             <a:avLst/>
@@ -19082,7 +19082,7 @@
               </a:spcAft>
             </a:pPr>
             <a:r>
-              <a:rPr sz="1300" b="1">
+              <a:rPr sz="1250" b="1">
                 <a:solidFill>
                   <a:srgbClr val="25313A"/>
                 </a:solidFill>
@@ -19120,8 +19120,8 @@
         </p:nvSpPr>
         <p:spPr>
           <a:xfrm>
-            <a:off x="9281160" y="2468880"/>
-            <a:ext cx="1920240" cy="868680"/>
+            <a:off x="8412480" y="2468880"/>
+            <a:ext cx="2286000" cy="868680"/>
           </a:xfrm>
           <a:prstGeom prst="rect">
             <a:avLst/>
@@ -19166,8 +19166,8 @@
         </p:nvSpPr>
         <p:spPr>
           <a:xfrm>
-            <a:off x="9281160" y="2610612"/>
-            <a:ext cx="1920240" cy="868680"/>
+            <a:off x="8412480" y="2610612"/>
+            <a:ext cx="2286000" cy="868680"/>
           </a:xfrm>
           <a:prstGeom prst="rect">
             <a:avLst/>
@@ -19195,7 +19195,7 @@
                 </a:solidFill>
                 <a:latin typeface="DejaVu Sans Mono"/>
               </a:rPr>
-              <a:t>Database</a:t>
+              <a:t>PROD database</a:t>
             </a:r>
           </a:p>
           <a:p>
@@ -19214,7 +19214,7 @@
                 </a:solidFill>
                 <a:latin typeface="DejaVu Sans Mono"/>
               </a:rPr>
-              <a:t>LND · STG · PRE</a:t>
+              <a:t>…_PROD · from git</a:t>
             </a:r>
           </a:p>
         </p:txBody>
@@ -19227,8 +19227,8 @@
         </p:nvCxnSpPr>
         <p:spPr>
           <a:xfrm>
-            <a:off x="2788920" y="2898648"/>
-            <a:ext cx="804671" cy="0"/>
+            <a:off x="2697480" y="2898648"/>
+            <a:ext cx="621792" cy="0"/>
           </a:xfrm>
           <a:prstGeom prst="bentConnector3">
             <a:avLst/>
@@ -19264,7 +19264,7 @@
         </p:nvSpPr>
         <p:spPr>
           <a:xfrm>
-            <a:off x="2788920" y="2514600"/>
+            <a:off x="2651760" y="2523744"/>
             <a:ext cx="822960" cy="274320"/>
           </a:xfrm>
           <a:prstGeom prst="rect">
@@ -19287,7 +19287,7 @@
               </a:spcAft>
             </a:pPr>
             <a:r>
-              <a:rPr sz="900" b="0">
+              <a:rPr sz="850" b="0">
                 <a:solidFill>
                   <a:srgbClr val="6C7B88"/>
                 </a:solidFill>
@@ -19306,8 +19306,8 @@
         </p:nvCxnSpPr>
         <p:spPr>
           <a:xfrm>
-            <a:off x="5715000" y="2898648"/>
-            <a:ext cx="804672" cy="0"/>
+            <a:off x="5303520" y="2898648"/>
+            <a:ext cx="576072" cy="0"/>
           </a:xfrm>
           <a:prstGeom prst="bentConnector3">
             <a:avLst/>
@@ -19343,8 +19343,8 @@
         </p:nvCxnSpPr>
         <p:spPr>
           <a:xfrm>
-            <a:off x="8458200" y="2743200"/>
-            <a:ext cx="804672" cy="0"/>
+            <a:off x="7726680" y="2761488"/>
+            <a:ext cx="667512" cy="0"/>
           </a:xfrm>
           <a:prstGeom prst="bentConnector3">
             <a:avLst/>
@@ -19380,8 +19380,8 @@
         </p:nvSpPr>
         <p:spPr>
           <a:xfrm>
-            <a:off x="8275320" y="2359152"/>
-            <a:ext cx="1280160" cy="274320"/>
+            <a:off x="7589520" y="2377440"/>
+            <a:ext cx="1371600" cy="274320"/>
           </a:xfrm>
           <a:prstGeom prst="rect">
             <a:avLst/>
@@ -19403,13 +19403,13 @@
               </a:spcAft>
             </a:pPr>
             <a:r>
-              <a:rPr sz="850" b="0">
+              <a:rPr sz="800" b="0">
                 <a:solidFill>
                   <a:srgbClr val="6C7B88"/>
                 </a:solidFill>
                 <a:latin typeface="DejaVu Sans Mono"/>
               </a:rPr>
-              <a:t>DEPLOY · writes</a:t>
+              <a:t>DEPLOY · from git</a:t>
             </a:r>
           </a:p>
         </p:txBody>
@@ -19422,8 +19422,8 @@
         </p:nvCxnSpPr>
         <p:spPr>
           <a:xfrm>
-            <a:off x="8458200" y="3072384"/>
-            <a:ext cx="804672" cy="0"/>
+            <a:off x="7726680" y="3054096"/>
+            <a:ext cx="667512" cy="0"/>
           </a:xfrm>
           <a:prstGeom prst="bentConnector3">
             <a:avLst/>
@@ -19460,7 +19460,7 @@
         </p:nvSpPr>
         <p:spPr>
           <a:xfrm>
-            <a:off x="8001000" y="3154680"/>
+            <a:off x="7406640" y="3127248"/>
             <a:ext cx="1828800" cy="274320"/>
           </a:xfrm>
           <a:prstGeom prst="rect">
@@ -19483,7 +19483,7 @@
               </a:spcAft>
             </a:pPr>
             <a:r>
-              <a:rPr sz="850" b="0">
+              <a:rPr sz="800" b="0">
                 <a:solidFill>
                   <a:srgbClr val="B26B12"/>
                 </a:solidFill>
@@ -19502,8 +19502,8 @@
         </p:nvSpPr>
         <p:spPr>
           <a:xfrm>
-            <a:off x="6537959" y="4297680"/>
-            <a:ext cx="1920240" cy="822960"/>
+            <a:off x="5897880" y="4343400"/>
+            <a:ext cx="1828800" cy="822960"/>
           </a:xfrm>
           <a:prstGeom prst="rect">
             <a:avLst/>
@@ -19548,8 +19548,8 @@
         </p:nvSpPr>
         <p:spPr>
           <a:xfrm>
-            <a:off x="6537959" y="4416552"/>
-            <a:ext cx="1920240" cy="822960"/>
+            <a:off x="5897880" y="4462272"/>
+            <a:ext cx="1828800" cy="822960"/>
           </a:xfrm>
           <a:prstGeom prst="rect">
             <a:avLst/>
@@ -19571,7 +19571,7 @@
               </a:spcAft>
             </a:pPr>
             <a:r>
-              <a:rPr sz="1300" b="1">
+              <a:rPr sz="1250" b="1">
                 <a:solidFill>
                   <a:srgbClr val="8A5210"/>
                 </a:solidFill>
@@ -19609,8 +19609,8 @@
         </p:nvSpPr>
         <p:spPr>
           <a:xfrm>
-            <a:off x="8823960" y="4297680"/>
-            <a:ext cx="1737360" cy="822960"/>
+            <a:off x="8001000" y="4343400"/>
+            <a:ext cx="1554480" cy="822960"/>
           </a:xfrm>
           <a:prstGeom prst="rect">
             <a:avLst/>
@@ -19655,8 +19655,8 @@
         </p:nvSpPr>
         <p:spPr>
           <a:xfrm>
-            <a:off x="8823960" y="4416552"/>
-            <a:ext cx="1737360" cy="822960"/>
+            <a:off x="8001000" y="4462272"/>
+            <a:ext cx="1554480" cy="822960"/>
           </a:xfrm>
           <a:prstGeom prst="rect">
             <a:avLst/>
@@ -19678,7 +19678,7 @@
               </a:spcAft>
             </a:pPr>
             <a:r>
-              <a:rPr sz="1300" b="1">
+              <a:rPr sz="1250" b="1">
                 <a:solidFill>
                   <a:srgbClr val="25313A"/>
                 </a:solidFill>
@@ -19716,8 +19716,8 @@
         </p:nvSpPr>
         <p:spPr>
           <a:xfrm>
-            <a:off x="10927080" y="4297680"/>
-            <a:ext cx="1234440" cy="822960"/>
+            <a:off x="9784080" y="4343400"/>
+            <a:ext cx="1280160" cy="822960"/>
           </a:xfrm>
           <a:prstGeom prst="rect">
             <a:avLst/>
@@ -19762,8 +19762,8 @@
         </p:nvSpPr>
         <p:spPr>
           <a:xfrm>
-            <a:off x="10927080" y="4416552"/>
-            <a:ext cx="1234440" cy="822960"/>
+            <a:off x="9784080" y="4462272"/>
+            <a:ext cx="1280160" cy="822960"/>
           </a:xfrm>
           <a:prstGeom prst="rect">
             <a:avLst/>
@@ -19785,7 +19785,7 @@
               </a:spcAft>
             </a:pPr>
             <a:r>
-              <a:rPr sz="1300" b="1">
+              <a:rPr sz="1250" b="1">
                 <a:solidFill>
                   <a:srgbClr val="FFFFFF"/>
                 </a:solidFill>
@@ -19810,7 +19810,7 @@
                 </a:solidFill>
                 <a:latin typeface="DejaVu Sans Mono"/>
               </a:rPr>
-              <a:t>on drift</a:t>
+              <a:t>if not CLEAN</a:t>
             </a:r>
           </a:p>
         </p:txBody>
@@ -19823,8 +19823,8 @@
         </p:nvCxnSpPr>
         <p:spPr>
           <a:xfrm>
-            <a:off x="7498080" y="3337560"/>
-            <a:ext cx="0" cy="941832"/>
+            <a:off x="6812280" y="3337560"/>
+            <a:ext cx="0" cy="987552"/>
           </a:xfrm>
           <a:prstGeom prst="bentConnector3">
             <a:avLst/>
@@ -19860,8 +19860,8 @@
         </p:nvSpPr>
         <p:spPr>
           <a:xfrm>
-            <a:off x="7635240" y="3611880"/>
-            <a:ext cx="1645920" cy="274320"/>
+            <a:off x="6949440" y="3685032"/>
+            <a:ext cx="1737360" cy="274320"/>
           </a:xfrm>
           <a:prstGeom prst="rect">
             <a:avLst/>
@@ -19883,13 +19883,13 @@
               </a:spcAft>
             </a:pPr>
             <a:r>
-              <a:rPr sz="900" b="0">
+              <a:rPr sz="850" b="0">
                 <a:solidFill>
                   <a:srgbClr val="6C7B88"/>
                 </a:solidFill>
                 <a:latin typeface="DejaVu Sans Mono"/>
               </a:rPr>
-              <a:t>FETCH → PLAN</a:t>
+              <a:t>FETCH → PLAN vs git</a:t>
             </a:r>
           </a:p>
         </p:txBody>
@@ -19902,8 +19902,8 @@
         </p:nvCxnSpPr>
         <p:spPr>
           <a:xfrm>
-            <a:off x="8458200" y="4709160"/>
-            <a:ext cx="347472" cy="0"/>
+            <a:off x="7726680" y="4754880"/>
+            <a:ext cx="256032" cy="0"/>
           </a:xfrm>
           <a:prstGeom prst="bentConnector3">
             <a:avLst/>
@@ -19939,8 +19939,8 @@
         </p:nvCxnSpPr>
         <p:spPr>
           <a:xfrm>
-            <a:off x="10561320" y="4709160"/>
-            <a:ext cx="347472" cy="0"/>
+            <a:off x="9555480" y="4754880"/>
+            <a:ext cx="210312" cy="0"/>
           </a:xfrm>
           <a:prstGeom prst="bentConnector3">
             <a:avLst/>
@@ -19976,8 +19976,8 @@
         </p:nvSpPr>
         <p:spPr>
           <a:xfrm>
-            <a:off x="960120" y="5486400"/>
-            <a:ext cx="10271455" cy="548640"/>
+            <a:off x="960120" y="5440680"/>
+            <a:ext cx="10271455" cy="731520"/>
           </a:xfrm>
           <a:prstGeom prst="rect">
             <a:avLst/>
@@ -19992,7 +19992,7 @@
           <a:p>
             <a:pPr algn="l">
               <a:lnSpc>
-                <a:spcPct val="135000"/>
+                <a:spcPct val="140000"/>
               </a:lnSpc>
               <a:spcBef>
                 <a:spcPts val="0"/>
@@ -20002,22 +20002,31 @@
               </a:spcAft>
             </a:pPr>
             <a:r>
-              <a:rPr sz="1350" b="1">
+              <a:rPr sz="1300" b="0">
+                <a:solidFill>
+                  <a:srgbClr val="6C7B88"/>
+                </a:solidFill>
+                <a:latin typeface="DejaVu Sans"/>
+              </a:rPr>
+              <a:t>Dev deploys from the workspace (next slide); </a:t>
+            </a:r>
+            <a:r>
+              <a:rPr sz="1300" b="1">
                 <a:solidFill>
                   <a:srgbClr val="25313A"/>
                 </a:solidFill>
                 <a:latin typeface="DejaVu Sans"/>
               </a:rPr>
-              <a:t>PLAN is automated; DEPLOY is not.</a:t>
-            </a:r>
-            <a:r>
-              <a:rPr sz="1350" b="0">
+              <a:t>prod is deployed from git</a:t>
+            </a:r>
+            <a:r>
+              <a:rPr sz="1300" b="0">
                 <a:solidFill>
                   <a:srgbClr val="6C7B88"/>
                 </a:solidFill>
                 <a:latin typeface="DejaVu Sans"/>
               </a:rPr>
-              <a:t> The amber path only reads — safe nightly. The solid path writes, and drops columns to do it.</a:t>
+              <a:t>, and the nightly check watches prod. PLAN is automated; DEPLOY is a human decision — it drops columns to revert.</a:t>
             </a:r>
           </a:p>
         </p:txBody>

</xml_diff>

<commit_message>
pptx slide 7: nudge PLAN label clear of PROD box; verified via LibreOffice render
Installed LibreOffice + poppler so the .pptx can be rendered to PDF/image and
actually inspected - closing the gap where I could only geometry-check it. Slide 7
verified visually: no overflow, PROD-from-git target, labels clear.

Co-Authored-By: Claude Opus 4.8 <noreply@anthropic.com>
Claude-Session: https://claude.ai/code/session_01K8zkg1ABYKGv6DLUxPXUSx
</commit_message>
<xml_diff>
--- a/docs/DCM_Presentation.pptx
+++ b/docs/DCM_Presentation.pptx
@@ -19460,8 +19460,8 @@
         </p:nvSpPr>
         <p:spPr>
           <a:xfrm>
-            <a:off x="7406640" y="3127248"/>
-            <a:ext cx="1828800" cy="274320"/>
+            <a:off x="6355080" y="3127248"/>
+            <a:ext cx="1737360" cy="274320"/>
           </a:xfrm>
           <a:prstGeom prst="rect">
             <a:avLst/>

</xml_diff>

<commit_message>
Deck visual sweep via LibreOffice render — fix caption overlaps and a manifest inconsistency
Rendered the .pptx to PDF and inspected every diagram/code slide. Three fixes
that only a visual pass catches:

- Slides 6 and 17: captions were rendering UNDER the code block's grey
  background (text hidden behind a filled box — a class the textbox-overlap
  check can't see). Moved both captions below the boxes.
- Slide 6: manifest showed DEV env_suffix '' while slide 10 shows DEMO_PBI_DEV.
  Set DEV to '_DEV' so the deck is internally consistent with slide 10 and the
  run sheet. (HTML deck too.)

Verified clean after fixes: 6, 7, 9, 10, 11, 12, 17. The honest lesson — automated
geometry checks help but don't replace rendering-and-looking, which is now
possible for both decks (LibreOffice for pptx, headless Chrome for HTML).

Co-Authored-By: Claude Opus 4.8 <noreply@anthropic.com>
Claude-Session: https://claude.ai/code/session_01K8zkg1ABYKGv6DLUxPXUSx
</commit_message>
<xml_diff>
--- a/docs/DCM_Presentation.pptx
+++ b/docs/DCM_Presentation.pptx
@@ -11612,7 +11612,7 @@
         </p:nvSpPr>
         <p:spPr>
           <a:xfrm>
-            <a:off x="960120" y="4709160"/>
+            <a:off x="960120" y="5074920"/>
             <a:ext cx="5943600" cy="640080"/>
           </a:xfrm>
           <a:prstGeom prst="rect">
@@ -18407,7 +18407,25 @@
                 </a:solidFill>
                 <a:latin typeface="DejaVu Sans Mono"/>
               </a:rPr>
-              <a:t>    DEV:  { env_suffix: "" }</a:t>
+              <a:t>    DEV:  { env_suffix: </a:t>
+            </a:r>
+            <a:r>
+              <a:rPr sz="1200" b="1">
+                <a:solidFill>
+                  <a:srgbClr val="B26B12"/>
+                </a:solidFill>
+                <a:latin typeface="DejaVu Sans Mono"/>
+              </a:rPr>
+              <a:t>"_DEV"</a:t>
+            </a:r>
+            <a:r>
+              <a:rPr sz="1200" b="0">
+                <a:solidFill>
+                  <a:srgbClr val="36454F"/>
+                </a:solidFill>
+                <a:latin typeface="DejaVu Sans Mono"/>
+              </a:rPr>
+              <a:t> }</a:t>
             </a:r>
           </a:p>
           <a:p>
@@ -18457,7 +18475,7 @@
         </p:nvSpPr>
         <p:spPr>
           <a:xfrm>
-            <a:off x="6537959" y="5074920"/>
+            <a:off x="6537959" y="5349240"/>
             <a:ext cx="4693615" cy="548640"/>
           </a:xfrm>
           <a:prstGeom prst="rect">

</xml_diff>

<commit_message>
Add Speaker Companion PDF — per-slide presenter script
A presenter companion for the 18-slide deck: one section per slide, with an amber
SAY block (the spoken script, written to be said not recited, with (beat) cues)
and a grey IF ASKED block (numbers, the why, likely follow-ups). Cover explains
the colour code. Built from companion.html, rendered to PDF via headless Chrome;
regenerable.

Co-Authored-By: Claude Opus 4.8 <noreply@anthropic.com>
Claude-Session: https://claude.ai/code/session_01K8zkg1ABYKGv6DLUxPXUSx
</commit_message>
<xml_diff>
--- a/docs/DCM_Presentation.pptx
+++ b/docs/DCM_Presentation.pptx
@@ -5,26 +5,26 @@
     <p:sldMasterId id="2147483648" r:id="rId1"/>
   </p:sldMasterIdLst>
   <p:sldIdLst>
-    <p:sldId id="256" r:id="rId7"/>
-    <p:sldId id="257" r:id="rId8"/>
-    <p:sldId id="258" r:id="rId9"/>
-    <p:sldId id="259" r:id="rId10"/>
-    <p:sldId id="260" r:id="rId11"/>
-    <p:sldId id="261" r:id="rId12"/>
-    <p:sldId id="262" r:id="rId13"/>
-    <p:sldId id="263" r:id="rId14"/>
-    <p:sldId id="264" r:id="rId15"/>
-    <p:sldId id="265" r:id="rId16"/>
-    <p:sldId id="266" r:id="rId17"/>
-    <p:sldId id="267" r:id="rId18"/>
-    <p:sldId id="268" r:id="rId19"/>
-    <p:sldId id="269" r:id="rId20"/>
-    <p:sldId id="270" r:id="rId21"/>
-    <p:sldId id="271" r:id="rId22"/>
-    <p:sldId id="272" r:id="rId23"/>
-    <p:sldId id="273" r:id="rId24"/>
+    <p:sldId id="256" r:id="rId2"/>
+    <p:sldId id="257" r:id="rId3"/>
+    <p:sldId id="258" r:id="rId4"/>
+    <p:sldId id="259" r:id="rId5"/>
+    <p:sldId id="260" r:id="rId6"/>
+    <p:sldId id="261" r:id="rId7"/>
+    <p:sldId id="262" r:id="rId8"/>
+    <p:sldId id="263" r:id="rId9"/>
+    <p:sldId id="264" r:id="rId10"/>
+    <p:sldId id="265" r:id="rId11"/>
+    <p:sldId id="266" r:id="rId12"/>
+    <p:sldId id="267" r:id="rId13"/>
+    <p:sldId id="268" r:id="rId14"/>
+    <p:sldId id="269" r:id="rId15"/>
+    <p:sldId id="270" r:id="rId16"/>
+    <p:sldId id="271" r:id="rId17"/>
+    <p:sldId id="272" r:id="rId18"/>
+    <p:sldId id="273" r:id="rId19"/>
   </p:sldIdLst>
-  <p:sldSz cx="12191695" cy="6858000" type="screen4x3"/>
+  <p:sldSz cx="12192000" cy="6858000"/>
   <p:notesSz cx="6858000" cy="9144000"/>
   <p:defaultTextStyle>
     <a:defPPr>
@@ -121,6 +121,22 @@
       </a:defRPr>
     </a:lvl9pPr>
   </p:defaultTextStyle>
+  <p:extLst>
+    <p:ext uri="{EFAFB233-063F-42B5-8137-9DF3F51BA10A}">
+      <p15:sldGuideLst xmlns:p15="http://schemas.microsoft.com/office/powerpoint/2012/main">
+        <p15:guide id="1" orient="horz" pos="2160">
+          <p15:clr>
+            <a:srgbClr val="A4A3A4"/>
+          </p15:clr>
+        </p15:guide>
+        <p15:guide id="2" pos="2880">
+          <p15:clr>
+            <a:srgbClr val="A4A3A4"/>
+          </p15:clr>
+        </p15:guide>
+      </p15:sldGuideLst>
+    </p:ext>
+  </p:extLst>
 </p:presentation>
 </file>
 
@@ -162,10 +178,9 @@
           <a:lstStyle/>
           <a:p>
             <a:r>
-              <a:rPr lang="en-US" smtClean="0"/>
+              <a:rPr lang="en-US"/>
               <a:t>Click to edit Master title style</a:t>
             </a:r>
-            <a:endParaRPr lang="en-US"/>
           </a:p>
         </p:txBody>
       </p:sp>
@@ -281,10 +296,9 @@
           </a:lstStyle>
           <a:p>
             <a:r>
-              <a:rPr lang="en-US" smtClean="0"/>
+              <a:rPr lang="en-US"/>
               <a:t>Click to edit Master subtitle style</a:t>
             </a:r>
-            <a:endParaRPr lang="en-US"/>
           </a:p>
         </p:txBody>
       </p:sp>
@@ -305,7 +319,7 @@
           <a:p>
             <a:fld id="{5BCAD085-E8A6-8845-BD4E-CB4CCA059FC4}" type="datetimeFigureOut">
               <a:rPr lang="en-US" smtClean="0"/>
-              <a:t>1/27/13</a:t>
+              <a:t>8/26/26</a:t>
             </a:fld>
             <a:endParaRPr lang="en-US"/>
           </a:p>
@@ -399,10 +413,9 @@
           <a:lstStyle/>
           <a:p>
             <a:r>
-              <a:rPr lang="en-US" smtClean="0"/>
+              <a:rPr lang="en-US"/>
               <a:t>Click to edit Master title style</a:t>
             </a:r>
-            <a:endParaRPr lang="en-US"/>
           </a:p>
         </p:txBody>
       </p:sp>
@@ -423,38 +436,37 @@
           <a:p>
             <a:pPr lvl="0"/>
             <a:r>
-              <a:rPr lang="en-US" smtClean="0"/>
+              <a:rPr lang="en-US"/>
               <a:t>Click to edit Master text styles</a:t>
             </a:r>
           </a:p>
           <a:p>
             <a:pPr lvl="1"/>
             <a:r>
-              <a:rPr lang="en-US" smtClean="0"/>
+              <a:rPr lang="en-US"/>
               <a:t>Second level</a:t>
             </a:r>
           </a:p>
           <a:p>
             <a:pPr lvl="2"/>
             <a:r>
-              <a:rPr lang="en-US" smtClean="0"/>
+              <a:rPr lang="en-US"/>
               <a:t>Third level</a:t>
             </a:r>
           </a:p>
           <a:p>
             <a:pPr lvl="3"/>
             <a:r>
-              <a:rPr lang="en-US" smtClean="0"/>
+              <a:rPr lang="en-US"/>
               <a:t>Fourth level</a:t>
             </a:r>
           </a:p>
           <a:p>
             <a:pPr lvl="4"/>
             <a:r>
-              <a:rPr lang="en-US" smtClean="0"/>
+              <a:rPr lang="en-US"/>
               <a:t>Fifth level</a:t>
             </a:r>
-            <a:endParaRPr lang="en-US"/>
           </a:p>
         </p:txBody>
       </p:sp>
@@ -475,7 +487,7 @@
           <a:p>
             <a:fld id="{5BCAD085-E8A6-8845-BD4E-CB4CCA059FC4}" type="datetimeFigureOut">
               <a:rPr lang="en-US" smtClean="0"/>
-              <a:t>1/27/13</a:t>
+              <a:t>8/26/26</a:t>
             </a:fld>
             <a:endParaRPr lang="en-US"/>
           </a:p>
@@ -574,10 +586,9 @@
           <a:lstStyle/>
           <a:p>
             <a:r>
-              <a:rPr lang="en-US" smtClean="0"/>
+              <a:rPr lang="en-US"/>
               <a:t>Click to edit Master title style</a:t>
             </a:r>
-            <a:endParaRPr lang="en-US"/>
           </a:p>
         </p:txBody>
       </p:sp>
@@ -603,38 +614,37 @@
           <a:p>
             <a:pPr lvl="0"/>
             <a:r>
-              <a:rPr lang="en-US" smtClean="0"/>
+              <a:rPr lang="en-US"/>
               <a:t>Click to edit Master text styles</a:t>
             </a:r>
           </a:p>
           <a:p>
             <a:pPr lvl="1"/>
             <a:r>
-              <a:rPr lang="en-US" smtClean="0"/>
+              <a:rPr lang="en-US"/>
               <a:t>Second level</a:t>
             </a:r>
           </a:p>
           <a:p>
             <a:pPr lvl="2"/>
             <a:r>
-              <a:rPr lang="en-US" smtClean="0"/>
+              <a:rPr lang="en-US"/>
               <a:t>Third level</a:t>
             </a:r>
           </a:p>
           <a:p>
             <a:pPr lvl="3"/>
             <a:r>
-              <a:rPr lang="en-US" smtClean="0"/>
+              <a:rPr lang="en-US"/>
               <a:t>Fourth level</a:t>
             </a:r>
           </a:p>
           <a:p>
             <a:pPr lvl="4"/>
             <a:r>
-              <a:rPr lang="en-US" smtClean="0"/>
+              <a:rPr lang="en-US"/>
               <a:t>Fifth level</a:t>
             </a:r>
-            <a:endParaRPr lang="en-US"/>
           </a:p>
         </p:txBody>
       </p:sp>
@@ -655,7 +665,7 @@
           <a:p>
             <a:fld id="{5BCAD085-E8A6-8845-BD4E-CB4CCA059FC4}" type="datetimeFigureOut">
               <a:rPr lang="en-US" smtClean="0"/>
-              <a:t>1/27/13</a:t>
+              <a:t>8/26/26</a:t>
             </a:fld>
             <a:endParaRPr lang="en-US"/>
           </a:p>
@@ -749,10 +759,9 @@
           <a:lstStyle/>
           <a:p>
             <a:r>
-              <a:rPr lang="en-US" smtClean="0"/>
+              <a:rPr lang="en-US"/>
               <a:t>Click to edit Master title style</a:t>
             </a:r>
-            <a:endParaRPr lang="en-US"/>
           </a:p>
         </p:txBody>
       </p:sp>
@@ -773,38 +782,37 @@
           <a:p>
             <a:pPr lvl="0"/>
             <a:r>
-              <a:rPr lang="en-US" smtClean="0"/>
+              <a:rPr lang="en-US"/>
               <a:t>Click to edit Master text styles</a:t>
             </a:r>
           </a:p>
           <a:p>
             <a:pPr lvl="1"/>
             <a:r>
-              <a:rPr lang="en-US" smtClean="0"/>
+              <a:rPr lang="en-US"/>
               <a:t>Second level</a:t>
             </a:r>
           </a:p>
           <a:p>
             <a:pPr lvl="2"/>
             <a:r>
-              <a:rPr lang="en-US" smtClean="0"/>
+              <a:rPr lang="en-US"/>
               <a:t>Third level</a:t>
             </a:r>
           </a:p>
           <a:p>
             <a:pPr lvl="3"/>
             <a:r>
-              <a:rPr lang="en-US" smtClean="0"/>
+              <a:rPr lang="en-US"/>
               <a:t>Fourth level</a:t>
             </a:r>
           </a:p>
           <a:p>
             <a:pPr lvl="4"/>
             <a:r>
-              <a:rPr lang="en-US" smtClean="0"/>
+              <a:rPr lang="en-US"/>
               <a:t>Fifth level</a:t>
             </a:r>
-            <a:endParaRPr lang="en-US"/>
           </a:p>
         </p:txBody>
       </p:sp>
@@ -825,7 +833,7 @@
           <a:p>
             <a:fld id="{5BCAD085-E8A6-8845-BD4E-CB4CCA059FC4}" type="datetimeFigureOut">
               <a:rPr lang="en-US" smtClean="0"/>
-              <a:t>1/27/13</a:t>
+              <a:t>8/26/26</a:t>
             </a:fld>
             <a:endParaRPr lang="en-US"/>
           </a:p>
@@ -928,10 +936,9 @@
           </a:lstStyle>
           <a:p>
             <a:r>
-              <a:rPr lang="en-US" smtClean="0"/>
+              <a:rPr lang="en-US"/>
               <a:t>Click to edit Master title style</a:t>
             </a:r>
-            <a:endParaRPr lang="en-US"/>
           </a:p>
         </p:txBody>
       </p:sp>
@@ -1048,7 +1055,7 @@
           <a:p>
             <a:pPr lvl="0"/>
             <a:r>
-              <a:rPr lang="en-US" smtClean="0"/>
+              <a:rPr lang="en-US"/>
               <a:t>Click to edit Master text styles</a:t>
             </a:r>
           </a:p>
@@ -1071,7 +1078,7 @@
           <a:p>
             <a:fld id="{5BCAD085-E8A6-8845-BD4E-CB4CCA059FC4}" type="datetimeFigureOut">
               <a:rPr lang="en-US" smtClean="0"/>
-              <a:t>1/27/13</a:t>
+              <a:t>8/26/26</a:t>
             </a:fld>
             <a:endParaRPr lang="en-US"/>
           </a:p>
@@ -1165,10 +1172,9 @@
           <a:lstStyle/>
           <a:p>
             <a:r>
-              <a:rPr lang="en-US" smtClean="0"/>
+              <a:rPr lang="en-US"/>
               <a:t>Click to edit Master title style</a:t>
             </a:r>
-            <a:endParaRPr lang="en-US"/>
           </a:p>
         </p:txBody>
       </p:sp>
@@ -1222,38 +1228,37 @@
           <a:p>
             <a:pPr lvl="0"/>
             <a:r>
-              <a:rPr lang="en-US" smtClean="0"/>
+              <a:rPr lang="en-US"/>
               <a:t>Click to edit Master text styles</a:t>
             </a:r>
           </a:p>
           <a:p>
             <a:pPr lvl="1"/>
             <a:r>
-              <a:rPr lang="en-US" smtClean="0"/>
+              <a:rPr lang="en-US"/>
               <a:t>Second level</a:t>
             </a:r>
           </a:p>
           <a:p>
             <a:pPr lvl="2"/>
             <a:r>
-              <a:rPr lang="en-US" smtClean="0"/>
+              <a:rPr lang="en-US"/>
               <a:t>Third level</a:t>
             </a:r>
           </a:p>
           <a:p>
             <a:pPr lvl="3"/>
             <a:r>
-              <a:rPr lang="en-US" smtClean="0"/>
+              <a:rPr lang="en-US"/>
               <a:t>Fourth level</a:t>
             </a:r>
           </a:p>
           <a:p>
             <a:pPr lvl="4"/>
             <a:r>
-              <a:rPr lang="en-US" smtClean="0"/>
+              <a:rPr lang="en-US"/>
               <a:t>Fifth level</a:t>
             </a:r>
-            <a:endParaRPr lang="en-US"/>
           </a:p>
         </p:txBody>
       </p:sp>
@@ -1307,38 +1312,37 @@
           <a:p>
             <a:pPr lvl="0"/>
             <a:r>
-              <a:rPr lang="en-US" smtClean="0"/>
+              <a:rPr lang="en-US"/>
               <a:t>Click to edit Master text styles</a:t>
             </a:r>
           </a:p>
           <a:p>
             <a:pPr lvl="1"/>
             <a:r>
-              <a:rPr lang="en-US" smtClean="0"/>
+              <a:rPr lang="en-US"/>
               <a:t>Second level</a:t>
             </a:r>
           </a:p>
           <a:p>
             <a:pPr lvl="2"/>
             <a:r>
-              <a:rPr lang="en-US" smtClean="0"/>
+              <a:rPr lang="en-US"/>
               <a:t>Third level</a:t>
             </a:r>
           </a:p>
           <a:p>
             <a:pPr lvl="3"/>
             <a:r>
-              <a:rPr lang="en-US" smtClean="0"/>
+              <a:rPr lang="en-US"/>
               <a:t>Fourth level</a:t>
             </a:r>
           </a:p>
           <a:p>
             <a:pPr lvl="4"/>
             <a:r>
-              <a:rPr lang="en-US" smtClean="0"/>
+              <a:rPr lang="en-US"/>
               <a:t>Fifth level</a:t>
             </a:r>
-            <a:endParaRPr lang="en-US"/>
           </a:p>
         </p:txBody>
       </p:sp>
@@ -1359,7 +1363,7 @@
           <a:p>
             <a:fld id="{5BCAD085-E8A6-8845-BD4E-CB4CCA059FC4}" type="datetimeFigureOut">
               <a:rPr lang="en-US" smtClean="0"/>
-              <a:t>1/27/13</a:t>
+              <a:t>8/26/26</a:t>
             </a:fld>
             <a:endParaRPr lang="en-US"/>
           </a:p>
@@ -1457,10 +1461,9 @@
           </a:lstStyle>
           <a:p>
             <a:r>
-              <a:rPr lang="en-US" smtClean="0"/>
+              <a:rPr lang="en-US"/>
               <a:t>Click to edit Master title style</a:t>
             </a:r>
-            <a:endParaRPr lang="en-US"/>
           </a:p>
         </p:txBody>
       </p:sp>
@@ -1523,7 +1526,7 @@
           <a:p>
             <a:pPr lvl="0"/>
             <a:r>
-              <a:rPr lang="en-US" smtClean="0"/>
+              <a:rPr lang="en-US"/>
               <a:t>Click to edit Master text styles</a:t>
             </a:r>
           </a:p>
@@ -1579,38 +1582,37 @@
           <a:p>
             <a:pPr lvl="0"/>
             <a:r>
-              <a:rPr lang="en-US" smtClean="0"/>
+              <a:rPr lang="en-US"/>
               <a:t>Click to edit Master text styles</a:t>
             </a:r>
           </a:p>
           <a:p>
             <a:pPr lvl="1"/>
             <a:r>
-              <a:rPr lang="en-US" smtClean="0"/>
+              <a:rPr lang="en-US"/>
               <a:t>Second level</a:t>
             </a:r>
           </a:p>
           <a:p>
             <a:pPr lvl="2"/>
             <a:r>
-              <a:rPr lang="en-US" smtClean="0"/>
+              <a:rPr lang="en-US"/>
               <a:t>Third level</a:t>
             </a:r>
           </a:p>
           <a:p>
             <a:pPr lvl="3"/>
             <a:r>
-              <a:rPr lang="en-US" smtClean="0"/>
+              <a:rPr lang="en-US"/>
               <a:t>Fourth level</a:t>
             </a:r>
           </a:p>
           <a:p>
             <a:pPr lvl="4"/>
             <a:r>
-              <a:rPr lang="en-US" smtClean="0"/>
+              <a:rPr lang="en-US"/>
               <a:t>Fifth level</a:t>
             </a:r>
-            <a:endParaRPr lang="en-US"/>
           </a:p>
         </p:txBody>
       </p:sp>
@@ -1673,7 +1675,7 @@
           <a:p>
             <a:pPr lvl="0"/>
             <a:r>
-              <a:rPr lang="en-US" smtClean="0"/>
+              <a:rPr lang="en-US"/>
               <a:t>Click to edit Master text styles</a:t>
             </a:r>
           </a:p>
@@ -1729,38 +1731,37 @@
           <a:p>
             <a:pPr lvl="0"/>
             <a:r>
-              <a:rPr lang="en-US" smtClean="0"/>
+              <a:rPr lang="en-US"/>
               <a:t>Click to edit Master text styles</a:t>
             </a:r>
           </a:p>
           <a:p>
             <a:pPr lvl="1"/>
             <a:r>
-              <a:rPr lang="en-US" smtClean="0"/>
+              <a:rPr lang="en-US"/>
               <a:t>Second level</a:t>
             </a:r>
           </a:p>
           <a:p>
             <a:pPr lvl="2"/>
             <a:r>
-              <a:rPr lang="en-US" smtClean="0"/>
+              <a:rPr lang="en-US"/>
               <a:t>Third level</a:t>
             </a:r>
           </a:p>
           <a:p>
             <a:pPr lvl="3"/>
             <a:r>
-              <a:rPr lang="en-US" smtClean="0"/>
+              <a:rPr lang="en-US"/>
               <a:t>Fourth level</a:t>
             </a:r>
           </a:p>
           <a:p>
             <a:pPr lvl="4"/>
             <a:r>
-              <a:rPr lang="en-US" smtClean="0"/>
+              <a:rPr lang="en-US"/>
               <a:t>Fifth level</a:t>
             </a:r>
-            <a:endParaRPr lang="en-US"/>
           </a:p>
         </p:txBody>
       </p:sp>
@@ -1781,7 +1782,7 @@
           <a:p>
             <a:fld id="{5BCAD085-E8A6-8845-BD4E-CB4CCA059FC4}" type="datetimeFigureOut">
               <a:rPr lang="en-US" smtClean="0"/>
-              <a:t>1/27/13</a:t>
+              <a:t>8/26/26</a:t>
             </a:fld>
             <a:endParaRPr lang="en-US"/>
           </a:p>
@@ -1875,10 +1876,9 @@
           <a:lstStyle/>
           <a:p>
             <a:r>
-              <a:rPr lang="en-US" smtClean="0"/>
+              <a:rPr lang="en-US"/>
               <a:t>Click to edit Master title style</a:t>
             </a:r>
-            <a:endParaRPr lang="en-US"/>
           </a:p>
         </p:txBody>
       </p:sp>
@@ -1899,7 +1899,7 @@
           <a:p>
             <a:fld id="{5BCAD085-E8A6-8845-BD4E-CB4CCA059FC4}" type="datetimeFigureOut">
               <a:rPr lang="en-US" smtClean="0"/>
-              <a:t>1/27/13</a:t>
+              <a:t>8/26/26</a:t>
             </a:fld>
             <a:endParaRPr lang="en-US"/>
           </a:p>
@@ -1994,7 +1994,7 @@
           <a:p>
             <a:fld id="{5BCAD085-E8A6-8845-BD4E-CB4CCA059FC4}" type="datetimeFigureOut">
               <a:rPr lang="en-US" smtClean="0"/>
-              <a:t>1/27/13</a:t>
+              <a:t>8/26/26</a:t>
             </a:fld>
             <a:endParaRPr lang="en-US"/>
           </a:p>
@@ -2097,10 +2097,9 @@
           </a:lstStyle>
           <a:p>
             <a:r>
-              <a:rPr lang="en-US" smtClean="0"/>
+              <a:rPr lang="en-US"/>
               <a:t>Click to edit Master title style</a:t>
             </a:r>
-            <a:endParaRPr lang="en-US"/>
           </a:p>
         </p:txBody>
       </p:sp>
@@ -2154,38 +2153,37 @@
           <a:p>
             <a:pPr lvl="0"/>
             <a:r>
-              <a:rPr lang="en-US" smtClean="0"/>
+              <a:rPr lang="en-US"/>
               <a:t>Click to edit Master text styles</a:t>
             </a:r>
           </a:p>
           <a:p>
             <a:pPr lvl="1"/>
             <a:r>
-              <a:rPr lang="en-US" smtClean="0"/>
+              <a:rPr lang="en-US"/>
               <a:t>Second level</a:t>
             </a:r>
           </a:p>
           <a:p>
             <a:pPr lvl="2"/>
             <a:r>
-              <a:rPr lang="en-US" smtClean="0"/>
+              <a:rPr lang="en-US"/>
               <a:t>Third level</a:t>
             </a:r>
           </a:p>
           <a:p>
             <a:pPr lvl="3"/>
             <a:r>
-              <a:rPr lang="en-US" smtClean="0"/>
+              <a:rPr lang="en-US"/>
               <a:t>Fourth level</a:t>
             </a:r>
           </a:p>
           <a:p>
             <a:pPr lvl="4"/>
             <a:r>
-              <a:rPr lang="en-US" smtClean="0"/>
+              <a:rPr lang="en-US"/>
               <a:t>Fifth level</a:t>
             </a:r>
-            <a:endParaRPr lang="en-US"/>
           </a:p>
         </p:txBody>
       </p:sp>
@@ -2248,7 +2246,7 @@
           <a:p>
             <a:pPr lvl="0"/>
             <a:r>
-              <a:rPr lang="en-US" smtClean="0"/>
+              <a:rPr lang="en-US"/>
               <a:t>Click to edit Master text styles</a:t>
             </a:r>
           </a:p>
@@ -2271,7 +2269,7 @@
           <a:p>
             <a:fld id="{5BCAD085-E8A6-8845-BD4E-CB4CCA059FC4}" type="datetimeFigureOut">
               <a:rPr lang="en-US" smtClean="0"/>
-              <a:t>1/27/13</a:t>
+              <a:t>8/26/26</a:t>
             </a:fld>
             <a:endParaRPr lang="en-US"/>
           </a:p>
@@ -2374,10 +2372,9 @@
           </a:lstStyle>
           <a:p>
             <a:r>
-              <a:rPr lang="en-US" smtClean="0"/>
+              <a:rPr lang="en-US"/>
               <a:t>Click to edit Master title style</a:t>
             </a:r>
-            <a:endParaRPr lang="en-US"/>
           </a:p>
         </p:txBody>
       </p:sp>
@@ -2501,7 +2498,7 @@
           <a:p>
             <a:pPr lvl="0"/>
             <a:r>
-              <a:rPr lang="en-US" smtClean="0"/>
+              <a:rPr lang="en-US"/>
               <a:t>Click to edit Master text styles</a:t>
             </a:r>
           </a:p>
@@ -2524,7 +2521,7 @@
           <a:p>
             <a:fld id="{5BCAD085-E8A6-8845-BD4E-CB4CCA059FC4}" type="datetimeFigureOut">
               <a:rPr lang="en-US" smtClean="0"/>
-              <a:t>1/27/13</a:t>
+              <a:t>8/26/26</a:t>
             </a:fld>
             <a:endParaRPr lang="en-US"/>
           </a:p>
@@ -2633,10 +2630,9 @@
           <a:lstStyle/>
           <a:p>
             <a:r>
-              <a:rPr lang="en-US" smtClean="0"/>
+              <a:rPr lang="en-US"/>
               <a:t>Click to edit Master title style</a:t>
             </a:r>
-            <a:endParaRPr lang="en-US"/>
           </a:p>
         </p:txBody>
       </p:sp>
@@ -2667,38 +2663,37 @@
           <a:p>
             <a:pPr lvl="0"/>
             <a:r>
-              <a:rPr lang="en-US" smtClean="0"/>
+              <a:rPr lang="en-US"/>
               <a:t>Click to edit Master text styles</a:t>
             </a:r>
           </a:p>
           <a:p>
             <a:pPr lvl="1"/>
             <a:r>
-              <a:rPr lang="en-US" smtClean="0"/>
+              <a:rPr lang="en-US"/>
               <a:t>Second level</a:t>
             </a:r>
           </a:p>
           <a:p>
             <a:pPr lvl="2"/>
             <a:r>
-              <a:rPr lang="en-US" smtClean="0"/>
+              <a:rPr lang="en-US"/>
               <a:t>Third level</a:t>
             </a:r>
           </a:p>
           <a:p>
             <a:pPr lvl="3"/>
             <a:r>
-              <a:rPr lang="en-US" smtClean="0"/>
+              <a:rPr lang="en-US"/>
               <a:t>Fourth level</a:t>
             </a:r>
           </a:p>
           <a:p>
             <a:pPr lvl="4"/>
             <a:r>
-              <a:rPr lang="en-US" smtClean="0"/>
+              <a:rPr lang="en-US"/>
               <a:t>Fifth level</a:t>
             </a:r>
-            <a:endParaRPr lang="en-US"/>
           </a:p>
         </p:txBody>
       </p:sp>
@@ -2737,7 +2732,7 @@
           <a:p>
             <a:fld id="{5BCAD085-E8A6-8845-BD4E-CB4CCA059FC4}" type="datetimeFigureOut">
               <a:rPr lang="en-US" smtClean="0"/>
-              <a:t>1/27/13</a:t>
+              <a:t>8/26/26</a:t>
             </a:fld>
             <a:endParaRPr lang="en-US"/>
           </a:p>
@@ -3096,7 +3091,7 @@
 </file>
 
 <file path=ppt/slides/slide1.xml><?xml version="1.0" encoding="utf-8"?>
-<p:sld xmlns:a="http://schemas.openxmlformats.org/drawingml/2006/main" xmlns:p="http://schemas.openxmlformats.org/presentationml/2006/main" xmlns:r="http://schemas.openxmlformats.org/officeDocument/2006/relationships">
+<p:sld xmlns:a="http://schemas.openxmlformats.org/drawingml/2006/main" xmlns:r="http://schemas.openxmlformats.org/officeDocument/2006/relationships" xmlns:p="http://schemas.openxmlformats.org/presentationml/2006/main">
   <p:cSld>
     <p:bg>
       <p:bgPr>
@@ -3112,7 +3107,14 @@
         <p:cNvGrpSpPr/>
         <p:nvPr/>
       </p:nvGrpSpPr>
-      <p:grpSpPr/>
+      <p:grpSpPr>
+        <a:xfrm>
+          <a:off x="0" y="0"/>
+          <a:ext cx="0" cy="0"/>
+          <a:chOff x="0" y="0"/>
+          <a:chExt cx="0" cy="0"/>
+        </a:xfrm>
+      </p:grpSpPr>
       <p:sp>
         <p:nvSpPr>
           <p:cNvPr id="2" name="Rectangle 1"/>
@@ -3154,6 +3156,7 @@
           <a:lstStyle/>
           <a:p>
             <a:pPr algn="ctr"/>
+            <a:endParaRPr/>
           </a:p>
         </p:txBody>
       </p:sp>
@@ -3198,6 +3201,7 @@
           <a:lstStyle/>
           <a:p>
             <a:pPr algn="ctr"/>
+            <a:endParaRPr/>
           </a:p>
         </p:txBody>
       </p:sp>
@@ -3218,7 +3222,7 @@
           <a:noFill/>
         </p:spPr>
         <p:txBody>
-          <a:bodyPr wrap="square" anchor="t" lIns="0" rIns="0" tIns="0" bIns="0">
+          <a:bodyPr wrap="square" lIns="0" tIns="0" rIns="0" bIns="0" anchor="t">
             <a:spAutoFit/>
           </a:bodyPr>
           <a:lstStyle/>
@@ -3284,6 +3288,7 @@
           <a:lstStyle/>
           <a:p>
             <a:pPr algn="ctr"/>
+            <a:endParaRPr/>
           </a:p>
         </p:txBody>
       </p:sp>
@@ -3406,6 +3411,7 @@
           <a:lstStyle/>
           <a:p>
             <a:pPr algn="ctr"/>
+            <a:endParaRPr/>
           </a:p>
         </p:txBody>
       </p:sp>
@@ -3426,7 +3432,7 @@
           <a:noFill/>
         </p:spPr>
         <p:txBody>
-          <a:bodyPr wrap="square" anchor="t" lIns="0" rIns="0" tIns="0" bIns="0">
+          <a:bodyPr wrap="square" lIns="0" tIns="0" rIns="0" bIns="0" anchor="t">
             <a:spAutoFit/>
           </a:bodyPr>
           <a:lstStyle/>
@@ -3529,7 +3535,7 @@
           <a:noFill/>
         </p:spPr>
         <p:txBody>
-          <a:bodyPr wrap="square" anchor="t" lIns="0" rIns="0" tIns="0" bIns="0">
+          <a:bodyPr wrap="square" lIns="0" tIns="0" rIns="0" bIns="0" anchor="t">
             <a:spAutoFit/>
           </a:bodyPr>
           <a:lstStyle/>
@@ -3616,7 +3622,7 @@
           <a:noFill/>
         </p:spPr>
         <p:txBody>
-          <a:bodyPr wrap="square" anchor="t" lIns="0" rIns="0" tIns="0" bIns="0">
+          <a:bodyPr wrap="square" lIns="0" tIns="0" rIns="0" bIns="0" anchor="t">
             <a:spAutoFit/>
           </a:bodyPr>
           <a:lstStyle/>
@@ -3658,7 +3664,7 @@
           <a:noFill/>
         </p:spPr>
         <p:txBody>
-          <a:bodyPr wrap="square" anchor="t" lIns="0" rIns="0" tIns="0" bIns="0">
+          <a:bodyPr wrap="square" lIns="0" tIns="0" rIns="0" bIns="0" anchor="t">
             <a:spAutoFit/>
           </a:bodyPr>
           <a:lstStyle/>
@@ -3701,7 +3707,7 @@
 </file>
 
 <file path=ppt/slides/slide10.xml><?xml version="1.0" encoding="utf-8"?>
-<p:sld xmlns:a="http://schemas.openxmlformats.org/drawingml/2006/main" xmlns:p="http://schemas.openxmlformats.org/presentationml/2006/main" xmlns:r="http://schemas.openxmlformats.org/officeDocument/2006/relationships">
+<p:sld xmlns:a="http://schemas.openxmlformats.org/drawingml/2006/main" xmlns:r="http://schemas.openxmlformats.org/officeDocument/2006/relationships" xmlns:p="http://schemas.openxmlformats.org/presentationml/2006/main">
   <p:cSld>
     <p:bg>
       <p:bgPr>
@@ -3717,7 +3723,14 @@
         <p:cNvGrpSpPr/>
         <p:nvPr/>
       </p:nvGrpSpPr>
-      <p:grpSpPr/>
+      <p:grpSpPr>
+        <a:xfrm>
+          <a:off x="0" y="0"/>
+          <a:ext cx="0" cy="0"/>
+          <a:chOff x="0" y="0"/>
+          <a:chExt cx="0" cy="0"/>
+        </a:xfrm>
+      </p:grpSpPr>
       <p:sp>
         <p:nvSpPr>
           <p:cNvPr id="2" name="Rectangle 1"/>
@@ -3759,6 +3772,7 @@
           <a:lstStyle/>
           <a:p>
             <a:pPr algn="ctr"/>
+            <a:endParaRPr/>
           </a:p>
         </p:txBody>
       </p:sp>
@@ -3803,6 +3817,7 @@
           <a:lstStyle/>
           <a:p>
             <a:pPr algn="ctr"/>
+            <a:endParaRPr/>
           </a:p>
         </p:txBody>
       </p:sp>
@@ -3823,7 +3838,7 @@
           <a:noFill/>
         </p:spPr>
         <p:txBody>
-          <a:bodyPr wrap="square" anchor="t" lIns="0" rIns="0" tIns="0" bIns="0">
+          <a:bodyPr wrap="square" lIns="0" tIns="0" rIns="0" bIns="0" anchor="t">
             <a:spAutoFit/>
           </a:bodyPr>
           <a:lstStyle/>
@@ -3939,6 +3954,7 @@
           <a:lstStyle/>
           <a:p>
             <a:pPr algn="ctr"/>
+            <a:endParaRPr/>
           </a:p>
         </p:txBody>
       </p:sp>
@@ -3959,7 +3975,7 @@
           <a:noFill/>
         </p:spPr>
         <p:txBody>
-          <a:bodyPr wrap="square" anchor="t" lIns="0" rIns="0" tIns="0" bIns="0">
+          <a:bodyPr wrap="square" lIns="0" tIns="0" rIns="0" bIns="0" anchor="t">
             <a:spAutoFit/>
           </a:bodyPr>
           <a:lstStyle/>
@@ -4046,6 +4062,7 @@
           <a:lstStyle/>
           <a:p>
             <a:pPr algn="ctr"/>
+            <a:endParaRPr/>
           </a:p>
         </p:txBody>
       </p:sp>
@@ -4066,7 +4083,7 @@
           <a:noFill/>
         </p:spPr>
         <p:txBody>
-          <a:bodyPr wrap="square" anchor="t" lIns="0" rIns="0" tIns="0" bIns="0">
+          <a:bodyPr wrap="square" lIns="0" tIns="0" rIns="0" bIns="0" anchor="t">
             <a:spAutoFit/>
           </a:bodyPr>
           <a:lstStyle/>
@@ -4153,6 +4170,7 @@
           <a:lstStyle/>
           <a:p>
             <a:pPr algn="ctr"/>
+            <a:endParaRPr/>
           </a:p>
         </p:txBody>
       </p:sp>
@@ -4173,7 +4191,7 @@
           <a:noFill/>
         </p:spPr>
         <p:txBody>
-          <a:bodyPr wrap="square" anchor="t" lIns="0" rIns="0" tIns="0" bIns="0">
+          <a:bodyPr wrap="square" lIns="0" tIns="0" rIns="0" bIns="0" anchor="t">
             <a:spAutoFit/>
           </a:bodyPr>
           <a:lstStyle/>
@@ -4260,6 +4278,7 @@
           <a:lstStyle/>
           <a:p>
             <a:pPr algn="ctr"/>
+            <a:endParaRPr/>
           </a:p>
         </p:txBody>
       </p:sp>
@@ -4280,7 +4299,7 @@
           <a:noFill/>
         </p:spPr>
         <p:txBody>
-          <a:bodyPr wrap="square" anchor="t" lIns="0" rIns="0" tIns="0" bIns="0">
+          <a:bodyPr wrap="square" lIns="0" tIns="0" rIns="0" bIns="0" anchor="t">
             <a:spAutoFit/>
           </a:bodyPr>
           <a:lstStyle/>
@@ -4378,7 +4397,7 @@
           <a:noFill/>
         </p:spPr>
         <p:txBody>
-          <a:bodyPr wrap="square" anchor="t" lIns="0" rIns="0" tIns="0" bIns="0">
+          <a:bodyPr wrap="square" lIns="0" tIns="0" rIns="0" bIns="0" anchor="t">
             <a:spAutoFit/>
           </a:bodyPr>
           <a:lstStyle/>
@@ -4457,7 +4476,7 @@
           <a:noFill/>
         </p:spPr>
         <p:txBody>
-          <a:bodyPr wrap="square" anchor="t" lIns="0" rIns="0" tIns="0" bIns="0">
+          <a:bodyPr wrap="square" lIns="0" tIns="0" rIns="0" bIns="0" anchor="t">
             <a:spAutoFit/>
           </a:bodyPr>
           <a:lstStyle/>
@@ -4536,7 +4555,7 @@
           <a:noFill/>
         </p:spPr>
         <p:txBody>
-          <a:bodyPr wrap="square" anchor="t" lIns="0" rIns="0" tIns="0" bIns="0">
+          <a:bodyPr wrap="square" lIns="0" tIns="0" rIns="0" bIns="0" anchor="t">
             <a:spAutoFit/>
           </a:bodyPr>
           <a:lstStyle/>
@@ -4578,7 +4597,7 @@
           <a:noFill/>
         </p:spPr>
         <p:txBody>
-          <a:bodyPr wrap="square" anchor="t" lIns="0" rIns="0" tIns="0" bIns="0">
+          <a:bodyPr wrap="square" lIns="0" tIns="0" rIns="0" bIns="0" anchor="t">
             <a:spAutoFit/>
           </a:bodyPr>
           <a:lstStyle/>
@@ -4659,7 +4678,7 @@
           <a:noFill/>
         </p:spPr>
         <p:txBody>
-          <a:bodyPr wrap="square" anchor="t" lIns="0" rIns="0" tIns="0" bIns="0">
+          <a:bodyPr wrap="square" lIns="0" tIns="0" rIns="0" bIns="0" anchor="t">
             <a:spAutoFit/>
           </a:bodyPr>
           <a:lstStyle/>
@@ -4701,7 +4720,7 @@
           <a:noFill/>
         </p:spPr>
         <p:txBody>
-          <a:bodyPr wrap="square" anchor="t" lIns="0" rIns="0" tIns="0" bIns="0">
+          <a:bodyPr wrap="square" lIns="0" tIns="0" rIns="0" bIns="0" anchor="t">
             <a:spAutoFit/>
           </a:bodyPr>
           <a:lstStyle/>
@@ -4744,7 +4763,7 @@
 </file>
 
 <file path=ppt/slides/slide11.xml><?xml version="1.0" encoding="utf-8"?>
-<p:sld xmlns:a="http://schemas.openxmlformats.org/drawingml/2006/main" xmlns:p="http://schemas.openxmlformats.org/presentationml/2006/main" xmlns:r="http://schemas.openxmlformats.org/officeDocument/2006/relationships">
+<p:sld xmlns:a="http://schemas.openxmlformats.org/drawingml/2006/main" xmlns:r="http://schemas.openxmlformats.org/officeDocument/2006/relationships" xmlns:p="http://schemas.openxmlformats.org/presentationml/2006/main">
   <p:cSld>
     <p:bg>
       <p:bgPr>
@@ -4760,7 +4779,14 @@
         <p:cNvGrpSpPr/>
         <p:nvPr/>
       </p:nvGrpSpPr>
-      <p:grpSpPr/>
+      <p:grpSpPr>
+        <a:xfrm>
+          <a:off x="0" y="0"/>
+          <a:ext cx="0" cy="0"/>
+          <a:chOff x="0" y="0"/>
+          <a:chExt cx="0" cy="0"/>
+        </a:xfrm>
+      </p:grpSpPr>
       <p:sp>
         <p:nvSpPr>
           <p:cNvPr id="2" name="Rectangle 1"/>
@@ -4802,6 +4828,7 @@
           <a:lstStyle/>
           <a:p>
             <a:pPr algn="ctr"/>
+            <a:endParaRPr/>
           </a:p>
         </p:txBody>
       </p:sp>
@@ -4846,6 +4873,7 @@
           <a:lstStyle/>
           <a:p>
             <a:pPr algn="ctr"/>
+            <a:endParaRPr/>
           </a:p>
         </p:txBody>
       </p:sp>
@@ -4866,7 +4894,7 @@
           <a:noFill/>
         </p:spPr>
         <p:txBody>
-          <a:bodyPr wrap="square" anchor="t" lIns="0" rIns="0" tIns="0" bIns="0">
+          <a:bodyPr wrap="square" lIns="0" tIns="0" rIns="0" bIns="0" anchor="t">
             <a:spAutoFit/>
           </a:bodyPr>
           <a:lstStyle/>
@@ -4973,6 +5001,7 @@
           <a:lstStyle/>
           <a:p>
             <a:pPr algn="ctr"/>
+            <a:endParaRPr/>
           </a:p>
         </p:txBody>
       </p:sp>
@@ -4993,7 +5022,7 @@
           <a:noFill/>
         </p:spPr>
         <p:txBody>
-          <a:bodyPr wrap="square" anchor="t" lIns="0" rIns="0" tIns="0" bIns="0">
+          <a:bodyPr wrap="square" lIns="0" tIns="0" rIns="0" bIns="0" anchor="t">
             <a:spAutoFit/>
           </a:bodyPr>
           <a:lstStyle/>
@@ -5035,7 +5064,7 @@
           <a:noFill/>
         </p:spPr>
         <p:txBody>
-          <a:bodyPr wrap="square" anchor="ctr" lIns="0" rIns="0" tIns="0" bIns="0">
+          <a:bodyPr wrap="square" lIns="0" tIns="0" rIns="0" bIns="0" anchor="ctr">
             <a:spAutoFit/>
           </a:bodyPr>
           <a:lstStyle/>
@@ -5101,6 +5130,7 @@
           <a:lstStyle/>
           <a:p>
             <a:pPr algn="ctr"/>
+            <a:endParaRPr/>
           </a:p>
         </p:txBody>
       </p:sp>
@@ -5121,7 +5151,7 @@
           <a:noFill/>
         </p:spPr>
         <p:txBody>
-          <a:bodyPr wrap="square" anchor="t" lIns="0" rIns="0" tIns="0" bIns="0">
+          <a:bodyPr wrap="square" lIns="0" tIns="0" rIns="0" bIns="0" anchor="t">
             <a:spAutoFit/>
           </a:bodyPr>
           <a:lstStyle/>
@@ -5189,6 +5219,7 @@
           <a:lstStyle/>
           <a:p>
             <a:pPr algn="ctr"/>
+            <a:endParaRPr/>
           </a:p>
         </p:txBody>
       </p:sp>
@@ -5209,7 +5240,7 @@
           <a:noFill/>
         </p:spPr>
         <p:txBody>
-          <a:bodyPr wrap="square" anchor="t" lIns="0" rIns="0" tIns="0" bIns="0">
+          <a:bodyPr wrap="square" lIns="0" tIns="0" rIns="0" bIns="0" anchor="t">
             <a:spAutoFit/>
           </a:bodyPr>
           <a:lstStyle/>
@@ -5251,7 +5282,7 @@
           <a:noFill/>
         </p:spPr>
         <p:txBody>
-          <a:bodyPr wrap="square" anchor="ctr" lIns="0" rIns="0" tIns="0" bIns="0">
+          <a:bodyPr wrap="square" lIns="0" tIns="0" rIns="0" bIns="0" anchor="ctr">
             <a:spAutoFit/>
           </a:bodyPr>
           <a:lstStyle/>
@@ -5317,6 +5348,7 @@
           <a:lstStyle/>
           <a:p>
             <a:pPr algn="ctr"/>
+            <a:endParaRPr/>
           </a:p>
         </p:txBody>
       </p:sp>
@@ -5337,7 +5369,7 @@
           <a:noFill/>
         </p:spPr>
         <p:txBody>
-          <a:bodyPr wrap="square" anchor="t" lIns="0" rIns="0" tIns="0" bIns="0">
+          <a:bodyPr wrap="square" lIns="0" tIns="0" rIns="0" bIns="0" anchor="t">
             <a:spAutoFit/>
           </a:bodyPr>
           <a:lstStyle/>
@@ -5405,6 +5437,7 @@
           <a:lstStyle/>
           <a:p>
             <a:pPr algn="ctr"/>
+            <a:endParaRPr/>
           </a:p>
         </p:txBody>
       </p:sp>
@@ -5449,6 +5482,7 @@
           <a:lstStyle/>
           <a:p>
             <a:pPr algn="ctr"/>
+            <a:endParaRPr/>
           </a:p>
         </p:txBody>
       </p:sp>
@@ -5469,7 +5503,7 @@
           <a:noFill/>
         </p:spPr>
         <p:txBody>
-          <a:bodyPr wrap="square" anchor="t" lIns="0" rIns="0" tIns="0" bIns="0">
+          <a:bodyPr wrap="square" lIns="0" tIns="0" rIns="0" bIns="0" anchor="t">
             <a:spAutoFit/>
           </a:bodyPr>
           <a:lstStyle/>
@@ -5511,7 +5545,7 @@
           <a:noFill/>
         </p:spPr>
         <p:txBody>
-          <a:bodyPr wrap="square" anchor="ctr" lIns="0" rIns="0" tIns="0" bIns="0">
+          <a:bodyPr wrap="square" lIns="0" tIns="0" rIns="0" bIns="0" anchor="ctr">
             <a:spAutoFit/>
           </a:bodyPr>
           <a:lstStyle/>
@@ -5577,6 +5611,7 @@
           <a:lstStyle/>
           <a:p>
             <a:pPr algn="ctr"/>
+            <a:endParaRPr/>
           </a:p>
         </p:txBody>
       </p:sp>
@@ -5597,7 +5632,7 @@
           <a:noFill/>
         </p:spPr>
         <p:txBody>
-          <a:bodyPr wrap="square" anchor="t" lIns="0" rIns="0" tIns="0" bIns="0">
+          <a:bodyPr wrap="square" lIns="0" tIns="0" rIns="0" bIns="0" anchor="t">
             <a:spAutoFit/>
           </a:bodyPr>
           <a:lstStyle/>
@@ -5639,7 +5674,7 @@
           <a:noFill/>
         </p:spPr>
         <p:txBody>
-          <a:bodyPr wrap="square" anchor="t" lIns="0" rIns="0" tIns="0" bIns="0">
+          <a:bodyPr wrap="square" lIns="0" tIns="0" rIns="0" bIns="0" anchor="t">
             <a:spAutoFit/>
           </a:bodyPr>
           <a:lstStyle/>
@@ -5690,7 +5725,7 @@
           <a:noFill/>
         </p:spPr>
         <p:txBody>
-          <a:bodyPr wrap="square" anchor="t" lIns="0" rIns="0" tIns="0" bIns="0">
+          <a:bodyPr wrap="square" lIns="0" tIns="0" rIns="0" bIns="0" anchor="t">
             <a:spAutoFit/>
           </a:bodyPr>
           <a:lstStyle/>
@@ -5732,7 +5767,7 @@
           <a:noFill/>
         </p:spPr>
         <p:txBody>
-          <a:bodyPr wrap="square" anchor="t" lIns="0" rIns="0" tIns="0" bIns="0">
+          <a:bodyPr wrap="square" lIns="0" tIns="0" rIns="0" bIns="0" anchor="t">
             <a:spAutoFit/>
           </a:bodyPr>
           <a:lstStyle/>
@@ -5775,7 +5810,7 @@
 </file>
 
 <file path=ppt/slides/slide12.xml><?xml version="1.0" encoding="utf-8"?>
-<p:sld xmlns:a="http://schemas.openxmlformats.org/drawingml/2006/main" xmlns:p="http://schemas.openxmlformats.org/presentationml/2006/main" xmlns:r="http://schemas.openxmlformats.org/officeDocument/2006/relationships">
+<p:sld xmlns:a="http://schemas.openxmlformats.org/drawingml/2006/main" xmlns:r="http://schemas.openxmlformats.org/officeDocument/2006/relationships" xmlns:p="http://schemas.openxmlformats.org/presentationml/2006/main">
   <p:cSld>
     <p:bg>
       <p:bgPr>
@@ -5791,7 +5826,14 @@
         <p:cNvGrpSpPr/>
         <p:nvPr/>
       </p:nvGrpSpPr>
-      <p:grpSpPr/>
+      <p:grpSpPr>
+        <a:xfrm>
+          <a:off x="0" y="0"/>
+          <a:ext cx="0" cy="0"/>
+          <a:chOff x="0" y="0"/>
+          <a:chExt cx="0" cy="0"/>
+        </a:xfrm>
+      </p:grpSpPr>
       <p:sp>
         <p:nvSpPr>
           <p:cNvPr id="2" name="Rectangle 1"/>
@@ -5833,6 +5875,7 @@
           <a:lstStyle/>
           <a:p>
             <a:pPr algn="ctr"/>
+            <a:endParaRPr/>
           </a:p>
         </p:txBody>
       </p:sp>
@@ -5877,6 +5920,7 @@
           <a:lstStyle/>
           <a:p>
             <a:pPr algn="ctr"/>
+            <a:endParaRPr/>
           </a:p>
         </p:txBody>
       </p:sp>
@@ -5897,7 +5941,7 @@
           <a:noFill/>
         </p:spPr>
         <p:txBody>
-          <a:bodyPr wrap="square" anchor="t" lIns="0" rIns="0" tIns="0" bIns="0">
+          <a:bodyPr wrap="square" lIns="0" tIns="0" rIns="0" bIns="0" anchor="t">
             <a:spAutoFit/>
           </a:bodyPr>
           <a:lstStyle/>
@@ -5965,6 +6009,7 @@
           <a:lstStyle/>
           <a:p>
             <a:pPr algn="ctr"/>
+            <a:endParaRPr/>
           </a:p>
         </p:txBody>
       </p:sp>
@@ -5985,7 +6030,7 @@
           <a:noFill/>
         </p:spPr>
         <p:txBody>
-          <a:bodyPr wrap="square" anchor="t" lIns="0" rIns="0" tIns="0" bIns="0">
+          <a:bodyPr wrap="square" lIns="0" tIns="0" rIns="0" bIns="0" anchor="t">
             <a:spAutoFit/>
           </a:bodyPr>
           <a:lstStyle/>
@@ -6053,6 +6098,7 @@
           <a:lstStyle/>
           <a:p>
             <a:pPr algn="ctr"/>
+            <a:endParaRPr/>
           </a:p>
         </p:txBody>
       </p:sp>
@@ -6073,7 +6119,7 @@
           <a:noFill/>
         </p:spPr>
         <p:txBody>
-          <a:bodyPr wrap="square" anchor="t" lIns="0" rIns="0" tIns="0" bIns="0">
+          <a:bodyPr wrap="square" lIns="0" tIns="0" rIns="0" bIns="0" anchor="t">
             <a:spAutoFit/>
           </a:bodyPr>
           <a:lstStyle/>
@@ -6160,6 +6206,7 @@
           <a:lstStyle/>
           <a:p>
             <a:pPr algn="ctr"/>
+            <a:endParaRPr/>
           </a:p>
         </p:txBody>
       </p:sp>
@@ -6180,7 +6227,7 @@
           <a:noFill/>
         </p:spPr>
         <p:txBody>
-          <a:bodyPr wrap="square" anchor="t" lIns="0" rIns="0" tIns="0" bIns="0">
+          <a:bodyPr wrap="square" lIns="0" tIns="0" rIns="0" bIns="0" anchor="t">
             <a:spAutoFit/>
           </a:bodyPr>
           <a:lstStyle/>
@@ -6248,6 +6295,7 @@
           <a:lstStyle/>
           <a:p>
             <a:pPr algn="ctr"/>
+            <a:endParaRPr/>
           </a:p>
         </p:txBody>
       </p:sp>
@@ -6268,7 +6316,7 @@
           <a:noFill/>
         </p:spPr>
         <p:txBody>
-          <a:bodyPr wrap="square" anchor="t" lIns="0" rIns="0" tIns="0" bIns="0">
+          <a:bodyPr wrap="square" lIns="0" tIns="0" rIns="0" bIns="0" anchor="t">
             <a:spAutoFit/>
           </a:bodyPr>
           <a:lstStyle/>
@@ -6355,6 +6403,7 @@
           <a:lstStyle/>
           <a:p>
             <a:pPr algn="ctr"/>
+            <a:endParaRPr/>
           </a:p>
         </p:txBody>
       </p:sp>
@@ -6375,7 +6424,7 @@
           <a:noFill/>
         </p:spPr>
         <p:txBody>
-          <a:bodyPr wrap="square" anchor="t" lIns="0" rIns="0" tIns="0" bIns="0">
+          <a:bodyPr wrap="square" lIns="0" tIns="0" rIns="0" bIns="0" anchor="t">
             <a:spAutoFit/>
           </a:bodyPr>
           <a:lstStyle/>
@@ -6473,7 +6522,7 @@
           <a:noFill/>
         </p:spPr>
         <p:txBody>
-          <a:bodyPr wrap="square" anchor="t" lIns="0" rIns="0" tIns="0" bIns="0">
+          <a:bodyPr wrap="square" lIns="0" tIns="0" rIns="0" bIns="0" anchor="t">
             <a:spAutoFit/>
           </a:bodyPr>
           <a:lstStyle/>
@@ -6552,7 +6601,7 @@
           <a:noFill/>
         </p:spPr>
         <p:txBody>
-          <a:bodyPr wrap="square" anchor="t" lIns="0" rIns="0" tIns="0" bIns="0">
+          <a:bodyPr wrap="square" lIns="0" tIns="0" rIns="0" bIns="0" anchor="t">
             <a:spAutoFit/>
           </a:bodyPr>
           <a:lstStyle/>
@@ -6631,7 +6680,7 @@
           <a:noFill/>
         </p:spPr>
         <p:txBody>
-          <a:bodyPr wrap="square" anchor="t" lIns="0" rIns="0" tIns="0" bIns="0">
+          <a:bodyPr wrap="square" lIns="0" tIns="0" rIns="0" bIns="0" anchor="t">
             <a:spAutoFit/>
           </a:bodyPr>
           <a:lstStyle/>
@@ -6710,7 +6759,7 @@
           <a:noFill/>
         </p:spPr>
         <p:txBody>
-          <a:bodyPr wrap="square" anchor="t" lIns="0" rIns="0" tIns="0" bIns="0">
+          <a:bodyPr wrap="square" lIns="0" tIns="0" rIns="0" bIns="0" anchor="t">
             <a:spAutoFit/>
           </a:bodyPr>
           <a:lstStyle/>
@@ -6830,7 +6879,7 @@
           <a:noFill/>
         </p:spPr>
         <p:txBody>
-          <a:bodyPr wrap="square" anchor="t" lIns="0" rIns="0" tIns="0" bIns="0">
+          <a:bodyPr wrap="square" lIns="0" tIns="0" rIns="0" bIns="0" anchor="t">
             <a:spAutoFit/>
           </a:bodyPr>
           <a:lstStyle/>
@@ -6901,6 +6950,7 @@
           <a:lstStyle/>
           <a:p>
             <a:pPr algn="ctr"/>
+            <a:endParaRPr/>
           </a:p>
         </p:txBody>
       </p:sp>
@@ -6945,6 +6995,7 @@
           <a:lstStyle/>
           <a:p>
             <a:pPr algn="ctr"/>
+            <a:endParaRPr/>
           </a:p>
         </p:txBody>
       </p:sp>
@@ -6965,7 +7016,7 @@
           <a:noFill/>
         </p:spPr>
         <p:txBody>
-          <a:bodyPr wrap="square" anchor="t" lIns="0" rIns="0" tIns="0" bIns="0">
+          <a:bodyPr wrap="square" lIns="0" tIns="0" rIns="0" bIns="0" anchor="t">
             <a:spAutoFit/>
           </a:bodyPr>
           <a:lstStyle/>
@@ -7007,7 +7058,7 @@
           <a:noFill/>
         </p:spPr>
         <p:txBody>
-          <a:bodyPr wrap="square" anchor="t" lIns="0" rIns="0" tIns="0" bIns="0">
+          <a:bodyPr wrap="square" lIns="0" tIns="0" rIns="0" bIns="0" anchor="t">
             <a:spAutoFit/>
           </a:bodyPr>
           <a:lstStyle/>
@@ -7083,7 +7134,7 @@
           <a:noFill/>
         </p:spPr>
         <p:txBody>
-          <a:bodyPr wrap="square" anchor="t" lIns="0" rIns="0" tIns="0" bIns="0">
+          <a:bodyPr wrap="square" lIns="0" tIns="0" rIns="0" bIns="0" anchor="t">
             <a:spAutoFit/>
           </a:bodyPr>
           <a:lstStyle/>
@@ -7128,7 +7179,7 @@
           <a:noFill/>
         </p:spPr>
         <p:txBody>
-          <a:bodyPr wrap="square" anchor="t" lIns="0" rIns="0" tIns="0" bIns="0">
+          <a:bodyPr wrap="square" lIns="0" tIns="0" rIns="0" bIns="0" anchor="t">
             <a:spAutoFit/>
           </a:bodyPr>
           <a:lstStyle/>
@@ -7170,7 +7221,7 @@
           <a:noFill/>
         </p:spPr>
         <p:txBody>
-          <a:bodyPr wrap="square" anchor="t" lIns="0" rIns="0" tIns="0" bIns="0">
+          <a:bodyPr wrap="square" lIns="0" tIns="0" rIns="0" bIns="0" anchor="t">
             <a:spAutoFit/>
           </a:bodyPr>
           <a:lstStyle/>
@@ -7213,7 +7264,7 @@
 </file>
 
 <file path=ppt/slides/slide13.xml><?xml version="1.0" encoding="utf-8"?>
-<p:sld xmlns:a="http://schemas.openxmlformats.org/drawingml/2006/main" xmlns:p="http://schemas.openxmlformats.org/presentationml/2006/main" xmlns:r="http://schemas.openxmlformats.org/officeDocument/2006/relationships">
+<p:sld xmlns:a="http://schemas.openxmlformats.org/drawingml/2006/main" xmlns:r="http://schemas.openxmlformats.org/officeDocument/2006/relationships" xmlns:p="http://schemas.openxmlformats.org/presentationml/2006/main">
   <p:cSld>
     <p:bg>
       <p:bgPr>
@@ -7229,7 +7280,14 @@
         <p:cNvGrpSpPr/>
         <p:nvPr/>
       </p:nvGrpSpPr>
-      <p:grpSpPr/>
+      <p:grpSpPr>
+        <a:xfrm>
+          <a:off x="0" y="0"/>
+          <a:ext cx="0" cy="0"/>
+          <a:chOff x="0" y="0"/>
+          <a:chExt cx="0" cy="0"/>
+        </a:xfrm>
+      </p:grpSpPr>
       <p:sp>
         <p:nvSpPr>
           <p:cNvPr id="2" name="Rectangle 1"/>
@@ -7271,6 +7329,7 @@
           <a:lstStyle/>
           <a:p>
             <a:pPr algn="ctr"/>
+            <a:endParaRPr/>
           </a:p>
         </p:txBody>
       </p:sp>
@@ -7315,6 +7374,7 @@
           <a:lstStyle/>
           <a:p>
             <a:pPr algn="ctr"/>
+            <a:endParaRPr/>
           </a:p>
         </p:txBody>
       </p:sp>
@@ -7335,7 +7395,7 @@
           <a:noFill/>
         </p:spPr>
         <p:txBody>
-          <a:bodyPr wrap="square" anchor="t" lIns="0" rIns="0" tIns="0" bIns="0">
+          <a:bodyPr wrap="square" lIns="0" tIns="0" rIns="0" bIns="0" anchor="t">
             <a:spAutoFit/>
           </a:bodyPr>
           <a:lstStyle/>
@@ -7440,6 +7500,7 @@
           <a:lstStyle/>
           <a:p>
             <a:pPr algn="ctr"/>
+            <a:endParaRPr/>
           </a:p>
         </p:txBody>
       </p:sp>
@@ -7484,6 +7545,7 @@
           <a:lstStyle/>
           <a:p>
             <a:pPr algn="ctr"/>
+            <a:endParaRPr/>
           </a:p>
         </p:txBody>
       </p:sp>
@@ -7612,7 +7674,7 @@
           <a:noFill/>
         </p:spPr>
         <p:txBody>
-          <a:bodyPr wrap="square" anchor="t" lIns="0" rIns="0" tIns="0" bIns="0">
+          <a:bodyPr wrap="square" lIns="0" tIns="0" rIns="0" bIns="0" anchor="t">
             <a:spAutoFit/>
           </a:bodyPr>
           <a:lstStyle/>
@@ -7657,7 +7719,7 @@
           <a:noFill/>
         </p:spPr>
         <p:txBody>
-          <a:bodyPr wrap="square" anchor="t" lIns="0" rIns="0" tIns="0" bIns="0">
+          <a:bodyPr wrap="square" lIns="0" tIns="0" rIns="0" bIns="0" anchor="t">
             <a:spAutoFit/>
           </a:bodyPr>
           <a:lstStyle/>
@@ -7723,6 +7785,7 @@
           <a:lstStyle/>
           <a:p>
             <a:pPr algn="ctr"/>
+            <a:endParaRPr/>
           </a:p>
         </p:txBody>
       </p:sp>
@@ -7767,6 +7830,7 @@
           <a:lstStyle/>
           <a:p>
             <a:pPr algn="ctr"/>
+            <a:endParaRPr/>
           </a:p>
         </p:txBody>
       </p:sp>
@@ -7838,15 +7902,12 @@
                 <a:spcPts val="200"/>
               </a:spcAft>
             </a:pPr>
-            <a:r>
-              <a:rPr sz="1250" b="0">
-                <a:solidFill>
-                  <a:srgbClr val="36454F"/>
-                </a:solidFill>
-                <a:latin typeface="DejaVu Sans Mono"/>
-              </a:rPr>
-              <a:t/>
-            </a:r>
+            <a:endParaRPr sz="1250" b="0">
+              <a:solidFill>
+                <a:srgbClr val="36454F"/>
+              </a:solidFill>
+              <a:latin typeface="DejaVu Sans Mono"/>
+            </a:endParaRPr>
           </a:p>
           <a:p>
             <a:pPr>
@@ -7914,7 +7975,7 @@
           <a:noFill/>
         </p:spPr>
         <p:txBody>
-          <a:bodyPr wrap="square" anchor="t" lIns="0" rIns="0" tIns="0" bIns="0">
+          <a:bodyPr wrap="square" lIns="0" tIns="0" rIns="0" bIns="0" anchor="t">
             <a:spAutoFit/>
           </a:bodyPr>
           <a:lstStyle/>
@@ -7995,7 +8056,7 @@
           <a:noFill/>
         </p:spPr>
         <p:txBody>
-          <a:bodyPr wrap="square" anchor="t" lIns="0" rIns="0" tIns="0" bIns="0">
+          <a:bodyPr wrap="square" lIns="0" tIns="0" rIns="0" bIns="0" anchor="t">
             <a:spAutoFit/>
           </a:bodyPr>
           <a:lstStyle/>
@@ -8037,7 +8098,7 @@
           <a:noFill/>
         </p:spPr>
         <p:txBody>
-          <a:bodyPr wrap="square" anchor="t" lIns="0" rIns="0" tIns="0" bIns="0">
+          <a:bodyPr wrap="square" lIns="0" tIns="0" rIns="0" bIns="0" anchor="t">
             <a:spAutoFit/>
           </a:bodyPr>
           <a:lstStyle/>
@@ -8080,7 +8141,7 @@
 </file>
 
 <file path=ppt/slides/slide14.xml><?xml version="1.0" encoding="utf-8"?>
-<p:sld xmlns:a="http://schemas.openxmlformats.org/drawingml/2006/main" xmlns:p="http://schemas.openxmlformats.org/presentationml/2006/main" xmlns:r="http://schemas.openxmlformats.org/officeDocument/2006/relationships">
+<p:sld xmlns:a="http://schemas.openxmlformats.org/drawingml/2006/main" xmlns:r="http://schemas.openxmlformats.org/officeDocument/2006/relationships" xmlns:p="http://schemas.openxmlformats.org/presentationml/2006/main">
   <p:cSld>
     <p:bg>
       <p:bgPr>
@@ -8096,7 +8157,14 @@
         <p:cNvGrpSpPr/>
         <p:nvPr/>
       </p:nvGrpSpPr>
-      <p:grpSpPr/>
+      <p:grpSpPr>
+        <a:xfrm>
+          <a:off x="0" y="0"/>
+          <a:ext cx="0" cy="0"/>
+          <a:chOff x="0" y="0"/>
+          <a:chExt cx="0" cy="0"/>
+        </a:xfrm>
+      </p:grpSpPr>
       <p:sp>
         <p:nvSpPr>
           <p:cNvPr id="2" name="Rectangle 1"/>
@@ -8138,6 +8206,7 @@
           <a:lstStyle/>
           <a:p>
             <a:pPr algn="ctr"/>
+            <a:endParaRPr/>
           </a:p>
         </p:txBody>
       </p:sp>
@@ -8182,6 +8251,7 @@
           <a:lstStyle/>
           <a:p>
             <a:pPr algn="ctr"/>
+            <a:endParaRPr/>
           </a:p>
         </p:txBody>
       </p:sp>
@@ -8202,7 +8272,7 @@
           <a:noFill/>
         </p:spPr>
         <p:txBody>
-          <a:bodyPr wrap="square" anchor="t" lIns="0" rIns="0" tIns="0" bIns="0">
+          <a:bodyPr wrap="square" lIns="0" tIns="0" rIns="0" bIns="0" anchor="t">
             <a:spAutoFit/>
           </a:bodyPr>
           <a:lstStyle/>
@@ -8307,6 +8377,7 @@
           <a:lstStyle/>
           <a:p>
             <a:pPr algn="ctr"/>
+            <a:endParaRPr/>
           </a:p>
         </p:txBody>
       </p:sp>
@@ -8327,7 +8398,7 @@
           <a:noFill/>
         </p:spPr>
         <p:txBody>
-          <a:bodyPr wrap="square" anchor="t" lIns="0" rIns="0" tIns="0" bIns="0">
+          <a:bodyPr wrap="square" lIns="0" tIns="0" rIns="0" bIns="0" anchor="t">
             <a:spAutoFit/>
           </a:bodyPr>
           <a:lstStyle/>
@@ -8369,7 +8440,7 @@
           <a:noFill/>
         </p:spPr>
         <p:txBody>
-          <a:bodyPr wrap="square" anchor="t" lIns="0" rIns="0" tIns="0" bIns="0">
+          <a:bodyPr wrap="square" lIns="0" tIns="0" rIns="0" bIns="0" anchor="t">
             <a:spAutoFit/>
           </a:bodyPr>
           <a:lstStyle/>
@@ -8435,6 +8506,7 @@
           <a:lstStyle/>
           <a:p>
             <a:pPr algn="ctr"/>
+            <a:endParaRPr/>
           </a:p>
         </p:txBody>
       </p:sp>
@@ -8479,6 +8551,7 @@
           <a:lstStyle/>
           <a:p>
             <a:pPr algn="ctr"/>
+            <a:endParaRPr/>
           </a:p>
         </p:txBody>
       </p:sp>
@@ -8499,7 +8572,7 @@
           <a:noFill/>
         </p:spPr>
         <p:txBody>
-          <a:bodyPr wrap="square" anchor="t" lIns="0" rIns="0" tIns="0" bIns="0">
+          <a:bodyPr wrap="square" lIns="0" tIns="0" rIns="0" bIns="0" anchor="t">
             <a:spAutoFit/>
           </a:bodyPr>
           <a:lstStyle/>
@@ -8541,7 +8614,7 @@
           <a:noFill/>
         </p:spPr>
         <p:txBody>
-          <a:bodyPr wrap="square" anchor="t" lIns="0" rIns="0" tIns="0" bIns="0">
+          <a:bodyPr wrap="square" lIns="0" tIns="0" rIns="0" bIns="0" anchor="t">
             <a:spAutoFit/>
           </a:bodyPr>
           <a:lstStyle/>
@@ -8607,6 +8680,7 @@
           <a:lstStyle/>
           <a:p>
             <a:pPr algn="ctr"/>
+            <a:endParaRPr/>
           </a:p>
         </p:txBody>
       </p:sp>
@@ -8627,7 +8701,7 @@
           <a:noFill/>
         </p:spPr>
         <p:txBody>
-          <a:bodyPr wrap="square" anchor="t" lIns="0" rIns="0" tIns="0" bIns="0">
+          <a:bodyPr wrap="square" lIns="0" tIns="0" rIns="0" bIns="0" anchor="t">
             <a:spAutoFit/>
           </a:bodyPr>
           <a:lstStyle/>
@@ -8669,7 +8743,7 @@
           <a:noFill/>
         </p:spPr>
         <p:txBody>
-          <a:bodyPr wrap="square" anchor="t" lIns="0" rIns="0" tIns="0" bIns="0">
+          <a:bodyPr wrap="square" lIns="0" tIns="0" rIns="0" bIns="0" anchor="t">
             <a:spAutoFit/>
           </a:bodyPr>
           <a:lstStyle/>
@@ -8735,6 +8809,7 @@
           <a:lstStyle/>
           <a:p>
             <a:pPr algn="ctr"/>
+            <a:endParaRPr/>
           </a:p>
         </p:txBody>
       </p:sp>
@@ -8779,6 +8854,7 @@
           <a:lstStyle/>
           <a:p>
             <a:pPr algn="ctr"/>
+            <a:endParaRPr/>
           </a:p>
         </p:txBody>
       </p:sp>
@@ -8799,7 +8875,7 @@
           <a:noFill/>
         </p:spPr>
         <p:txBody>
-          <a:bodyPr wrap="square" anchor="t" lIns="0" rIns="0" tIns="0" bIns="0">
+          <a:bodyPr wrap="square" lIns="0" tIns="0" rIns="0" bIns="0" anchor="t">
             <a:spAutoFit/>
           </a:bodyPr>
           <a:lstStyle/>
@@ -8841,7 +8917,7 @@
           <a:noFill/>
         </p:spPr>
         <p:txBody>
-          <a:bodyPr wrap="square" anchor="t" lIns="0" rIns="0" tIns="0" bIns="0">
+          <a:bodyPr wrap="square" lIns="0" tIns="0" rIns="0" bIns="0" anchor="t">
             <a:spAutoFit/>
           </a:bodyPr>
           <a:lstStyle/>
@@ -8907,6 +8983,7 @@
           <a:lstStyle/>
           <a:p>
             <a:pPr algn="ctr"/>
+            <a:endParaRPr/>
           </a:p>
         </p:txBody>
       </p:sp>
@@ -8927,7 +9004,7 @@
           <a:noFill/>
         </p:spPr>
         <p:txBody>
-          <a:bodyPr wrap="square" anchor="t" lIns="0" rIns="0" tIns="0" bIns="0">
+          <a:bodyPr wrap="square" lIns="0" tIns="0" rIns="0" bIns="0" anchor="t">
             <a:spAutoFit/>
           </a:bodyPr>
           <a:lstStyle/>
@@ -8969,7 +9046,7 @@
           <a:noFill/>
         </p:spPr>
         <p:txBody>
-          <a:bodyPr wrap="square" anchor="t" lIns="0" rIns="0" tIns="0" bIns="0">
+          <a:bodyPr wrap="square" lIns="0" tIns="0" rIns="0" bIns="0" anchor="t">
             <a:spAutoFit/>
           </a:bodyPr>
           <a:lstStyle/>
@@ -9011,7 +9088,7 @@
           <a:noFill/>
         </p:spPr>
         <p:txBody>
-          <a:bodyPr wrap="square" anchor="t" lIns="0" rIns="0" tIns="0" bIns="0">
+          <a:bodyPr wrap="square" lIns="0" tIns="0" rIns="0" bIns="0" anchor="t">
             <a:spAutoFit/>
           </a:bodyPr>
           <a:lstStyle/>
@@ -9071,7 +9148,7 @@
           <a:noFill/>
         </p:spPr>
         <p:txBody>
-          <a:bodyPr wrap="square" anchor="t" lIns="0" rIns="0" tIns="0" bIns="0">
+          <a:bodyPr wrap="square" lIns="0" tIns="0" rIns="0" bIns="0" anchor="t">
             <a:spAutoFit/>
           </a:bodyPr>
           <a:lstStyle/>
@@ -9113,7 +9190,7 @@
           <a:noFill/>
         </p:spPr>
         <p:txBody>
-          <a:bodyPr wrap="square" anchor="t" lIns="0" rIns="0" tIns="0" bIns="0">
+          <a:bodyPr wrap="square" lIns="0" tIns="0" rIns="0" bIns="0" anchor="t">
             <a:spAutoFit/>
           </a:bodyPr>
           <a:lstStyle/>
@@ -9156,7 +9233,7 @@
 </file>
 
 <file path=ppt/slides/slide15.xml><?xml version="1.0" encoding="utf-8"?>
-<p:sld xmlns:a="http://schemas.openxmlformats.org/drawingml/2006/main" xmlns:p="http://schemas.openxmlformats.org/presentationml/2006/main" xmlns:r="http://schemas.openxmlformats.org/officeDocument/2006/relationships">
+<p:sld xmlns:a="http://schemas.openxmlformats.org/drawingml/2006/main" xmlns:r="http://schemas.openxmlformats.org/officeDocument/2006/relationships" xmlns:p="http://schemas.openxmlformats.org/presentationml/2006/main">
   <p:cSld>
     <p:bg>
       <p:bgPr>
@@ -9172,7 +9249,14 @@
         <p:cNvGrpSpPr/>
         <p:nvPr/>
       </p:nvGrpSpPr>
-      <p:grpSpPr/>
+      <p:grpSpPr>
+        <a:xfrm>
+          <a:off x="0" y="0"/>
+          <a:ext cx="0" cy="0"/>
+          <a:chOff x="0" y="0"/>
+          <a:chExt cx="0" cy="0"/>
+        </a:xfrm>
+      </p:grpSpPr>
       <p:sp>
         <p:nvSpPr>
           <p:cNvPr id="2" name="Rectangle 1"/>
@@ -9214,6 +9298,7 @@
           <a:lstStyle/>
           <a:p>
             <a:pPr algn="ctr"/>
+            <a:endParaRPr/>
           </a:p>
         </p:txBody>
       </p:sp>
@@ -9258,6 +9343,7 @@
           <a:lstStyle/>
           <a:p>
             <a:pPr algn="ctr"/>
+            <a:endParaRPr/>
           </a:p>
         </p:txBody>
       </p:sp>
@@ -9278,7 +9364,7 @@
           <a:noFill/>
         </p:spPr>
         <p:txBody>
-          <a:bodyPr wrap="square" anchor="t" lIns="0" rIns="0" tIns="0" bIns="0">
+          <a:bodyPr wrap="square" lIns="0" tIns="0" rIns="0" bIns="0" anchor="t">
             <a:spAutoFit/>
           </a:bodyPr>
           <a:lstStyle/>
@@ -9359,7 +9445,7 @@
           <a:noFill/>
         </p:spPr>
         <p:txBody>
-          <a:bodyPr wrap="square" anchor="t" lIns="0" rIns="0" tIns="0" bIns="0">
+          <a:bodyPr wrap="square" lIns="0" tIns="0" rIns="0" bIns="0" anchor="t">
             <a:spAutoFit/>
           </a:bodyPr>
           <a:lstStyle/>
@@ -9401,7 +9487,7 @@
           <a:noFill/>
         </p:spPr>
         <p:txBody>
-          <a:bodyPr wrap="square" anchor="t" lIns="0" rIns="0" tIns="0" bIns="0">
+          <a:bodyPr wrap="square" lIns="0" tIns="0" rIns="0" bIns="0" anchor="t">
             <a:spAutoFit/>
           </a:bodyPr>
           <a:lstStyle/>
@@ -9446,7 +9532,7 @@
           <a:noFill/>
         </p:spPr>
         <p:txBody>
-          <a:bodyPr wrap="square" anchor="t" lIns="0" rIns="0" tIns="0" bIns="0">
+          <a:bodyPr wrap="square" lIns="0" tIns="0" rIns="0" bIns="0" anchor="t">
             <a:spAutoFit/>
           </a:bodyPr>
           <a:lstStyle/>
@@ -9488,7 +9574,7 @@
           <a:noFill/>
         </p:spPr>
         <p:txBody>
-          <a:bodyPr wrap="square" anchor="t" lIns="0" rIns="0" tIns="0" bIns="0">
+          <a:bodyPr wrap="square" lIns="0" tIns="0" rIns="0" bIns="0" anchor="t">
             <a:spAutoFit/>
           </a:bodyPr>
           <a:lstStyle/>
@@ -9533,7 +9619,7 @@
           <a:noFill/>
         </p:spPr>
         <p:txBody>
-          <a:bodyPr wrap="square" anchor="t" lIns="0" rIns="0" tIns="0" bIns="0">
+          <a:bodyPr wrap="square" lIns="0" tIns="0" rIns="0" bIns="0" anchor="t">
             <a:spAutoFit/>
           </a:bodyPr>
           <a:lstStyle/>
@@ -9575,7 +9661,7 @@
           <a:noFill/>
         </p:spPr>
         <p:txBody>
-          <a:bodyPr wrap="square" anchor="t" lIns="0" rIns="0" tIns="0" bIns="0">
+          <a:bodyPr wrap="square" lIns="0" tIns="0" rIns="0" bIns="0" anchor="t">
             <a:spAutoFit/>
           </a:bodyPr>
           <a:lstStyle/>
@@ -9620,7 +9706,7 @@
           <a:noFill/>
         </p:spPr>
         <p:txBody>
-          <a:bodyPr wrap="square" anchor="t" lIns="0" rIns="0" tIns="0" bIns="0">
+          <a:bodyPr wrap="square" lIns="0" tIns="0" rIns="0" bIns="0" anchor="t">
             <a:spAutoFit/>
           </a:bodyPr>
           <a:lstStyle/>
@@ -9662,7 +9748,7 @@
           <a:noFill/>
         </p:spPr>
         <p:txBody>
-          <a:bodyPr wrap="square" anchor="t" lIns="0" rIns="0" tIns="0" bIns="0">
+          <a:bodyPr wrap="square" lIns="0" tIns="0" rIns="0" bIns="0" anchor="t">
             <a:spAutoFit/>
           </a:bodyPr>
           <a:lstStyle/>
@@ -9707,7 +9793,7 @@
           <a:noFill/>
         </p:spPr>
         <p:txBody>
-          <a:bodyPr wrap="square" anchor="t" lIns="0" rIns="0" tIns="0" bIns="0">
+          <a:bodyPr wrap="square" lIns="0" tIns="0" rIns="0" bIns="0" anchor="t">
             <a:spAutoFit/>
           </a:bodyPr>
           <a:lstStyle/>
@@ -9749,7 +9835,7 @@
           <a:noFill/>
         </p:spPr>
         <p:txBody>
-          <a:bodyPr wrap="square" anchor="t" lIns="0" rIns="0" tIns="0" bIns="0">
+          <a:bodyPr wrap="square" lIns="0" tIns="0" rIns="0" bIns="0" anchor="t">
             <a:spAutoFit/>
           </a:bodyPr>
           <a:lstStyle/>
@@ -9818,6 +9904,7 @@
           <a:lstStyle/>
           <a:p>
             <a:pPr algn="ctr"/>
+            <a:endParaRPr/>
           </a:p>
         </p:txBody>
       </p:sp>
@@ -9838,7 +9925,7 @@
           <a:noFill/>
         </p:spPr>
         <p:txBody>
-          <a:bodyPr wrap="square" anchor="t" lIns="0" rIns="0" tIns="0" bIns="0">
+          <a:bodyPr wrap="square" lIns="0" tIns="0" rIns="0" bIns="0" anchor="t">
             <a:spAutoFit/>
           </a:bodyPr>
           <a:lstStyle/>
@@ -9880,7 +9967,7 @@
           <a:noFill/>
         </p:spPr>
         <p:txBody>
-          <a:bodyPr wrap="square" anchor="t" lIns="0" rIns="0" tIns="0" bIns="0">
+          <a:bodyPr wrap="square" lIns="0" tIns="0" rIns="0" bIns="0" anchor="t">
             <a:spAutoFit/>
           </a:bodyPr>
           <a:lstStyle/>
@@ -9925,7 +10012,7 @@
           <a:noFill/>
         </p:spPr>
         <p:txBody>
-          <a:bodyPr wrap="square" anchor="t" lIns="0" rIns="0" tIns="0" bIns="0">
+          <a:bodyPr wrap="square" lIns="0" tIns="0" rIns="0" bIns="0" anchor="t">
             <a:spAutoFit/>
           </a:bodyPr>
           <a:lstStyle/>
@@ -9967,7 +10054,7 @@
           <a:noFill/>
         </p:spPr>
         <p:txBody>
-          <a:bodyPr wrap="square" anchor="t" lIns="0" rIns="0" tIns="0" bIns="0">
+          <a:bodyPr wrap="square" lIns="0" tIns="0" rIns="0" bIns="0" anchor="t">
             <a:spAutoFit/>
           </a:bodyPr>
           <a:lstStyle/>
@@ -10012,7 +10099,7 @@
           <a:noFill/>
         </p:spPr>
         <p:txBody>
-          <a:bodyPr wrap="square" anchor="t" lIns="0" rIns="0" tIns="0" bIns="0">
+          <a:bodyPr wrap="square" lIns="0" tIns="0" rIns="0" bIns="0" anchor="t">
             <a:spAutoFit/>
           </a:bodyPr>
           <a:lstStyle/>
@@ -10054,7 +10141,7 @@
           <a:noFill/>
         </p:spPr>
         <p:txBody>
-          <a:bodyPr wrap="square" anchor="t" lIns="0" rIns="0" tIns="0" bIns="0">
+          <a:bodyPr wrap="square" lIns="0" tIns="0" rIns="0" bIns="0" anchor="t">
             <a:spAutoFit/>
           </a:bodyPr>
           <a:lstStyle/>
@@ -10097,7 +10184,7 @@
 </file>
 
 <file path=ppt/slides/slide16.xml><?xml version="1.0" encoding="utf-8"?>
-<p:sld xmlns:a="http://schemas.openxmlformats.org/drawingml/2006/main" xmlns:p="http://schemas.openxmlformats.org/presentationml/2006/main" xmlns:r="http://schemas.openxmlformats.org/officeDocument/2006/relationships">
+<p:sld xmlns:a="http://schemas.openxmlformats.org/drawingml/2006/main" xmlns:r="http://schemas.openxmlformats.org/officeDocument/2006/relationships" xmlns:p="http://schemas.openxmlformats.org/presentationml/2006/main">
   <p:cSld>
     <p:bg>
       <p:bgPr>
@@ -10113,7 +10200,14 @@
         <p:cNvGrpSpPr/>
         <p:nvPr/>
       </p:nvGrpSpPr>
-      <p:grpSpPr/>
+      <p:grpSpPr>
+        <a:xfrm>
+          <a:off x="0" y="0"/>
+          <a:ext cx="0" cy="0"/>
+          <a:chOff x="0" y="0"/>
+          <a:chExt cx="0" cy="0"/>
+        </a:xfrm>
+      </p:grpSpPr>
       <p:sp>
         <p:nvSpPr>
           <p:cNvPr id="2" name="Rectangle 1"/>
@@ -10155,6 +10249,7 @@
           <a:lstStyle/>
           <a:p>
             <a:pPr algn="ctr"/>
+            <a:endParaRPr/>
           </a:p>
         </p:txBody>
       </p:sp>
@@ -10199,6 +10294,7 @@
           <a:lstStyle/>
           <a:p>
             <a:pPr algn="ctr"/>
+            <a:endParaRPr/>
           </a:p>
         </p:txBody>
       </p:sp>
@@ -10219,7 +10315,7 @@
           <a:noFill/>
         </p:spPr>
         <p:txBody>
-          <a:bodyPr wrap="square" anchor="t" lIns="0" rIns="0" tIns="0" bIns="0">
+          <a:bodyPr wrap="square" lIns="0" tIns="0" rIns="0" bIns="0" anchor="t">
             <a:spAutoFit/>
           </a:bodyPr>
           <a:lstStyle/>
@@ -10287,6 +10383,7 @@
           <a:lstStyle/>
           <a:p>
             <a:pPr algn="ctr"/>
+            <a:endParaRPr/>
           </a:p>
         </p:txBody>
       </p:sp>
@@ -10307,7 +10404,7 @@
           <a:noFill/>
         </p:spPr>
         <p:txBody>
-          <a:bodyPr wrap="square" anchor="t" lIns="0" rIns="0" tIns="0" bIns="0">
+          <a:bodyPr wrap="square" lIns="0" tIns="0" rIns="0" bIns="0" anchor="t">
             <a:spAutoFit/>
           </a:bodyPr>
           <a:lstStyle/>
@@ -10394,6 +10491,7 @@
           <a:lstStyle/>
           <a:p>
             <a:pPr algn="ctr"/>
+            <a:endParaRPr/>
           </a:p>
         </p:txBody>
       </p:sp>
@@ -10414,7 +10512,7 @@
           <a:noFill/>
         </p:spPr>
         <p:txBody>
-          <a:bodyPr wrap="square" anchor="t" lIns="0" rIns="0" tIns="0" bIns="0">
+          <a:bodyPr wrap="square" lIns="0" tIns="0" rIns="0" bIns="0" anchor="t">
             <a:spAutoFit/>
           </a:bodyPr>
           <a:lstStyle/>
@@ -10501,6 +10599,7 @@
           <a:lstStyle/>
           <a:p>
             <a:pPr algn="ctr"/>
+            <a:endParaRPr/>
           </a:p>
         </p:txBody>
       </p:sp>
@@ -10521,7 +10620,7 @@
           <a:noFill/>
         </p:spPr>
         <p:txBody>
-          <a:bodyPr wrap="square" anchor="t" lIns="0" rIns="0" tIns="0" bIns="0">
+          <a:bodyPr wrap="square" lIns="0" tIns="0" rIns="0" bIns="0" anchor="t">
             <a:spAutoFit/>
           </a:bodyPr>
           <a:lstStyle/>
@@ -10656,7 +10755,7 @@
           <a:noFill/>
         </p:spPr>
         <p:txBody>
-          <a:bodyPr wrap="square" anchor="t" lIns="0" rIns="0" tIns="0" bIns="0">
+          <a:bodyPr wrap="square" lIns="0" tIns="0" rIns="0" bIns="0" anchor="t">
             <a:spAutoFit/>
           </a:bodyPr>
           <a:lstStyle/>
@@ -10698,7 +10797,7 @@
           <a:noFill/>
         </p:spPr>
         <p:txBody>
-          <a:bodyPr wrap="square" anchor="t" lIns="0" rIns="0" tIns="0" bIns="0">
+          <a:bodyPr wrap="square" lIns="0" tIns="0" rIns="0" bIns="0" anchor="t">
             <a:spAutoFit/>
           </a:bodyPr>
           <a:lstStyle/>
@@ -10836,7 +10935,7 @@
           <a:noFill/>
         </p:spPr>
         <p:txBody>
-          <a:bodyPr wrap="square" anchor="t" lIns="0" rIns="0" tIns="0" bIns="0">
+          <a:bodyPr wrap="square" lIns="0" tIns="0" rIns="0" bIns="0" anchor="t">
             <a:spAutoFit/>
           </a:bodyPr>
           <a:lstStyle/>
@@ -10881,7 +10980,7 @@
           <a:noFill/>
         </p:spPr>
         <p:txBody>
-          <a:bodyPr wrap="square" anchor="t" lIns="0" rIns="0" tIns="0" bIns="0">
+          <a:bodyPr wrap="square" lIns="0" tIns="0" rIns="0" bIns="0" anchor="t">
             <a:spAutoFit/>
           </a:bodyPr>
           <a:lstStyle/>
@@ -10944,7 +11043,7 @@
           <a:noFill/>
         </p:spPr>
         <p:txBody>
-          <a:bodyPr wrap="square" anchor="t" lIns="0" rIns="0" tIns="0" bIns="0">
+          <a:bodyPr wrap="square" lIns="0" tIns="0" rIns="0" bIns="0" anchor="t">
             <a:spAutoFit/>
           </a:bodyPr>
           <a:lstStyle/>
@@ -10986,7 +11085,7 @@
           <a:noFill/>
         </p:spPr>
         <p:txBody>
-          <a:bodyPr wrap="square" anchor="t" lIns="0" rIns="0" tIns="0" bIns="0">
+          <a:bodyPr wrap="square" lIns="0" tIns="0" rIns="0" bIns="0" anchor="t">
             <a:spAutoFit/>
           </a:bodyPr>
           <a:lstStyle/>
@@ -11029,7 +11128,7 @@
 </file>
 
 <file path=ppt/slides/slide17.xml><?xml version="1.0" encoding="utf-8"?>
-<p:sld xmlns:a="http://schemas.openxmlformats.org/drawingml/2006/main" xmlns:p="http://schemas.openxmlformats.org/presentationml/2006/main" xmlns:r="http://schemas.openxmlformats.org/officeDocument/2006/relationships">
+<p:sld xmlns:a="http://schemas.openxmlformats.org/drawingml/2006/main" xmlns:r="http://schemas.openxmlformats.org/officeDocument/2006/relationships" xmlns:p="http://schemas.openxmlformats.org/presentationml/2006/main">
   <p:cSld>
     <p:bg>
       <p:bgPr>
@@ -11045,7 +11144,14 @@
         <p:cNvGrpSpPr/>
         <p:nvPr/>
       </p:nvGrpSpPr>
-      <p:grpSpPr/>
+      <p:grpSpPr>
+        <a:xfrm>
+          <a:off x="0" y="0"/>
+          <a:ext cx="0" cy="0"/>
+          <a:chOff x="0" y="0"/>
+          <a:chExt cx="0" cy="0"/>
+        </a:xfrm>
+      </p:grpSpPr>
       <p:sp>
         <p:nvSpPr>
           <p:cNvPr id="2" name="Rectangle 1"/>
@@ -11087,6 +11193,7 @@
           <a:lstStyle/>
           <a:p>
             <a:pPr algn="ctr"/>
+            <a:endParaRPr/>
           </a:p>
         </p:txBody>
       </p:sp>
@@ -11131,6 +11238,7 @@
           <a:lstStyle/>
           <a:p>
             <a:pPr algn="ctr"/>
+            <a:endParaRPr/>
           </a:p>
         </p:txBody>
       </p:sp>
@@ -11151,7 +11259,7 @@
           <a:noFill/>
         </p:spPr>
         <p:txBody>
-          <a:bodyPr wrap="square" anchor="t" lIns="0" rIns="0" tIns="0" bIns="0">
+          <a:bodyPr wrap="square" lIns="0" tIns="0" rIns="0" bIns="0" anchor="t">
             <a:spAutoFit/>
           </a:bodyPr>
           <a:lstStyle/>
@@ -11256,6 +11364,7 @@
           <a:lstStyle/>
           <a:p>
             <a:pPr algn="ctr"/>
+            <a:endParaRPr/>
           </a:p>
         </p:txBody>
       </p:sp>
@@ -11300,6 +11409,7 @@
           <a:lstStyle/>
           <a:p>
             <a:pPr algn="ctr"/>
+            <a:endParaRPr/>
           </a:p>
         </p:txBody>
       </p:sp>
@@ -11472,15 +11582,12 @@
                 <a:spcPts val="200"/>
               </a:spcAft>
             </a:pPr>
-            <a:r>
-              <a:rPr sz="1100" b="0">
-                <a:solidFill>
-                  <a:srgbClr val="36454F"/>
-                </a:solidFill>
-                <a:latin typeface="DejaVu Sans Mono"/>
-              </a:rPr>
-              <a:t/>
-            </a:r>
+            <a:endParaRPr sz="1100" b="0">
+              <a:solidFill>
+                <a:srgbClr val="36454F"/>
+              </a:solidFill>
+              <a:latin typeface="DejaVu Sans Mono"/>
+            </a:endParaRPr>
           </a:p>
           <a:p>
             <a:pPr>
@@ -11621,7 +11728,7 @@
           <a:noFill/>
         </p:spPr>
         <p:txBody>
-          <a:bodyPr wrap="square" anchor="t" lIns="0" rIns="0" tIns="0" bIns="0">
+          <a:bodyPr wrap="square" lIns="0" tIns="0" rIns="0" bIns="0" anchor="t">
             <a:spAutoFit/>
           </a:bodyPr>
           <a:lstStyle/>
@@ -11684,7 +11791,7 @@
           <a:noFill/>
         </p:spPr>
         <p:txBody>
-          <a:bodyPr wrap="square" anchor="t" lIns="0" rIns="0" tIns="0" bIns="0">
+          <a:bodyPr wrap="square" lIns="0" tIns="0" rIns="0" bIns="0" anchor="t">
             <a:spAutoFit/>
           </a:bodyPr>
           <a:lstStyle/>
@@ -11750,6 +11857,7 @@
           <a:lstStyle/>
           <a:p>
             <a:pPr algn="ctr"/>
+            <a:endParaRPr/>
           </a:p>
         </p:txBody>
       </p:sp>
@@ -11794,6 +11902,7 @@
           <a:lstStyle/>
           <a:p>
             <a:pPr algn="ctr"/>
+            <a:endParaRPr/>
           </a:p>
         </p:txBody>
       </p:sp>
@@ -11846,15 +11955,12 @@
                 <a:spcPts val="200"/>
               </a:spcAft>
             </a:pPr>
-            <a:r>
-              <a:rPr sz="1200" b="0">
-                <a:solidFill>
-                  <a:srgbClr val="36454F"/>
-                </a:solidFill>
-                <a:latin typeface="DejaVu Sans Mono"/>
-              </a:rPr>
-              <a:t/>
-            </a:r>
+            <a:endParaRPr sz="1200" b="0">
+              <a:solidFill>
+                <a:srgbClr val="36454F"/>
+              </a:solidFill>
+              <a:latin typeface="DejaVu Sans Mono"/>
+            </a:endParaRPr>
           </a:p>
           <a:p>
             <a:pPr>
@@ -11951,7 +12057,7 @@
           <a:noFill/>
         </p:spPr>
         <p:txBody>
-          <a:bodyPr wrap="square" anchor="t" lIns="0" rIns="0" tIns="0" bIns="0">
+          <a:bodyPr wrap="square" lIns="0" tIns="0" rIns="0" bIns="0" anchor="t">
             <a:spAutoFit/>
           </a:bodyPr>
           <a:lstStyle/>
@@ -12014,7 +12120,7 @@
           <a:noFill/>
         </p:spPr>
         <p:txBody>
-          <a:bodyPr wrap="square" anchor="t" lIns="0" rIns="0" tIns="0" bIns="0">
+          <a:bodyPr wrap="square" lIns="0" tIns="0" rIns="0" bIns="0" anchor="t">
             <a:spAutoFit/>
           </a:bodyPr>
           <a:lstStyle/>
@@ -12056,7 +12162,7 @@
           <a:noFill/>
         </p:spPr>
         <p:txBody>
-          <a:bodyPr wrap="square" anchor="t" lIns="0" rIns="0" tIns="0" bIns="0">
+          <a:bodyPr wrap="square" lIns="0" tIns="0" rIns="0" bIns="0" anchor="t">
             <a:spAutoFit/>
           </a:bodyPr>
           <a:lstStyle/>
@@ -12099,7 +12205,7 @@
 </file>
 
 <file path=ppt/slides/slide18.xml><?xml version="1.0" encoding="utf-8"?>
-<p:sld xmlns:a="http://schemas.openxmlformats.org/drawingml/2006/main" xmlns:p="http://schemas.openxmlformats.org/presentationml/2006/main" xmlns:r="http://schemas.openxmlformats.org/officeDocument/2006/relationships">
+<p:sld xmlns:a="http://schemas.openxmlformats.org/drawingml/2006/main" xmlns:r="http://schemas.openxmlformats.org/officeDocument/2006/relationships" xmlns:p="http://schemas.openxmlformats.org/presentationml/2006/main">
   <p:cSld>
     <p:bg>
       <p:bgPr>
@@ -12115,7 +12221,14 @@
         <p:cNvGrpSpPr/>
         <p:nvPr/>
       </p:nvGrpSpPr>
-      <p:grpSpPr/>
+      <p:grpSpPr>
+        <a:xfrm>
+          <a:off x="0" y="0"/>
+          <a:ext cx="0" cy="0"/>
+          <a:chOff x="0" y="0"/>
+          <a:chExt cx="0" cy="0"/>
+        </a:xfrm>
+      </p:grpSpPr>
       <p:sp>
         <p:nvSpPr>
           <p:cNvPr id="2" name="Rectangle 1"/>
@@ -12157,6 +12270,7 @@
           <a:lstStyle/>
           <a:p>
             <a:pPr algn="ctr"/>
+            <a:endParaRPr/>
           </a:p>
         </p:txBody>
       </p:sp>
@@ -12201,6 +12315,7 @@
           <a:lstStyle/>
           <a:p>
             <a:pPr algn="ctr"/>
+            <a:endParaRPr/>
           </a:p>
         </p:txBody>
       </p:sp>
@@ -12221,7 +12336,7 @@
           <a:noFill/>
         </p:spPr>
         <p:txBody>
-          <a:bodyPr wrap="square" anchor="t" lIns="0" rIns="0" tIns="0" bIns="0">
+          <a:bodyPr wrap="square" lIns="0" tIns="0" rIns="0" bIns="0" anchor="t">
             <a:spAutoFit/>
           </a:bodyPr>
           <a:lstStyle/>
@@ -12365,6 +12480,7 @@
           <a:lstStyle/>
           <a:p>
             <a:pPr algn="ctr"/>
+            <a:endParaRPr/>
           </a:p>
         </p:txBody>
       </p:sp>
@@ -12385,7 +12501,7 @@
           <a:noFill/>
         </p:spPr>
         <p:txBody>
-          <a:bodyPr wrap="square" anchor="t" lIns="0" rIns="0" tIns="0" bIns="0">
+          <a:bodyPr wrap="square" lIns="0" tIns="0" rIns="0" bIns="0" anchor="t">
             <a:spAutoFit/>
           </a:bodyPr>
           <a:lstStyle/>
@@ -12451,6 +12567,7 @@
           <a:lstStyle/>
           <a:p>
             <a:pPr algn="ctr"/>
+            <a:endParaRPr/>
           </a:p>
         </p:txBody>
       </p:sp>
@@ -12471,7 +12588,7 @@
           <a:noFill/>
         </p:spPr>
         <p:txBody>
-          <a:bodyPr wrap="square" anchor="t" lIns="0" rIns="0" tIns="0" bIns="0">
+          <a:bodyPr wrap="square" lIns="0" tIns="0" rIns="0" bIns="0" anchor="t">
             <a:spAutoFit/>
           </a:bodyPr>
           <a:lstStyle/>
@@ -12537,6 +12654,7 @@
           <a:lstStyle/>
           <a:p>
             <a:pPr algn="ctr"/>
+            <a:endParaRPr/>
           </a:p>
         </p:txBody>
       </p:sp>
@@ -12557,7 +12675,7 @@
           <a:noFill/>
         </p:spPr>
         <p:txBody>
-          <a:bodyPr wrap="square" anchor="t" lIns="0" rIns="0" tIns="0" bIns="0">
+          <a:bodyPr wrap="square" lIns="0" tIns="0" rIns="0" bIns="0" anchor="t">
             <a:spAutoFit/>
           </a:bodyPr>
           <a:lstStyle/>
@@ -12623,6 +12741,7 @@
           <a:lstStyle/>
           <a:p>
             <a:pPr algn="ctr"/>
+            <a:endParaRPr/>
           </a:p>
         </p:txBody>
       </p:sp>
@@ -12643,7 +12762,7 @@
           <a:noFill/>
         </p:spPr>
         <p:txBody>
-          <a:bodyPr wrap="square" anchor="t" lIns="0" rIns="0" tIns="0" bIns="0">
+          <a:bodyPr wrap="square" lIns="0" tIns="0" rIns="0" bIns="0" anchor="t">
             <a:spAutoFit/>
           </a:bodyPr>
           <a:lstStyle/>
@@ -12709,6 +12828,7 @@
           <a:lstStyle/>
           <a:p>
             <a:pPr algn="ctr"/>
+            <a:endParaRPr/>
           </a:p>
         </p:txBody>
       </p:sp>
@@ -12729,7 +12849,7 @@
           <a:noFill/>
         </p:spPr>
         <p:txBody>
-          <a:bodyPr wrap="square" anchor="t" lIns="0" rIns="0" tIns="0" bIns="0">
+          <a:bodyPr wrap="square" lIns="0" tIns="0" rIns="0" bIns="0" anchor="t">
             <a:spAutoFit/>
           </a:bodyPr>
           <a:lstStyle/>
@@ -12795,6 +12915,7 @@
           <a:lstStyle/>
           <a:p>
             <a:pPr algn="ctr"/>
+            <a:endParaRPr/>
           </a:p>
         </p:txBody>
       </p:sp>
@@ -12815,7 +12936,7 @@
           <a:noFill/>
         </p:spPr>
         <p:txBody>
-          <a:bodyPr wrap="square" anchor="t" lIns="0" rIns="0" tIns="0" bIns="0">
+          <a:bodyPr wrap="square" lIns="0" tIns="0" rIns="0" bIns="0" anchor="t">
             <a:spAutoFit/>
           </a:bodyPr>
           <a:lstStyle/>
@@ -12900,7 +13021,7 @@
           <a:noFill/>
         </p:spPr>
         <p:txBody>
-          <a:bodyPr wrap="square" anchor="t" lIns="0" rIns="0" tIns="0" bIns="0">
+          <a:bodyPr wrap="square" lIns="0" tIns="0" rIns="0" bIns="0" anchor="t">
             <a:spAutoFit/>
           </a:bodyPr>
           <a:lstStyle/>
@@ -12945,7 +13066,7 @@
           <a:noFill/>
         </p:spPr>
         <p:txBody>
-          <a:bodyPr wrap="square" anchor="t" lIns="0" rIns="0" tIns="0" bIns="0">
+          <a:bodyPr wrap="square" lIns="0" tIns="0" rIns="0" bIns="0" anchor="t">
             <a:spAutoFit/>
           </a:bodyPr>
           <a:lstStyle/>
@@ -12987,7 +13108,7 @@
           <a:noFill/>
         </p:spPr>
         <p:txBody>
-          <a:bodyPr wrap="square" anchor="t" lIns="0" rIns="0" tIns="0" bIns="0">
+          <a:bodyPr wrap="square" lIns="0" tIns="0" rIns="0" bIns="0" anchor="t">
             <a:spAutoFit/>
           </a:bodyPr>
           <a:lstStyle/>
@@ -13030,7 +13151,7 @@
 </file>
 
 <file path=ppt/slides/slide2.xml><?xml version="1.0" encoding="utf-8"?>
-<p:sld xmlns:a="http://schemas.openxmlformats.org/drawingml/2006/main" xmlns:p="http://schemas.openxmlformats.org/presentationml/2006/main" xmlns:r="http://schemas.openxmlformats.org/officeDocument/2006/relationships">
+<p:sld xmlns:a="http://schemas.openxmlformats.org/drawingml/2006/main" xmlns:r="http://schemas.openxmlformats.org/officeDocument/2006/relationships" xmlns:p="http://schemas.openxmlformats.org/presentationml/2006/main">
   <p:cSld>
     <p:bg>
       <p:bgPr>
@@ -13046,7 +13167,14 @@
         <p:cNvGrpSpPr/>
         <p:nvPr/>
       </p:nvGrpSpPr>
-      <p:grpSpPr/>
+      <p:grpSpPr>
+        <a:xfrm>
+          <a:off x="0" y="0"/>
+          <a:ext cx="0" cy="0"/>
+          <a:chOff x="0" y="0"/>
+          <a:chExt cx="0" cy="0"/>
+        </a:xfrm>
+      </p:grpSpPr>
       <p:sp>
         <p:nvSpPr>
           <p:cNvPr id="2" name="Rectangle 1"/>
@@ -13088,6 +13216,7 @@
           <a:lstStyle/>
           <a:p>
             <a:pPr algn="ctr"/>
+            <a:endParaRPr/>
           </a:p>
         </p:txBody>
       </p:sp>
@@ -13132,6 +13261,7 @@
           <a:lstStyle/>
           <a:p>
             <a:pPr algn="ctr"/>
+            <a:endParaRPr/>
           </a:p>
         </p:txBody>
       </p:sp>
@@ -13152,7 +13282,7 @@
           <a:noFill/>
         </p:spPr>
         <p:txBody>
-          <a:bodyPr wrap="square" anchor="t" lIns="0" rIns="0" tIns="0" bIns="0">
+          <a:bodyPr wrap="square" lIns="0" tIns="0" rIns="0" bIns="0" anchor="t">
             <a:spAutoFit/>
           </a:bodyPr>
           <a:lstStyle/>
@@ -13251,7 +13381,7 @@
           <a:noFill/>
         </p:spPr>
         <p:txBody>
-          <a:bodyPr wrap="square" anchor="t" lIns="0" rIns="0" tIns="0" bIns="0">
+          <a:bodyPr wrap="square" lIns="0" tIns="0" rIns="0" bIns="0" anchor="t">
             <a:spAutoFit/>
           </a:bodyPr>
           <a:lstStyle/>
@@ -13340,6 +13470,7 @@
           <a:lstStyle/>
           <a:p>
             <a:pPr algn="ctr"/>
+            <a:endParaRPr/>
           </a:p>
         </p:txBody>
       </p:sp>
@@ -13360,7 +13491,7 @@
           <a:noFill/>
         </p:spPr>
         <p:txBody>
-          <a:bodyPr wrap="square" anchor="t" lIns="0" rIns="0" tIns="0" bIns="0">
+          <a:bodyPr wrap="square" lIns="0" tIns="0" rIns="0" bIns="0" anchor="t">
             <a:spAutoFit/>
           </a:bodyPr>
           <a:lstStyle/>
@@ -13426,6 +13557,7 @@
           <a:lstStyle/>
           <a:p>
             <a:pPr algn="ctr"/>
+            <a:endParaRPr/>
           </a:p>
         </p:txBody>
       </p:sp>
@@ -13446,7 +13578,7 @@
           <a:noFill/>
         </p:spPr>
         <p:txBody>
-          <a:bodyPr wrap="square" anchor="t" lIns="0" rIns="0" tIns="0" bIns="0">
+          <a:bodyPr wrap="square" lIns="0" tIns="0" rIns="0" bIns="0" anchor="t">
             <a:spAutoFit/>
           </a:bodyPr>
           <a:lstStyle/>
@@ -13488,7 +13620,7 @@
           <a:noFill/>
         </p:spPr>
         <p:txBody>
-          <a:bodyPr wrap="square" anchor="t" lIns="0" rIns="0" tIns="0" bIns="0">
+          <a:bodyPr wrap="square" lIns="0" tIns="0" rIns="0" bIns="0" anchor="t">
             <a:spAutoFit/>
           </a:bodyPr>
           <a:lstStyle/>
@@ -13556,6 +13688,7 @@
           <a:lstStyle/>
           <a:p>
             <a:pPr algn="ctr"/>
+            <a:endParaRPr/>
           </a:p>
         </p:txBody>
       </p:sp>
@@ -13576,7 +13709,7 @@
           <a:noFill/>
         </p:spPr>
         <p:txBody>
-          <a:bodyPr wrap="square" anchor="t" lIns="0" rIns="0" tIns="0" bIns="0">
+          <a:bodyPr wrap="square" lIns="0" tIns="0" rIns="0" bIns="0" anchor="t">
             <a:spAutoFit/>
           </a:bodyPr>
           <a:lstStyle/>
@@ -13642,6 +13775,7 @@
           <a:lstStyle/>
           <a:p>
             <a:pPr algn="ctr"/>
+            <a:endParaRPr/>
           </a:p>
         </p:txBody>
       </p:sp>
@@ -13662,7 +13796,7 @@
           <a:noFill/>
         </p:spPr>
         <p:txBody>
-          <a:bodyPr wrap="square" anchor="t" lIns="0" rIns="0" tIns="0" bIns="0">
+          <a:bodyPr wrap="square" lIns="0" tIns="0" rIns="0" bIns="0" anchor="t">
             <a:spAutoFit/>
           </a:bodyPr>
           <a:lstStyle/>
@@ -13704,7 +13838,7 @@
           <a:noFill/>
         </p:spPr>
         <p:txBody>
-          <a:bodyPr wrap="square" anchor="t" lIns="0" rIns="0" tIns="0" bIns="0">
+          <a:bodyPr wrap="square" lIns="0" tIns="0" rIns="0" bIns="0" anchor="t">
             <a:spAutoFit/>
           </a:bodyPr>
           <a:lstStyle/>
@@ -13746,7 +13880,7 @@
           <a:noFill/>
         </p:spPr>
         <p:txBody>
-          <a:bodyPr wrap="square" anchor="t" lIns="0" rIns="0" tIns="0" bIns="0">
+          <a:bodyPr wrap="square" lIns="0" tIns="0" rIns="0" bIns="0" anchor="t">
             <a:spAutoFit/>
           </a:bodyPr>
           <a:lstStyle/>
@@ -13814,6 +13948,7 @@
           <a:lstStyle/>
           <a:p>
             <a:pPr algn="ctr"/>
+            <a:endParaRPr/>
           </a:p>
         </p:txBody>
       </p:sp>
@@ -13834,7 +13969,7 @@
           <a:noFill/>
         </p:spPr>
         <p:txBody>
-          <a:bodyPr wrap="square" anchor="t" lIns="0" rIns="0" tIns="0" bIns="0">
+          <a:bodyPr wrap="square" lIns="0" tIns="0" rIns="0" bIns="0" anchor="t">
             <a:spAutoFit/>
           </a:bodyPr>
           <a:lstStyle/>
@@ -13900,6 +14035,7 @@
           <a:lstStyle/>
           <a:p>
             <a:pPr algn="ctr"/>
+            <a:endParaRPr/>
           </a:p>
         </p:txBody>
       </p:sp>
@@ -13920,7 +14056,7 @@
           <a:noFill/>
         </p:spPr>
         <p:txBody>
-          <a:bodyPr wrap="square" anchor="t" lIns="0" rIns="0" tIns="0" bIns="0">
+          <a:bodyPr wrap="square" lIns="0" tIns="0" rIns="0" bIns="0" anchor="t">
             <a:spAutoFit/>
           </a:bodyPr>
           <a:lstStyle/>
@@ -13962,7 +14098,7 @@
           <a:noFill/>
         </p:spPr>
         <p:txBody>
-          <a:bodyPr wrap="square" anchor="t" lIns="0" rIns="0" tIns="0" bIns="0">
+          <a:bodyPr wrap="square" lIns="0" tIns="0" rIns="0" bIns="0" anchor="t">
             <a:spAutoFit/>
           </a:bodyPr>
           <a:lstStyle/>
@@ -14004,7 +14140,7 @@
           <a:noFill/>
         </p:spPr>
         <p:txBody>
-          <a:bodyPr wrap="square" anchor="t" lIns="0" rIns="0" tIns="0" bIns="0">
+          <a:bodyPr wrap="square" lIns="0" tIns="0" rIns="0" bIns="0" anchor="t">
             <a:spAutoFit/>
           </a:bodyPr>
           <a:lstStyle/>
@@ -14120,7 +14256,7 @@
           <a:noFill/>
         </p:spPr>
         <p:txBody>
-          <a:bodyPr wrap="square" anchor="t" lIns="0" rIns="0" tIns="0" bIns="0">
+          <a:bodyPr wrap="square" lIns="0" tIns="0" rIns="0" bIns="0" anchor="t">
             <a:spAutoFit/>
           </a:bodyPr>
           <a:lstStyle/>
@@ -14183,7 +14319,7 @@
           <a:noFill/>
         </p:spPr>
         <p:txBody>
-          <a:bodyPr wrap="square" anchor="t" lIns="0" rIns="0" tIns="0" bIns="0">
+          <a:bodyPr wrap="square" lIns="0" tIns="0" rIns="0" bIns="0" anchor="t">
             <a:spAutoFit/>
           </a:bodyPr>
           <a:lstStyle/>
@@ -14225,7 +14361,7 @@
           <a:noFill/>
         </p:spPr>
         <p:txBody>
-          <a:bodyPr wrap="square" anchor="t" lIns="0" rIns="0" tIns="0" bIns="0">
+          <a:bodyPr wrap="square" lIns="0" tIns="0" rIns="0" bIns="0" anchor="t">
             <a:spAutoFit/>
           </a:bodyPr>
           <a:lstStyle/>
@@ -14268,7 +14404,7 @@
 </file>
 
 <file path=ppt/slides/slide3.xml><?xml version="1.0" encoding="utf-8"?>
-<p:sld xmlns:a="http://schemas.openxmlformats.org/drawingml/2006/main" xmlns:p="http://schemas.openxmlformats.org/presentationml/2006/main" xmlns:r="http://schemas.openxmlformats.org/officeDocument/2006/relationships">
+<p:sld xmlns:a="http://schemas.openxmlformats.org/drawingml/2006/main" xmlns:r="http://schemas.openxmlformats.org/officeDocument/2006/relationships" xmlns:p="http://schemas.openxmlformats.org/presentationml/2006/main">
   <p:cSld>
     <p:bg>
       <p:bgPr>
@@ -14284,7 +14420,14 @@
         <p:cNvGrpSpPr/>
         <p:nvPr/>
       </p:nvGrpSpPr>
-      <p:grpSpPr/>
+      <p:grpSpPr>
+        <a:xfrm>
+          <a:off x="0" y="0"/>
+          <a:ext cx="0" cy="0"/>
+          <a:chOff x="0" y="0"/>
+          <a:chExt cx="0" cy="0"/>
+        </a:xfrm>
+      </p:grpSpPr>
       <p:sp>
         <p:nvSpPr>
           <p:cNvPr id="2" name="Rectangle 1"/>
@@ -14326,6 +14469,7 @@
           <a:lstStyle/>
           <a:p>
             <a:pPr algn="ctr"/>
+            <a:endParaRPr/>
           </a:p>
         </p:txBody>
       </p:sp>
@@ -14370,6 +14514,7 @@
           <a:lstStyle/>
           <a:p>
             <a:pPr algn="ctr"/>
+            <a:endParaRPr/>
           </a:p>
         </p:txBody>
       </p:sp>
@@ -14390,7 +14535,7 @@
           <a:noFill/>
         </p:spPr>
         <p:txBody>
-          <a:bodyPr wrap="square" anchor="t" lIns="0" rIns="0" tIns="0" bIns="0">
+          <a:bodyPr wrap="square" lIns="0" tIns="0" rIns="0" bIns="0" anchor="t">
             <a:spAutoFit/>
           </a:bodyPr>
           <a:lstStyle/>
@@ -14471,7 +14616,7 @@
           <a:noFill/>
         </p:spPr>
         <p:txBody>
-          <a:bodyPr wrap="square" anchor="t" lIns="0" rIns="0" tIns="0" bIns="0">
+          <a:bodyPr wrap="square" lIns="0" tIns="0" rIns="0" bIns="0" anchor="t">
             <a:spAutoFit/>
           </a:bodyPr>
           <a:lstStyle/>
@@ -14537,6 +14682,7 @@
           <a:lstStyle/>
           <a:p>
             <a:pPr algn="ctr"/>
+            <a:endParaRPr/>
           </a:p>
         </p:txBody>
       </p:sp>
@@ -14557,7 +14703,7 @@
           <a:noFill/>
         </p:spPr>
         <p:txBody>
-          <a:bodyPr wrap="square" anchor="t" lIns="0" rIns="0" tIns="0" bIns="0">
+          <a:bodyPr wrap="square" lIns="0" tIns="0" rIns="0" bIns="0" anchor="t">
             <a:spAutoFit/>
           </a:bodyPr>
           <a:lstStyle/>
@@ -14570,15 +14716,7 @@
                 <a:spcPts val="400"/>
               </a:spcAft>
             </a:pPr>
-            <a:r>
-              <a:rPr sz="1100" b="1">
-                <a:solidFill>
-                  <a:srgbClr val="FFFFFF"/>
-                </a:solidFill>
-                <a:latin typeface="DejaVu Sans Mono"/>
-              </a:rPr>
-              <a:t/>
-            </a:r>
+            <a:endParaRPr/>
           </a:p>
         </p:txBody>
       </p:sp>
@@ -14599,7 +14737,7 @@
           <a:noFill/>
         </p:spPr>
         <p:txBody>
-          <a:bodyPr wrap="square" anchor="t" lIns="0" rIns="0" tIns="0" bIns="0">
+          <a:bodyPr wrap="square" lIns="0" tIns="0" rIns="0" bIns="0" anchor="t">
             <a:spAutoFit/>
           </a:bodyPr>
           <a:lstStyle/>
@@ -14641,7 +14779,7 @@
           <a:noFill/>
         </p:spPr>
         <p:txBody>
-          <a:bodyPr wrap="square" anchor="t" lIns="0" rIns="0" tIns="0" bIns="0">
+          <a:bodyPr wrap="square" lIns="0" tIns="0" rIns="0" bIns="0" anchor="t">
             <a:spAutoFit/>
           </a:bodyPr>
           <a:lstStyle/>
@@ -14707,6 +14845,7 @@
           <a:lstStyle/>
           <a:p>
             <a:pPr algn="ctr"/>
+            <a:endParaRPr/>
           </a:p>
         </p:txBody>
       </p:sp>
@@ -14727,7 +14866,7 @@
           <a:noFill/>
         </p:spPr>
         <p:txBody>
-          <a:bodyPr wrap="square" anchor="t" lIns="0" rIns="0" tIns="0" bIns="0">
+          <a:bodyPr wrap="square" lIns="0" tIns="0" rIns="0" bIns="0" anchor="t">
             <a:spAutoFit/>
           </a:bodyPr>
           <a:lstStyle/>
@@ -14769,7 +14908,7 @@
           <a:noFill/>
         </p:spPr>
         <p:txBody>
-          <a:bodyPr wrap="square" anchor="t" lIns="0" rIns="0" tIns="0" bIns="0">
+          <a:bodyPr wrap="square" lIns="0" tIns="0" rIns="0" bIns="0" anchor="t">
             <a:spAutoFit/>
           </a:bodyPr>
           <a:lstStyle/>
@@ -14811,7 +14950,7 @@
           <a:noFill/>
         </p:spPr>
         <p:txBody>
-          <a:bodyPr wrap="square" anchor="t" lIns="0" rIns="0" tIns="0" bIns="0">
+          <a:bodyPr wrap="square" lIns="0" tIns="0" rIns="0" bIns="0" anchor="t">
             <a:spAutoFit/>
           </a:bodyPr>
           <a:lstStyle/>
@@ -14877,6 +15016,7 @@
           <a:lstStyle/>
           <a:p>
             <a:pPr algn="ctr"/>
+            <a:endParaRPr/>
           </a:p>
         </p:txBody>
       </p:sp>
@@ -14921,6 +15061,7 @@
           <a:lstStyle/>
           <a:p>
             <a:pPr algn="ctr"/>
+            <a:endParaRPr/>
           </a:p>
         </p:txBody>
       </p:sp>
@@ -14941,7 +15082,7 @@
           <a:noFill/>
         </p:spPr>
         <p:txBody>
-          <a:bodyPr wrap="square" anchor="t" lIns="0" rIns="0" tIns="0" bIns="0">
+          <a:bodyPr wrap="square" lIns="0" tIns="0" rIns="0" bIns="0" anchor="t">
             <a:spAutoFit/>
           </a:bodyPr>
           <a:lstStyle/>
@@ -14983,7 +15124,7 @@
           <a:noFill/>
         </p:spPr>
         <p:txBody>
-          <a:bodyPr wrap="square" anchor="t" lIns="0" rIns="0" tIns="0" bIns="0">
+          <a:bodyPr wrap="square" lIns="0" tIns="0" rIns="0" bIns="0" anchor="t">
             <a:spAutoFit/>
           </a:bodyPr>
           <a:lstStyle/>
@@ -15025,7 +15166,7 @@
           <a:noFill/>
         </p:spPr>
         <p:txBody>
-          <a:bodyPr wrap="square" anchor="t" lIns="0" rIns="0" tIns="0" bIns="0">
+          <a:bodyPr wrap="square" lIns="0" tIns="0" rIns="0" bIns="0" anchor="t">
             <a:spAutoFit/>
           </a:bodyPr>
           <a:lstStyle/>
@@ -15067,7 +15208,7 @@
           <a:noFill/>
         </p:spPr>
         <p:txBody>
-          <a:bodyPr wrap="square" anchor="t" lIns="0" rIns="0" tIns="0" bIns="0">
+          <a:bodyPr wrap="square" lIns="0" tIns="0" rIns="0" bIns="0" anchor="t">
             <a:spAutoFit/>
           </a:bodyPr>
           <a:lstStyle/>
@@ -15148,7 +15289,7 @@
           <a:noFill/>
         </p:spPr>
         <p:txBody>
-          <a:bodyPr wrap="square" anchor="t" lIns="0" rIns="0" tIns="0" bIns="0">
+          <a:bodyPr wrap="square" lIns="0" tIns="0" rIns="0" bIns="0" anchor="t">
             <a:spAutoFit/>
           </a:bodyPr>
           <a:lstStyle/>
@@ -15190,7 +15331,7 @@
           <a:noFill/>
         </p:spPr>
         <p:txBody>
-          <a:bodyPr wrap="square" anchor="t" lIns="0" rIns="0" tIns="0" bIns="0">
+          <a:bodyPr wrap="square" lIns="0" tIns="0" rIns="0" bIns="0" anchor="t">
             <a:spAutoFit/>
           </a:bodyPr>
           <a:lstStyle/>
@@ -15233,7 +15374,7 @@
 </file>
 
 <file path=ppt/slides/slide4.xml><?xml version="1.0" encoding="utf-8"?>
-<p:sld xmlns:a="http://schemas.openxmlformats.org/drawingml/2006/main" xmlns:p="http://schemas.openxmlformats.org/presentationml/2006/main" xmlns:r="http://schemas.openxmlformats.org/officeDocument/2006/relationships">
+<p:sld xmlns:a="http://schemas.openxmlformats.org/drawingml/2006/main" xmlns:r="http://schemas.openxmlformats.org/officeDocument/2006/relationships" xmlns:p="http://schemas.openxmlformats.org/presentationml/2006/main">
   <p:cSld>
     <p:bg>
       <p:bgPr>
@@ -15249,7 +15390,14 @@
         <p:cNvGrpSpPr/>
         <p:nvPr/>
       </p:nvGrpSpPr>
-      <p:grpSpPr/>
+      <p:grpSpPr>
+        <a:xfrm>
+          <a:off x="0" y="0"/>
+          <a:ext cx="0" cy="0"/>
+          <a:chOff x="0" y="0"/>
+          <a:chExt cx="0" cy="0"/>
+        </a:xfrm>
+      </p:grpSpPr>
       <p:sp>
         <p:nvSpPr>
           <p:cNvPr id="2" name="Rectangle 1"/>
@@ -15291,6 +15439,7 @@
           <a:lstStyle/>
           <a:p>
             <a:pPr algn="ctr"/>
+            <a:endParaRPr/>
           </a:p>
         </p:txBody>
       </p:sp>
@@ -15335,6 +15484,7 @@
           <a:lstStyle/>
           <a:p>
             <a:pPr algn="ctr"/>
+            <a:endParaRPr/>
           </a:p>
         </p:txBody>
       </p:sp>
@@ -15355,7 +15505,7 @@
           <a:noFill/>
         </p:spPr>
         <p:txBody>
-          <a:bodyPr wrap="square" anchor="t" lIns="0" rIns="0" tIns="0" bIns="0">
+          <a:bodyPr wrap="square" lIns="0" tIns="0" rIns="0" bIns="0" anchor="t">
             <a:spAutoFit/>
           </a:bodyPr>
           <a:lstStyle/>
@@ -15517,6 +15667,7 @@
           <a:lstStyle/>
           <a:p>
             <a:pPr algn="ctr"/>
+            <a:endParaRPr/>
           </a:p>
         </p:txBody>
       </p:sp>
@@ -15537,7 +15688,7 @@
           <a:noFill/>
         </p:spPr>
         <p:txBody>
-          <a:bodyPr wrap="square" anchor="t" lIns="0" rIns="0" tIns="0" bIns="0">
+          <a:bodyPr wrap="square" lIns="0" tIns="0" rIns="0" bIns="0" anchor="t">
             <a:spAutoFit/>
           </a:bodyPr>
           <a:lstStyle/>
@@ -15579,7 +15730,7 @@
           <a:noFill/>
         </p:spPr>
         <p:txBody>
-          <a:bodyPr wrap="square" anchor="t" lIns="0" rIns="0" tIns="0" bIns="0">
+          <a:bodyPr wrap="square" lIns="0" tIns="0" rIns="0" bIns="0" anchor="t">
             <a:spAutoFit/>
           </a:bodyPr>
           <a:lstStyle/>
@@ -15648,6 +15799,7 @@
           <a:lstStyle/>
           <a:p>
             <a:pPr algn="ctr"/>
+            <a:endParaRPr/>
           </a:p>
         </p:txBody>
       </p:sp>
@@ -15668,7 +15820,7 @@
           <a:noFill/>
         </p:spPr>
         <p:txBody>
-          <a:bodyPr wrap="square" anchor="t" lIns="0" rIns="0" tIns="0" bIns="0">
+          <a:bodyPr wrap="square" lIns="0" tIns="0" rIns="0" bIns="0" anchor="t">
             <a:spAutoFit/>
           </a:bodyPr>
           <a:lstStyle/>
@@ -15710,7 +15862,7 @@
           <a:noFill/>
         </p:spPr>
         <p:txBody>
-          <a:bodyPr wrap="square" anchor="t" lIns="0" rIns="0" tIns="0" bIns="0">
+          <a:bodyPr wrap="square" lIns="0" tIns="0" rIns="0" bIns="0" anchor="t">
             <a:spAutoFit/>
           </a:bodyPr>
           <a:lstStyle/>
@@ -15779,6 +15931,7 @@
           <a:lstStyle/>
           <a:p>
             <a:pPr algn="ctr"/>
+            <a:endParaRPr/>
           </a:p>
         </p:txBody>
       </p:sp>
@@ -15799,7 +15952,7 @@
           <a:noFill/>
         </p:spPr>
         <p:txBody>
-          <a:bodyPr wrap="square" anchor="t" lIns="0" rIns="0" tIns="0" bIns="0">
+          <a:bodyPr wrap="square" lIns="0" tIns="0" rIns="0" bIns="0" anchor="t">
             <a:spAutoFit/>
           </a:bodyPr>
           <a:lstStyle/>
@@ -15841,7 +15994,7 @@
           <a:noFill/>
         </p:spPr>
         <p:txBody>
-          <a:bodyPr wrap="square" anchor="t" lIns="0" rIns="0" tIns="0" bIns="0">
+          <a:bodyPr wrap="square" lIns="0" tIns="0" rIns="0" bIns="0" anchor="t">
             <a:spAutoFit/>
           </a:bodyPr>
           <a:lstStyle/>
@@ -15886,7 +16039,7 @@
           <a:noFill/>
         </p:spPr>
         <p:txBody>
-          <a:bodyPr wrap="square" anchor="t" lIns="0" rIns="0" tIns="0" bIns="0">
+          <a:bodyPr wrap="square" lIns="0" tIns="0" rIns="0" bIns="0" anchor="t">
             <a:spAutoFit/>
           </a:bodyPr>
           <a:lstStyle/>
@@ -15973,6 +16126,7 @@
           <a:lstStyle/>
           <a:p>
             <a:pPr algn="ctr"/>
+            <a:endParaRPr/>
           </a:p>
         </p:txBody>
       </p:sp>
@@ -16017,6 +16171,7 @@
           <a:lstStyle/>
           <a:p>
             <a:pPr algn="ctr"/>
+            <a:endParaRPr/>
           </a:p>
         </p:txBody>
       </p:sp>
@@ -16200,15 +16355,12 @@
                 <a:spcPts val="200"/>
               </a:spcAft>
             </a:pPr>
-            <a:r>
-              <a:rPr sz="1250" b="0">
-                <a:solidFill>
-                  <a:srgbClr val="36454F"/>
-                </a:solidFill>
-                <a:latin typeface="DejaVu Sans Mono"/>
-              </a:rPr>
-              <a:t/>
-            </a:r>
+            <a:endParaRPr sz="1250" b="0">
+              <a:solidFill>
+                <a:srgbClr val="36454F"/>
+              </a:solidFill>
+              <a:latin typeface="DejaVu Sans Mono"/>
+            </a:endParaRPr>
           </a:p>
           <a:p>
             <a:pPr>
@@ -16267,7 +16419,7 @@
           <a:noFill/>
         </p:spPr>
         <p:txBody>
-          <a:bodyPr wrap="square" anchor="t" lIns="0" rIns="0" tIns="0" bIns="0">
+          <a:bodyPr wrap="square" lIns="0" tIns="0" rIns="0" bIns="0" anchor="t">
             <a:spAutoFit/>
           </a:bodyPr>
           <a:lstStyle/>
@@ -16309,7 +16461,7 @@
           <a:noFill/>
         </p:spPr>
         <p:txBody>
-          <a:bodyPr wrap="square" anchor="t" lIns="0" rIns="0" tIns="0" bIns="0">
+          <a:bodyPr wrap="square" lIns="0" tIns="0" rIns="0" bIns="0" anchor="t">
             <a:spAutoFit/>
           </a:bodyPr>
           <a:lstStyle/>
@@ -16352,7 +16504,7 @@
 </file>
 
 <file path=ppt/slides/slide5.xml><?xml version="1.0" encoding="utf-8"?>
-<p:sld xmlns:a="http://schemas.openxmlformats.org/drawingml/2006/main" xmlns:p="http://schemas.openxmlformats.org/presentationml/2006/main" xmlns:r="http://schemas.openxmlformats.org/officeDocument/2006/relationships">
+<p:sld xmlns:a="http://schemas.openxmlformats.org/drawingml/2006/main" xmlns:r="http://schemas.openxmlformats.org/officeDocument/2006/relationships" xmlns:p="http://schemas.openxmlformats.org/presentationml/2006/main">
   <p:cSld>
     <p:bg>
       <p:bgPr>
@@ -16368,7 +16520,14 @@
         <p:cNvGrpSpPr/>
         <p:nvPr/>
       </p:nvGrpSpPr>
-      <p:grpSpPr/>
+      <p:grpSpPr>
+        <a:xfrm>
+          <a:off x="0" y="0"/>
+          <a:ext cx="0" cy="0"/>
+          <a:chOff x="0" y="0"/>
+          <a:chExt cx="0" cy="0"/>
+        </a:xfrm>
+      </p:grpSpPr>
       <p:sp>
         <p:nvSpPr>
           <p:cNvPr id="2" name="Rectangle 1"/>
@@ -16410,6 +16569,7 @@
           <a:lstStyle/>
           <a:p>
             <a:pPr algn="ctr"/>
+            <a:endParaRPr/>
           </a:p>
         </p:txBody>
       </p:sp>
@@ -16454,6 +16614,7 @@
           <a:lstStyle/>
           <a:p>
             <a:pPr algn="ctr"/>
+            <a:endParaRPr/>
           </a:p>
         </p:txBody>
       </p:sp>
@@ -16474,7 +16635,7 @@
           <a:noFill/>
         </p:spPr>
         <p:txBody>
-          <a:bodyPr wrap="square" anchor="t" lIns="0" rIns="0" tIns="0" bIns="0">
+          <a:bodyPr wrap="square" lIns="0" tIns="0" rIns="0" bIns="0" anchor="t">
             <a:spAutoFit/>
           </a:bodyPr>
           <a:lstStyle/>
@@ -16581,6 +16742,7 @@
           <a:lstStyle/>
           <a:p>
             <a:pPr algn="ctr"/>
+            <a:endParaRPr/>
           </a:p>
         </p:txBody>
       </p:sp>
@@ -16601,7 +16763,7 @@
           <a:noFill/>
         </p:spPr>
         <p:txBody>
-          <a:bodyPr wrap="square" anchor="t" lIns="0" rIns="0" tIns="0" bIns="0">
+          <a:bodyPr wrap="square" lIns="0" tIns="0" rIns="0" bIns="0" anchor="t">
             <a:spAutoFit/>
           </a:bodyPr>
           <a:lstStyle/>
@@ -16667,6 +16829,7 @@
           <a:lstStyle/>
           <a:p>
             <a:pPr algn="ctr"/>
+            <a:endParaRPr/>
           </a:p>
         </p:txBody>
       </p:sp>
@@ -16687,7 +16850,7 @@
           <a:noFill/>
         </p:spPr>
         <p:txBody>
-          <a:bodyPr wrap="square" anchor="t" lIns="0" rIns="0" tIns="0" bIns="0">
+          <a:bodyPr wrap="square" lIns="0" tIns="0" rIns="0" bIns="0" anchor="t">
             <a:spAutoFit/>
           </a:bodyPr>
           <a:lstStyle/>
@@ -16753,6 +16916,7 @@
           <a:lstStyle/>
           <a:p>
             <a:pPr algn="ctr"/>
+            <a:endParaRPr/>
           </a:p>
         </p:txBody>
       </p:sp>
@@ -16773,7 +16937,7 @@
           <a:noFill/>
         </p:spPr>
         <p:txBody>
-          <a:bodyPr wrap="square" anchor="t" lIns="0" rIns="0" tIns="0" bIns="0">
+          <a:bodyPr wrap="square" lIns="0" tIns="0" rIns="0" bIns="0" anchor="t">
             <a:spAutoFit/>
           </a:bodyPr>
           <a:lstStyle/>
@@ -16839,6 +17003,7 @@
           <a:lstStyle/>
           <a:p>
             <a:pPr algn="ctr"/>
+            <a:endParaRPr/>
           </a:p>
         </p:txBody>
       </p:sp>
@@ -16859,7 +17024,7 @@
           <a:noFill/>
         </p:spPr>
         <p:txBody>
-          <a:bodyPr wrap="square" anchor="t" lIns="0" rIns="0" tIns="0" bIns="0">
+          <a:bodyPr wrap="square" lIns="0" tIns="0" rIns="0" bIns="0" anchor="t">
             <a:spAutoFit/>
           </a:bodyPr>
           <a:lstStyle/>
@@ -16925,6 +17090,7 @@
           <a:lstStyle/>
           <a:p>
             <a:pPr algn="ctr"/>
+            <a:endParaRPr/>
           </a:p>
         </p:txBody>
       </p:sp>
@@ -16945,7 +17111,7 @@
           <a:noFill/>
         </p:spPr>
         <p:txBody>
-          <a:bodyPr wrap="square" anchor="t" lIns="0" rIns="0" tIns="0" bIns="0">
+          <a:bodyPr wrap="square" lIns="0" tIns="0" rIns="0" bIns="0" anchor="t">
             <a:spAutoFit/>
           </a:bodyPr>
           <a:lstStyle/>
@@ -17013,6 +17179,7 @@
           <a:lstStyle/>
           <a:p>
             <a:pPr algn="ctr"/>
+            <a:endParaRPr/>
           </a:p>
         </p:txBody>
       </p:sp>
@@ -17057,6 +17224,7 @@
           <a:lstStyle/>
           <a:p>
             <a:pPr algn="ctr"/>
+            <a:endParaRPr/>
           </a:p>
         </p:txBody>
       </p:sp>
@@ -17077,7 +17245,7 @@
           <a:noFill/>
         </p:spPr>
         <p:txBody>
-          <a:bodyPr wrap="square" anchor="t" lIns="0" rIns="0" tIns="0" bIns="0">
+          <a:bodyPr wrap="square" lIns="0" tIns="0" rIns="0" bIns="0" anchor="t">
             <a:spAutoFit/>
           </a:bodyPr>
           <a:lstStyle/>
@@ -17143,6 +17311,7 @@
           <a:lstStyle/>
           <a:p>
             <a:pPr algn="ctr"/>
+            <a:endParaRPr/>
           </a:p>
         </p:txBody>
       </p:sp>
@@ -17163,7 +17332,7 @@
           <a:noFill/>
         </p:spPr>
         <p:txBody>
-          <a:bodyPr wrap="square" anchor="t" lIns="0" rIns="0" tIns="0" bIns="0">
+          <a:bodyPr wrap="square" lIns="0" tIns="0" rIns="0" bIns="0" anchor="t">
             <a:spAutoFit/>
           </a:bodyPr>
           <a:lstStyle/>
@@ -17229,6 +17398,7 @@
           <a:lstStyle/>
           <a:p>
             <a:pPr algn="ctr"/>
+            <a:endParaRPr/>
           </a:p>
         </p:txBody>
       </p:sp>
@@ -17249,7 +17419,7 @@
           <a:noFill/>
         </p:spPr>
         <p:txBody>
-          <a:bodyPr wrap="square" anchor="t" lIns="0" rIns="0" tIns="0" bIns="0">
+          <a:bodyPr wrap="square" lIns="0" tIns="0" rIns="0" bIns="0" anchor="t">
             <a:spAutoFit/>
           </a:bodyPr>
           <a:lstStyle/>
@@ -17315,6 +17485,7 @@
           <a:lstStyle/>
           <a:p>
             <a:pPr algn="ctr"/>
+            <a:endParaRPr/>
           </a:p>
         </p:txBody>
       </p:sp>
@@ -17335,7 +17506,7 @@
           <a:noFill/>
         </p:spPr>
         <p:txBody>
-          <a:bodyPr wrap="square" anchor="t" lIns="0" rIns="0" tIns="0" bIns="0">
+          <a:bodyPr wrap="square" lIns="0" tIns="0" rIns="0" bIns="0" anchor="t">
             <a:spAutoFit/>
           </a:bodyPr>
           <a:lstStyle/>
@@ -17401,6 +17572,7 @@
           <a:lstStyle/>
           <a:p>
             <a:pPr algn="ctr"/>
+            <a:endParaRPr/>
           </a:p>
         </p:txBody>
       </p:sp>
@@ -17421,7 +17593,7 @@
           <a:noFill/>
         </p:spPr>
         <p:txBody>
-          <a:bodyPr wrap="square" anchor="t" lIns="0" rIns="0" tIns="0" bIns="0">
+          <a:bodyPr wrap="square" lIns="0" tIns="0" rIns="0" bIns="0" anchor="t">
             <a:spAutoFit/>
           </a:bodyPr>
           <a:lstStyle/>
@@ -17463,7 +17635,7 @@
           <a:noFill/>
         </p:spPr>
         <p:txBody>
-          <a:bodyPr wrap="square" anchor="t" lIns="0" rIns="0" tIns="0" bIns="0">
+          <a:bodyPr wrap="square" lIns="0" tIns="0" rIns="0" bIns="0" anchor="t">
             <a:spAutoFit/>
           </a:bodyPr>
           <a:lstStyle/>
@@ -17523,7 +17695,7 @@
           <a:noFill/>
         </p:spPr>
         <p:txBody>
-          <a:bodyPr wrap="square" anchor="t" lIns="0" rIns="0" tIns="0" bIns="0">
+          <a:bodyPr wrap="square" lIns="0" tIns="0" rIns="0" bIns="0" anchor="t">
             <a:spAutoFit/>
           </a:bodyPr>
           <a:lstStyle/>
@@ -17565,7 +17737,7 @@
           <a:noFill/>
         </p:spPr>
         <p:txBody>
-          <a:bodyPr wrap="square" anchor="t" lIns="0" rIns="0" tIns="0" bIns="0">
+          <a:bodyPr wrap="square" lIns="0" tIns="0" rIns="0" bIns="0" anchor="t">
             <a:spAutoFit/>
           </a:bodyPr>
           <a:lstStyle/>
@@ -17608,7 +17780,7 @@
 </file>
 
 <file path=ppt/slides/slide6.xml><?xml version="1.0" encoding="utf-8"?>
-<p:sld xmlns:a="http://schemas.openxmlformats.org/drawingml/2006/main" xmlns:p="http://schemas.openxmlformats.org/presentationml/2006/main" xmlns:r="http://schemas.openxmlformats.org/officeDocument/2006/relationships">
+<p:sld xmlns:a="http://schemas.openxmlformats.org/drawingml/2006/main" xmlns:r="http://schemas.openxmlformats.org/officeDocument/2006/relationships" xmlns:p="http://schemas.openxmlformats.org/presentationml/2006/main">
   <p:cSld>
     <p:bg>
       <p:bgPr>
@@ -17624,7 +17796,14 @@
         <p:cNvGrpSpPr/>
         <p:nvPr/>
       </p:nvGrpSpPr>
-      <p:grpSpPr/>
+      <p:grpSpPr>
+        <a:xfrm>
+          <a:off x="0" y="0"/>
+          <a:ext cx="0" cy="0"/>
+          <a:chOff x="0" y="0"/>
+          <a:chExt cx="0" cy="0"/>
+        </a:xfrm>
+      </p:grpSpPr>
       <p:sp>
         <p:nvSpPr>
           <p:cNvPr id="2" name="Rectangle 1"/>
@@ -17666,6 +17845,7 @@
           <a:lstStyle/>
           <a:p>
             <a:pPr algn="ctr"/>
+            <a:endParaRPr/>
           </a:p>
         </p:txBody>
       </p:sp>
@@ -17710,6 +17890,7 @@
           <a:lstStyle/>
           <a:p>
             <a:pPr algn="ctr"/>
+            <a:endParaRPr/>
           </a:p>
         </p:txBody>
       </p:sp>
@@ -17730,7 +17911,7 @@
           <a:noFill/>
         </p:spPr>
         <p:txBody>
-          <a:bodyPr wrap="square" anchor="t" lIns="0" rIns="0" tIns="0" bIns="0">
+          <a:bodyPr wrap="square" lIns="0" tIns="0" rIns="0" bIns="0" anchor="t">
             <a:spAutoFit/>
           </a:bodyPr>
           <a:lstStyle/>
@@ -17853,6 +18034,7 @@
           <a:lstStyle/>
           <a:p>
             <a:pPr algn="ctr"/>
+            <a:endParaRPr/>
           </a:p>
         </p:txBody>
       </p:sp>
@@ -17897,6 +18079,7 @@
           <a:lstStyle/>
           <a:p>
             <a:pPr algn="ctr"/>
+            <a:endParaRPr/>
           </a:p>
         </p:txBody>
       </p:sp>
@@ -18071,7 +18254,7 @@
           <a:noFill/>
         </p:spPr>
         <p:txBody>
-          <a:bodyPr wrap="square" anchor="t" lIns="0" rIns="0" tIns="0" bIns="0">
+          <a:bodyPr wrap="square" lIns="0" tIns="0" rIns="0" bIns="0" anchor="t">
             <a:spAutoFit/>
           </a:bodyPr>
           <a:lstStyle/>
@@ -18143,7 +18326,7 @@
           <a:noFill/>
         </p:spPr>
         <p:txBody>
-          <a:bodyPr wrap="square" anchor="t" lIns="0" rIns="0" tIns="0" bIns="0">
+          <a:bodyPr wrap="square" lIns="0" tIns="0" rIns="0" bIns="0" anchor="t">
             <a:spAutoFit/>
           </a:bodyPr>
           <a:lstStyle/>
@@ -18209,6 +18392,7 @@
           <a:lstStyle/>
           <a:p>
             <a:pPr algn="ctr"/>
+            <a:endParaRPr/>
           </a:p>
         </p:txBody>
       </p:sp>
@@ -18253,6 +18437,7 @@
           <a:lstStyle/>
           <a:p>
             <a:pPr algn="ctr"/>
+            <a:endParaRPr/>
           </a:p>
         </p:txBody>
       </p:sp>
@@ -18484,7 +18669,7 @@
           <a:noFill/>
         </p:spPr>
         <p:txBody>
-          <a:bodyPr wrap="square" anchor="t" lIns="0" rIns="0" tIns="0" bIns="0">
+          <a:bodyPr wrap="square" lIns="0" tIns="0" rIns="0" bIns="0" anchor="t">
             <a:spAutoFit/>
           </a:bodyPr>
           <a:lstStyle/>
@@ -18538,7 +18723,7 @@
           <a:noFill/>
         </p:spPr>
         <p:txBody>
-          <a:bodyPr wrap="square" anchor="t" lIns="0" rIns="0" tIns="0" bIns="0">
+          <a:bodyPr wrap="square" lIns="0" tIns="0" rIns="0" bIns="0" anchor="t">
             <a:spAutoFit/>
           </a:bodyPr>
           <a:lstStyle/>
@@ -18580,7 +18765,7 @@
           <a:noFill/>
         </p:spPr>
         <p:txBody>
-          <a:bodyPr wrap="square" anchor="t" lIns="0" rIns="0" tIns="0" bIns="0">
+          <a:bodyPr wrap="square" lIns="0" tIns="0" rIns="0" bIns="0" anchor="t">
             <a:spAutoFit/>
           </a:bodyPr>
           <a:lstStyle/>
@@ -18623,7 +18808,7 @@
 </file>
 
 <file path=ppt/slides/slide7.xml><?xml version="1.0" encoding="utf-8"?>
-<p:sld xmlns:a="http://schemas.openxmlformats.org/drawingml/2006/main" xmlns:p="http://schemas.openxmlformats.org/presentationml/2006/main" xmlns:r="http://schemas.openxmlformats.org/officeDocument/2006/relationships">
+<p:sld xmlns:a="http://schemas.openxmlformats.org/drawingml/2006/main" xmlns:r="http://schemas.openxmlformats.org/officeDocument/2006/relationships" xmlns:p="http://schemas.openxmlformats.org/presentationml/2006/main">
   <p:cSld>
     <p:bg>
       <p:bgPr>
@@ -18639,7 +18824,14 @@
         <p:cNvGrpSpPr/>
         <p:nvPr/>
       </p:nvGrpSpPr>
-      <p:grpSpPr/>
+      <p:grpSpPr>
+        <a:xfrm>
+          <a:off x="0" y="0"/>
+          <a:ext cx="0" cy="0"/>
+          <a:chOff x="0" y="0"/>
+          <a:chExt cx="0" cy="0"/>
+        </a:xfrm>
+      </p:grpSpPr>
       <p:sp>
         <p:nvSpPr>
           <p:cNvPr id="2" name="Rectangle 1"/>
@@ -18681,6 +18873,7 @@
           <a:lstStyle/>
           <a:p>
             <a:pPr algn="ctr"/>
+            <a:endParaRPr/>
           </a:p>
         </p:txBody>
       </p:sp>
@@ -18725,6 +18918,7 @@
           <a:lstStyle/>
           <a:p>
             <a:pPr algn="ctr"/>
+            <a:endParaRPr/>
           </a:p>
         </p:txBody>
       </p:sp>
@@ -18745,7 +18939,7 @@
           <a:noFill/>
         </p:spPr>
         <p:txBody>
-          <a:bodyPr wrap="square" anchor="t" lIns="0" rIns="0" tIns="0" bIns="0">
+          <a:bodyPr wrap="square" lIns="0" tIns="0" rIns="0" bIns="0" anchor="t">
             <a:spAutoFit/>
           </a:bodyPr>
           <a:lstStyle/>
@@ -18852,6 +19046,7 @@
           <a:lstStyle/>
           <a:p>
             <a:pPr algn="ctr"/>
+            <a:endParaRPr/>
           </a:p>
         </p:txBody>
       </p:sp>
@@ -18872,7 +19067,7 @@
           <a:noFill/>
         </p:spPr>
         <p:txBody>
-          <a:bodyPr wrap="square" anchor="t" lIns="0" rIns="0" tIns="0" bIns="0">
+          <a:bodyPr wrap="square" lIns="0" tIns="0" rIns="0" bIns="0" anchor="t">
             <a:spAutoFit/>
           </a:bodyPr>
           <a:lstStyle/>
@@ -18959,6 +19154,7 @@
           <a:lstStyle/>
           <a:p>
             <a:pPr algn="ctr"/>
+            <a:endParaRPr/>
           </a:p>
         </p:txBody>
       </p:sp>
@@ -18979,7 +19175,7 @@
           <a:noFill/>
         </p:spPr>
         <p:txBody>
-          <a:bodyPr wrap="square" anchor="t" lIns="0" rIns="0" tIns="0" bIns="0">
+          <a:bodyPr wrap="square" lIns="0" tIns="0" rIns="0" bIns="0" anchor="t">
             <a:spAutoFit/>
           </a:bodyPr>
           <a:lstStyle/>
@@ -19066,6 +19262,7 @@
           <a:lstStyle/>
           <a:p>
             <a:pPr algn="ctr"/>
+            <a:endParaRPr/>
           </a:p>
         </p:txBody>
       </p:sp>
@@ -19086,7 +19283,7 @@
           <a:noFill/>
         </p:spPr>
         <p:txBody>
-          <a:bodyPr wrap="square" anchor="t" lIns="0" rIns="0" tIns="0" bIns="0">
+          <a:bodyPr wrap="square" lIns="0" tIns="0" rIns="0" bIns="0" anchor="t">
             <a:spAutoFit/>
           </a:bodyPr>
           <a:lstStyle/>
@@ -19173,6 +19370,7 @@
           <a:lstStyle/>
           <a:p>
             <a:pPr algn="ctr"/>
+            <a:endParaRPr/>
           </a:p>
         </p:txBody>
       </p:sp>
@@ -19193,7 +19391,7 @@
           <a:noFill/>
         </p:spPr>
         <p:txBody>
-          <a:bodyPr wrap="square" anchor="t" lIns="0" rIns="0" tIns="0" bIns="0">
+          <a:bodyPr wrap="square" lIns="0" tIns="0" rIns="0" bIns="0" anchor="t">
             <a:spAutoFit/>
           </a:bodyPr>
           <a:lstStyle/>
@@ -19291,7 +19489,7 @@
           <a:noFill/>
         </p:spPr>
         <p:txBody>
-          <a:bodyPr wrap="square" anchor="t" lIns="0" rIns="0" tIns="0" bIns="0">
+          <a:bodyPr wrap="square" lIns="0" tIns="0" rIns="0" bIns="0" anchor="t">
             <a:spAutoFit/>
           </a:bodyPr>
           <a:lstStyle/>
@@ -19398,7 +19596,7 @@
         </p:nvSpPr>
         <p:spPr>
           <a:xfrm>
-            <a:off x="7589520" y="2377440"/>
+            <a:off x="7438644" y="2240280"/>
             <a:ext cx="1371600" cy="274320"/>
           </a:xfrm>
           <a:prstGeom prst="rect">
@@ -19407,7 +19605,7 @@
           <a:noFill/>
         </p:spPr>
         <p:txBody>
-          <a:bodyPr wrap="square" anchor="t" lIns="0" rIns="0" tIns="0" bIns="0">
+          <a:bodyPr wrap="square" lIns="0" tIns="0" rIns="0" bIns="0" anchor="t">
             <a:spAutoFit/>
           </a:bodyPr>
           <a:lstStyle/>
@@ -19421,7 +19619,7 @@
               </a:spcAft>
             </a:pPr>
             <a:r>
-              <a:rPr sz="800" b="0">
+              <a:rPr sz="800" b="0" dirty="0">
                 <a:solidFill>
                   <a:srgbClr val="6C7B88"/>
                 </a:solidFill>
@@ -19448,9 +19646,6 @@
           </a:prstGeom>
           <a:ln w="17780">
             <a:prstDash val="dash"/>
-            <a:solidFill>
-              <a:srgbClr val="B26B12"/>
-            </a:solidFill>
             <a:tailEnd type="triangle" w="med" len="med"/>
           </a:ln>
           <a:effectLst/>
@@ -19487,7 +19682,7 @@
           <a:noFill/>
         </p:spPr>
         <p:txBody>
-          <a:bodyPr wrap="square" anchor="t" lIns="0" rIns="0" tIns="0" bIns="0">
+          <a:bodyPr wrap="square" lIns="0" tIns="0" rIns="0" bIns="0" anchor="t">
             <a:spAutoFit/>
           </a:bodyPr>
           <a:lstStyle/>
@@ -19555,6 +19750,7 @@
           <a:lstStyle/>
           <a:p>
             <a:pPr algn="ctr"/>
+            <a:endParaRPr/>
           </a:p>
         </p:txBody>
       </p:sp>
@@ -19575,7 +19771,7 @@
           <a:noFill/>
         </p:spPr>
         <p:txBody>
-          <a:bodyPr wrap="square" anchor="t" lIns="0" rIns="0" tIns="0" bIns="0">
+          <a:bodyPr wrap="square" lIns="0" tIns="0" rIns="0" bIns="0" anchor="t">
             <a:spAutoFit/>
           </a:bodyPr>
           <a:lstStyle/>
@@ -19662,6 +19858,7 @@
           <a:lstStyle/>
           <a:p>
             <a:pPr algn="ctr"/>
+            <a:endParaRPr/>
           </a:p>
         </p:txBody>
       </p:sp>
@@ -19682,7 +19879,7 @@
           <a:noFill/>
         </p:spPr>
         <p:txBody>
-          <a:bodyPr wrap="square" anchor="t" lIns="0" rIns="0" tIns="0" bIns="0">
+          <a:bodyPr wrap="square" lIns="0" tIns="0" rIns="0" bIns="0" anchor="t">
             <a:spAutoFit/>
           </a:bodyPr>
           <a:lstStyle/>
@@ -19769,6 +19966,7 @@
           <a:lstStyle/>
           <a:p>
             <a:pPr algn="ctr"/>
+            <a:endParaRPr/>
           </a:p>
         </p:txBody>
       </p:sp>
@@ -19789,7 +19987,7 @@
           <a:noFill/>
         </p:spPr>
         <p:txBody>
-          <a:bodyPr wrap="square" anchor="t" lIns="0" rIns="0" tIns="0" bIns="0">
+          <a:bodyPr wrap="square" lIns="0" tIns="0" rIns="0" bIns="0" anchor="t">
             <a:spAutoFit/>
           </a:bodyPr>
           <a:lstStyle/>
@@ -19887,7 +20085,7 @@
           <a:noFill/>
         </p:spPr>
         <p:txBody>
-          <a:bodyPr wrap="square" anchor="t" lIns="0" rIns="0" tIns="0" bIns="0">
+          <a:bodyPr wrap="square" lIns="0" tIns="0" rIns="0" bIns="0" anchor="t">
             <a:spAutoFit/>
           </a:bodyPr>
           <a:lstStyle/>
@@ -20003,7 +20201,7 @@
           <a:noFill/>
         </p:spPr>
         <p:txBody>
-          <a:bodyPr wrap="square" anchor="t" lIns="0" rIns="0" tIns="0" bIns="0">
+          <a:bodyPr wrap="square" lIns="0" tIns="0" rIns="0" bIns="0" anchor="t">
             <a:spAutoFit/>
           </a:bodyPr>
           <a:lstStyle/>
@@ -20066,7 +20264,7 @@
           <a:noFill/>
         </p:spPr>
         <p:txBody>
-          <a:bodyPr wrap="square" anchor="t" lIns="0" rIns="0" tIns="0" bIns="0">
+          <a:bodyPr wrap="square" lIns="0" tIns="0" rIns="0" bIns="0" anchor="t">
             <a:spAutoFit/>
           </a:bodyPr>
           <a:lstStyle/>
@@ -20108,7 +20306,7 @@
           <a:noFill/>
         </p:spPr>
         <p:txBody>
-          <a:bodyPr wrap="square" anchor="t" lIns="0" rIns="0" tIns="0" bIns="0">
+          <a:bodyPr wrap="square" lIns="0" tIns="0" rIns="0" bIns="0" anchor="t">
             <a:spAutoFit/>
           </a:bodyPr>
           <a:lstStyle/>
@@ -20151,7 +20349,7 @@
 </file>
 
 <file path=ppt/slides/slide8.xml><?xml version="1.0" encoding="utf-8"?>
-<p:sld xmlns:a="http://schemas.openxmlformats.org/drawingml/2006/main" xmlns:p="http://schemas.openxmlformats.org/presentationml/2006/main" xmlns:r="http://schemas.openxmlformats.org/officeDocument/2006/relationships">
+<p:sld xmlns:a="http://schemas.openxmlformats.org/drawingml/2006/main" xmlns:r="http://schemas.openxmlformats.org/officeDocument/2006/relationships" xmlns:p="http://schemas.openxmlformats.org/presentationml/2006/main">
   <p:cSld>
     <p:bg>
       <p:bgPr>
@@ -20167,7 +20365,14 @@
         <p:cNvGrpSpPr/>
         <p:nvPr/>
       </p:nvGrpSpPr>
-      <p:grpSpPr/>
+      <p:grpSpPr>
+        <a:xfrm>
+          <a:off x="0" y="0"/>
+          <a:ext cx="0" cy="0"/>
+          <a:chOff x="0" y="0"/>
+          <a:chExt cx="0" cy="0"/>
+        </a:xfrm>
+      </p:grpSpPr>
       <p:sp>
         <p:nvSpPr>
           <p:cNvPr id="2" name="Rectangle 1"/>
@@ -20209,6 +20414,7 @@
           <a:lstStyle/>
           <a:p>
             <a:pPr algn="ctr"/>
+            <a:endParaRPr/>
           </a:p>
         </p:txBody>
       </p:sp>
@@ -20253,6 +20459,7 @@
           <a:lstStyle/>
           <a:p>
             <a:pPr algn="ctr"/>
+            <a:endParaRPr/>
           </a:p>
         </p:txBody>
       </p:sp>
@@ -20273,7 +20480,7 @@
           <a:noFill/>
         </p:spPr>
         <p:txBody>
-          <a:bodyPr wrap="square" anchor="t" lIns="0" rIns="0" tIns="0" bIns="0">
+          <a:bodyPr wrap="square" lIns="0" tIns="0" rIns="0" bIns="0" anchor="t">
             <a:spAutoFit/>
           </a:bodyPr>
           <a:lstStyle/>
@@ -20341,6 +20548,7 @@
           <a:lstStyle/>
           <a:p>
             <a:pPr algn="ctr"/>
+            <a:endParaRPr/>
           </a:p>
         </p:txBody>
       </p:sp>
@@ -20361,7 +20569,7 @@
           <a:noFill/>
         </p:spPr>
         <p:txBody>
-          <a:bodyPr wrap="square" anchor="t" lIns="0" rIns="0" tIns="0" bIns="0">
+          <a:bodyPr wrap="square" lIns="0" tIns="0" rIns="0" bIns="0" anchor="t">
             <a:spAutoFit/>
           </a:bodyPr>
           <a:lstStyle/>
@@ -20448,6 +20656,7 @@
           <a:lstStyle/>
           <a:p>
             <a:pPr algn="ctr"/>
+            <a:endParaRPr/>
           </a:p>
         </p:txBody>
       </p:sp>
@@ -20468,7 +20677,7 @@
           <a:noFill/>
         </p:spPr>
         <p:txBody>
-          <a:bodyPr wrap="square" anchor="t" lIns="0" rIns="0" tIns="0" bIns="0">
+          <a:bodyPr wrap="square" lIns="0" tIns="0" rIns="0" bIns="0" anchor="t">
             <a:spAutoFit/>
           </a:bodyPr>
           <a:lstStyle/>
@@ -20555,6 +20764,7 @@
           <a:lstStyle/>
           <a:p>
             <a:pPr algn="ctr"/>
+            <a:endParaRPr/>
           </a:p>
         </p:txBody>
       </p:sp>
@@ -20575,7 +20785,7 @@
           <a:noFill/>
         </p:spPr>
         <p:txBody>
-          <a:bodyPr wrap="square" anchor="t" lIns="0" rIns="0" tIns="0" bIns="0">
+          <a:bodyPr wrap="square" lIns="0" tIns="0" rIns="0" bIns="0" anchor="t">
             <a:spAutoFit/>
           </a:bodyPr>
           <a:lstStyle/>
@@ -20673,7 +20883,7 @@
           <a:noFill/>
         </p:spPr>
         <p:txBody>
-          <a:bodyPr wrap="square" anchor="t" lIns="0" rIns="0" tIns="0" bIns="0">
+          <a:bodyPr wrap="square" lIns="0" tIns="0" rIns="0" bIns="0" anchor="t">
             <a:spAutoFit/>
           </a:bodyPr>
           <a:lstStyle/>
@@ -20752,7 +20962,7 @@
           <a:noFill/>
         </p:spPr>
         <p:txBody>
-          <a:bodyPr wrap="square" anchor="t" lIns="0" rIns="0" tIns="0" bIns="0">
+          <a:bodyPr wrap="square" lIns="0" tIns="0" rIns="0" bIns="0" anchor="t">
             <a:spAutoFit/>
           </a:bodyPr>
           <a:lstStyle/>
@@ -20794,7 +21004,7 @@
           <a:noFill/>
         </p:spPr>
         <p:txBody>
-          <a:bodyPr wrap="square" anchor="t" lIns="0" rIns="0" tIns="0" bIns="0">
+          <a:bodyPr wrap="square" lIns="0" tIns="0" rIns="0" bIns="0" anchor="t">
             <a:spAutoFit/>
           </a:bodyPr>
           <a:lstStyle/>
@@ -20956,6 +21166,7 @@
           <a:lstStyle/>
           <a:p>
             <a:pPr algn="ctr"/>
+            <a:endParaRPr/>
           </a:p>
         </p:txBody>
       </p:sp>
@@ -20976,7 +21187,7 @@
           <a:noFill/>
         </p:spPr>
         <p:txBody>
-          <a:bodyPr wrap="square" anchor="t" lIns="0" rIns="0" tIns="0" bIns="0">
+          <a:bodyPr wrap="square" lIns="0" tIns="0" rIns="0" bIns="0" anchor="t">
             <a:spAutoFit/>
           </a:bodyPr>
           <a:lstStyle/>
@@ -21042,6 +21253,7 @@
           <a:lstStyle/>
           <a:p>
             <a:pPr algn="ctr"/>
+            <a:endParaRPr/>
           </a:p>
         </p:txBody>
       </p:sp>
@@ -21062,7 +21274,7 @@
           <a:noFill/>
         </p:spPr>
         <p:txBody>
-          <a:bodyPr wrap="square" anchor="t" lIns="0" rIns="0" tIns="0" bIns="0">
+          <a:bodyPr wrap="square" lIns="0" tIns="0" rIns="0" bIns="0" anchor="t">
             <a:spAutoFit/>
           </a:bodyPr>
           <a:lstStyle/>
@@ -21128,6 +21340,7 @@
           <a:lstStyle/>
           <a:p>
             <a:pPr algn="ctr"/>
+            <a:endParaRPr/>
           </a:p>
         </p:txBody>
       </p:sp>
@@ -21148,7 +21361,7 @@
           <a:noFill/>
         </p:spPr>
         <p:txBody>
-          <a:bodyPr wrap="square" anchor="t" lIns="0" rIns="0" tIns="0" bIns="0">
+          <a:bodyPr wrap="square" lIns="0" tIns="0" rIns="0" bIns="0" anchor="t">
             <a:spAutoFit/>
           </a:bodyPr>
           <a:lstStyle/>
@@ -21190,7 +21403,7 @@
           <a:noFill/>
         </p:spPr>
         <p:txBody>
-          <a:bodyPr wrap="square" anchor="t" lIns="0" rIns="0" tIns="0" bIns="0">
+          <a:bodyPr wrap="square" lIns="0" tIns="0" rIns="0" bIns="0" anchor="t">
             <a:spAutoFit/>
           </a:bodyPr>
           <a:lstStyle/>
@@ -21232,7 +21445,7 @@
           <a:noFill/>
         </p:spPr>
         <p:txBody>
-          <a:bodyPr wrap="square" anchor="t" lIns="0" rIns="0" tIns="0" bIns="0">
+          <a:bodyPr wrap="square" lIns="0" tIns="0" rIns="0" bIns="0" anchor="t">
             <a:spAutoFit/>
           </a:bodyPr>
           <a:lstStyle/>
@@ -21275,7 +21488,7 @@
 </file>
 
 <file path=ppt/slides/slide9.xml><?xml version="1.0" encoding="utf-8"?>
-<p:sld xmlns:a="http://schemas.openxmlformats.org/drawingml/2006/main" xmlns:p="http://schemas.openxmlformats.org/presentationml/2006/main" xmlns:r="http://schemas.openxmlformats.org/officeDocument/2006/relationships">
+<p:sld xmlns:a="http://schemas.openxmlformats.org/drawingml/2006/main" xmlns:r="http://schemas.openxmlformats.org/officeDocument/2006/relationships" xmlns:p="http://schemas.openxmlformats.org/presentationml/2006/main">
   <p:cSld>
     <p:bg>
       <p:bgPr>
@@ -21291,7 +21504,14 @@
         <p:cNvGrpSpPr/>
         <p:nvPr/>
       </p:nvGrpSpPr>
-      <p:grpSpPr/>
+      <p:grpSpPr>
+        <a:xfrm>
+          <a:off x="0" y="0"/>
+          <a:ext cx="0" cy="0"/>
+          <a:chOff x="0" y="0"/>
+          <a:chExt cx="0" cy="0"/>
+        </a:xfrm>
+      </p:grpSpPr>
       <p:sp>
         <p:nvSpPr>
           <p:cNvPr id="2" name="Rectangle 1"/>
@@ -21333,6 +21553,7 @@
           <a:lstStyle/>
           <a:p>
             <a:pPr algn="ctr"/>
+            <a:endParaRPr/>
           </a:p>
         </p:txBody>
       </p:sp>
@@ -21377,6 +21598,7 @@
           <a:lstStyle/>
           <a:p>
             <a:pPr algn="ctr"/>
+            <a:endParaRPr/>
           </a:p>
         </p:txBody>
       </p:sp>
@@ -21397,7 +21619,7 @@
           <a:noFill/>
         </p:spPr>
         <p:txBody>
-          <a:bodyPr wrap="square" anchor="t" lIns="0" rIns="0" tIns="0" bIns="0">
+          <a:bodyPr wrap="square" lIns="0" tIns="0" rIns="0" bIns="0" anchor="t">
             <a:spAutoFit/>
           </a:bodyPr>
           <a:lstStyle/>
@@ -21513,6 +21735,7 @@
           <a:lstStyle/>
           <a:p>
             <a:pPr algn="ctr"/>
+            <a:endParaRPr/>
           </a:p>
         </p:txBody>
       </p:sp>
@@ -21533,7 +21756,7 @@
           <a:noFill/>
         </p:spPr>
         <p:txBody>
-          <a:bodyPr wrap="square" anchor="t" lIns="0" rIns="0" tIns="0" bIns="0">
+          <a:bodyPr wrap="square" lIns="0" tIns="0" rIns="0" bIns="0" anchor="t">
             <a:spAutoFit/>
           </a:bodyPr>
           <a:lstStyle/>
@@ -21638,6 +21861,7 @@
           <a:lstStyle/>
           <a:p>
             <a:pPr algn="ctr"/>
+            <a:endParaRPr/>
           </a:p>
         </p:txBody>
       </p:sp>
@@ -21658,7 +21882,7 @@
           <a:noFill/>
         </p:spPr>
         <p:txBody>
-          <a:bodyPr wrap="square" anchor="t" lIns="0" rIns="0" tIns="0" bIns="0">
+          <a:bodyPr wrap="square" lIns="0" tIns="0" rIns="0" bIns="0" anchor="t">
             <a:spAutoFit/>
           </a:bodyPr>
           <a:lstStyle/>
@@ -21763,6 +21987,7 @@
           <a:lstStyle/>
           <a:p>
             <a:pPr algn="ctr"/>
+            <a:endParaRPr/>
           </a:p>
         </p:txBody>
       </p:sp>
@@ -21783,7 +22008,7 @@
           <a:noFill/>
         </p:spPr>
         <p:txBody>
-          <a:bodyPr wrap="square" anchor="t" lIns="0" rIns="0" tIns="0" bIns="0">
+          <a:bodyPr wrap="square" lIns="0" tIns="0" rIns="0" bIns="0" anchor="t">
             <a:spAutoFit/>
           </a:bodyPr>
           <a:lstStyle/>
@@ -21888,6 +22113,7 @@
           <a:lstStyle/>
           <a:p>
             <a:pPr algn="ctr"/>
+            <a:endParaRPr/>
           </a:p>
         </p:txBody>
       </p:sp>
@@ -21908,7 +22134,7 @@
           <a:noFill/>
         </p:spPr>
         <p:txBody>
-          <a:bodyPr wrap="square" anchor="t" lIns="0" rIns="0" tIns="0" bIns="0">
+          <a:bodyPr wrap="square" lIns="0" tIns="0" rIns="0" bIns="0" anchor="t">
             <a:spAutoFit/>
           </a:bodyPr>
           <a:lstStyle/>
@@ -22013,6 +22239,7 @@
           <a:lstStyle/>
           <a:p>
             <a:pPr algn="ctr"/>
+            <a:endParaRPr/>
           </a:p>
         </p:txBody>
       </p:sp>
@@ -22033,7 +22260,7 @@
           <a:noFill/>
         </p:spPr>
         <p:txBody>
-          <a:bodyPr wrap="square" anchor="t" lIns="0" rIns="0" tIns="0" bIns="0">
+          <a:bodyPr wrap="square" lIns="0" tIns="0" rIns="0" bIns="0" anchor="t">
             <a:spAutoFit/>
           </a:bodyPr>
           <a:lstStyle/>
@@ -22138,6 +22365,7 @@
           <a:lstStyle/>
           <a:p>
             <a:pPr algn="ctr"/>
+            <a:endParaRPr/>
           </a:p>
         </p:txBody>
       </p:sp>
@@ -22158,7 +22386,7 @@
           <a:noFill/>
         </p:spPr>
         <p:txBody>
-          <a:bodyPr wrap="square" anchor="t" lIns="0" rIns="0" tIns="0" bIns="0">
+          <a:bodyPr wrap="square" lIns="0" tIns="0" rIns="0" bIns="0" anchor="t">
             <a:spAutoFit/>
           </a:bodyPr>
           <a:lstStyle/>
@@ -22263,6 +22491,7 @@
           <a:lstStyle/>
           <a:p>
             <a:pPr algn="ctr"/>
+            <a:endParaRPr/>
           </a:p>
         </p:txBody>
       </p:sp>
@@ -22283,7 +22512,7 @@
           <a:noFill/>
         </p:spPr>
         <p:txBody>
-          <a:bodyPr wrap="square" anchor="t" lIns="0" rIns="0" tIns="0" bIns="0">
+          <a:bodyPr wrap="square" lIns="0" tIns="0" rIns="0" bIns="0" anchor="t">
             <a:spAutoFit/>
           </a:bodyPr>
           <a:lstStyle/>
@@ -22388,6 +22617,7 @@
           <a:lstStyle/>
           <a:p>
             <a:pPr algn="ctr"/>
+            <a:endParaRPr/>
           </a:p>
         </p:txBody>
       </p:sp>
@@ -22408,7 +22638,7 @@
           <a:noFill/>
         </p:spPr>
         <p:txBody>
-          <a:bodyPr wrap="square" anchor="t" lIns="0" rIns="0" tIns="0" bIns="0">
+          <a:bodyPr wrap="square" lIns="0" tIns="0" rIns="0" bIns="0" anchor="t">
             <a:spAutoFit/>
           </a:bodyPr>
           <a:lstStyle/>
@@ -22449,9 +22679,6 @@
           </a:prstGeom>
           <a:ln w="17780">
             <a:prstDash val="dash"/>
-            <a:solidFill>
-              <a:srgbClr val="B26B12"/>
-            </a:solidFill>
           </a:ln>
           <a:effectLst/>
         </p:spPr>
@@ -22511,6 +22738,7 @@
           <a:lstStyle/>
           <a:p>
             <a:pPr algn="ctr"/>
+            <a:endParaRPr/>
           </a:p>
         </p:txBody>
       </p:sp>
@@ -22531,7 +22759,7 @@
           <a:noFill/>
         </p:spPr>
         <p:txBody>
-          <a:bodyPr wrap="square" anchor="t" lIns="0" rIns="0" tIns="0" bIns="0">
+          <a:bodyPr wrap="square" lIns="0" tIns="0" rIns="0" bIns="0" anchor="t">
             <a:spAutoFit/>
           </a:bodyPr>
           <a:lstStyle/>
@@ -22573,7 +22801,7 @@
           <a:noFill/>
         </p:spPr>
         <p:txBody>
-          <a:bodyPr wrap="square" anchor="t" lIns="0" rIns="0" tIns="0" bIns="0">
+          <a:bodyPr wrap="square" lIns="0" tIns="0" rIns="0" bIns="0" anchor="t">
             <a:spAutoFit/>
           </a:bodyPr>
           <a:lstStyle/>
@@ -22636,7 +22864,7 @@
           <a:noFill/>
         </p:spPr>
         <p:txBody>
-          <a:bodyPr wrap="square" anchor="t" lIns="0" rIns="0" tIns="0" bIns="0">
+          <a:bodyPr wrap="square" lIns="0" tIns="0" rIns="0" bIns="0" anchor="t">
             <a:spAutoFit/>
           </a:bodyPr>
           <a:lstStyle/>
@@ -22678,7 +22906,7 @@
           <a:noFill/>
         </p:spPr>
         <p:txBody>
-          <a:bodyPr wrap="square" anchor="t" lIns="0" rIns="0" tIns="0" bIns="0">
+          <a:bodyPr wrap="square" lIns="0" tIns="0" rIns="0" bIns="0" anchor="t">
             <a:spAutoFit/>
           </a:bodyPr>
           <a:lstStyle/>

</xml_diff>

<commit_message>
Expand Speaker Companion: Q&A bank, facts cheat-sheet, glossary
Grew the companion from a per-slide script into a full presenter kit (5 -> 9 pages):
- Facts at a glance: the numbers to have ready (70 statements, GA date, Standard
  edition, 45/53, DEPLOY-not-PLAN, nightly cadence, cost).
- Questions you'll get: ~18 anticipated audience questions across six themes
  (adoption/cost, production/risk, alternatives, security, scope, ops), each with
  a prepared answer that stays honest about gaps (concurrent deploy untested,
  streams preview, scale unmeasured).
- Glossary of the terms that may come up.
- Added backup blocks to slides 9, 11, 14 which lacked them.

Every answer grounded in what we verified this session. Regenerable from
companion.html.

Co-Authored-By: Claude Opus 4.8 <noreply@anthropic.com>
Claude-Session: https://claude.ai/code/session_01K8zkg1ABYKGv6DLUxPXUSx
</commit_message>
<xml_diff>
--- a/docs/DCM_Presentation.pptx
+++ b/docs/DCM_Presentation.pptx
@@ -4388,7 +4388,7 @@
         </p:nvSpPr>
         <p:spPr>
           <a:xfrm>
-            <a:off x="3108960" y="3017520"/>
+            <a:off x="2834640" y="3003804"/>
             <a:ext cx="1645920" cy="274320"/>
           </a:xfrm>
           <a:prstGeom prst="rect">
@@ -4411,7 +4411,7 @@
               </a:spcAft>
             </a:pPr>
             <a:r>
-              <a:rPr sz="950" b="0">
+              <a:rPr sz="950" b="0" dirty="0">
                 <a:solidFill>
                   <a:srgbClr val="6C7B88"/>
                 </a:solidFill>
@@ -4546,7 +4546,7 @@
         </p:nvSpPr>
         <p:spPr>
           <a:xfrm>
-            <a:off x="6812280" y="4224528"/>
+            <a:off x="6702552" y="3922776"/>
             <a:ext cx="3291840" cy="274320"/>
           </a:xfrm>
           <a:prstGeom prst="rect">
@@ -4569,7 +4569,7 @@
               </a:spcAft>
             </a:pPr>
             <a:r>
-              <a:rPr sz="900" b="0">
+              <a:rPr sz="900" b="0" dirty="0">
                 <a:solidFill>
                   <a:srgbClr val="B26B12"/>
                 </a:solidFill>

</xml_diff>

<commit_message>
F16: one DCM project object per environment (dev/prod cannot share)
Found in rehearsal: deploying PROD (USING CONFIGURATION PROD) against the same
project object that deployed DEV DROPPED the entire dev database - a DCM project
holds one desired state, and the _DEV->_PROD rename made every dev object read as
'no longer declared'. Observed DROP DATABASE DEMO_PBI_DEV in the changeset.

This is Snowflake's intended model (its scaffold names the project DEMO_PROJECT_DEV).
Verified: two project objects, deploy DEV to one and PROD to the other, and both
databases coexist - neither drops the other.

Updated the runsheet manifest (two targets, DEMO_CAPACITIES_DEV / _PROD) and the
prod deploy (targets the _PROD project, /DCM_DEMO/ subfolder path). Recorded F16;
CLAUDE.md updated.

Co-Authored-By: Claude Opus 4.8 <noreply@anthropic.com>
Claude-Session: https://claude.ai/code/session_01K8zkg1ABYKGv6DLUxPXUSx
</commit_message>
<xml_diff>
--- a/docs/DCM_Presentation.pptx
+++ b/docs/DCM_Presentation.pptx
@@ -6480,7 +6480,9 @@
             <a:ext cx="1005840" cy="896112"/>
           </a:xfrm>
           <a:prstGeom prst="bentConnector3">
-            <a:avLst/>
+            <a:avLst>
+              <a:gd name="adj1" fmla="val 100977"/>
+            </a:avLst>
           </a:prstGeom>
           <a:ln w="17780">
             <a:solidFill>
@@ -6547,19 +6549,65 @@
           </a:p>
         </p:txBody>
       </p:sp>
+      <p:sp>
+        <p:nvSpPr>
+          <p:cNvPr id="18" name="TextBox 17"/>
+          <p:cNvSpPr txBox="1"/>
+          <p:nvPr/>
+        </p:nvSpPr>
+        <p:spPr>
+          <a:xfrm>
+            <a:off x="2517005" y="3200400"/>
+            <a:ext cx="457200" cy="274320"/>
+          </a:xfrm>
+          <a:prstGeom prst="rect">
+            <a:avLst/>
+          </a:prstGeom>
+          <a:noFill/>
+        </p:spPr>
+        <p:txBody>
+          <a:bodyPr wrap="square" lIns="0" tIns="0" rIns="0" bIns="0" anchor="t">
+            <a:spAutoFit/>
+          </a:bodyPr>
+          <a:lstStyle/>
+          <a:p>
+            <a:pPr algn="l">
+              <a:spcBef>
+                <a:spcPts val="0"/>
+              </a:spcBef>
+              <a:spcAft>
+                <a:spcPts val="400"/>
+              </a:spcAft>
+            </a:pPr>
+            <a:r>
+              <a:rPr sz="950" b="0" dirty="0">
+                <a:solidFill>
+                  <a:srgbClr val="6C7B88"/>
+                </a:solidFill>
+                <a:latin typeface="DejaVu Sans Mono"/>
+              </a:rPr>
+              <a:t>yes</a:t>
+            </a:r>
+          </a:p>
+        </p:txBody>
+      </p:sp>
       <p:cxnSp>
         <p:nvCxnSpPr>
-          <p:cNvPr id="17" name="Connector 16"/>
-          <p:cNvCxnSpPr/>
+          <p:cNvPr id="19" name="Connector 18"/>
+          <p:cNvCxnSpPr>
+            <a:cxnSpLocks/>
+          </p:cNvCxnSpPr>
           <p:nvPr/>
         </p:nvCxnSpPr>
         <p:spPr>
-          <a:xfrm flipH="1">
-            <a:off x="2697480" y="3017520"/>
-            <a:ext cx="91440" cy="621792"/>
+          <a:xfrm rot="5400000">
+            <a:off x="1091253" y="4291653"/>
+            <a:ext cx="972174" cy="228600"/>
           </a:xfrm>
           <a:prstGeom prst="bentConnector3">
-            <a:avLst/>
+            <a:avLst>
+              <a:gd name="adj1" fmla="val 1139"/>
+            </a:avLst>
           </a:prstGeom>
           <a:ln w="17780">
             <a:solidFill>
@@ -6586,14 +6634,14 @@
       </p:cxnSp>
       <p:sp>
         <p:nvSpPr>
-          <p:cNvPr id="18" name="TextBox 17"/>
-          <p:cNvSpPr txBox="1"/>
-          <p:nvPr/>
-        </p:nvSpPr>
-        <p:spPr>
-          <a:xfrm>
-            <a:off x="2834639" y="3200400"/>
-            <a:ext cx="457200" cy="274320"/>
+          <p:cNvPr id="20" name="TextBox 19"/>
+          <p:cNvSpPr txBox="1"/>
+          <p:nvPr/>
+        </p:nvSpPr>
+        <p:spPr>
+          <a:xfrm>
+            <a:off x="1492730" y="4480560"/>
+            <a:ext cx="640080" cy="274320"/>
           </a:xfrm>
           <a:prstGeom prst="rect">
             <a:avLst/>
@@ -6615,86 +6663,7 @@
               </a:spcAft>
             </a:pPr>
             <a:r>
-              <a:rPr sz="950" b="0">
-                <a:solidFill>
-                  <a:srgbClr val="6C7B88"/>
-                </a:solidFill>
-                <a:latin typeface="DejaVu Sans Mono"/>
-              </a:rPr>
-              <a:t>yes</a:t>
-            </a:r>
-          </a:p>
-        </p:txBody>
-      </p:sp>
-      <p:cxnSp>
-        <p:nvCxnSpPr>
-          <p:cNvPr id="19" name="Connector 18"/>
-          <p:cNvCxnSpPr/>
-          <p:nvPr/>
-        </p:nvCxnSpPr>
-        <p:spPr>
-          <a:xfrm flipH="1">
-            <a:off x="1828800" y="4206240"/>
-            <a:ext cx="320040" cy="667512"/>
-          </a:xfrm>
-          <a:prstGeom prst="bentConnector3">
-            <a:avLst/>
-          </a:prstGeom>
-          <a:ln w="17780">
-            <a:solidFill>
-              <a:srgbClr val="6C7B88"/>
-            </a:solidFill>
-            <a:tailEnd type="triangle" w="med" len="med"/>
-          </a:ln>
-          <a:effectLst/>
-        </p:spPr>
-        <p:style>
-          <a:lnRef idx="2">
-            <a:schemeClr val="accent1"/>
-          </a:lnRef>
-          <a:fillRef idx="0">
-            <a:schemeClr val="accent1"/>
-          </a:fillRef>
-          <a:effectRef idx="1">
-            <a:schemeClr val="accent1"/>
-          </a:effectRef>
-          <a:fontRef idx="minor">
-            <a:schemeClr val="tx1"/>
-          </a:fontRef>
-        </p:style>
-      </p:cxnSp>
-      <p:sp>
-        <p:nvSpPr>
-          <p:cNvPr id="20" name="TextBox 19"/>
-          <p:cNvSpPr txBox="1"/>
-          <p:nvPr/>
-        </p:nvSpPr>
-        <p:spPr>
-          <a:xfrm>
-            <a:off x="1463040" y="4480560"/>
-            <a:ext cx="640080" cy="274320"/>
-          </a:xfrm>
-          <a:prstGeom prst="rect">
-            <a:avLst/>
-          </a:prstGeom>
-          <a:noFill/>
-        </p:spPr>
-        <p:txBody>
-          <a:bodyPr wrap="square" lIns="0" tIns="0" rIns="0" bIns="0" anchor="t">
-            <a:spAutoFit/>
-          </a:bodyPr>
-          <a:lstStyle/>
-          <a:p>
-            <a:pPr algn="l">
-              <a:spcBef>
-                <a:spcPts val="0"/>
-              </a:spcBef>
-              <a:spcAft>
-                <a:spcPts val="400"/>
-              </a:spcAft>
-            </a:pPr>
-            <a:r>
-              <a:rPr sz="900" b="0">
+              <a:rPr sz="900" b="0" dirty="0">
                 <a:solidFill>
                   <a:srgbClr val="4B6650"/>
                 </a:solidFill>
@@ -6708,16 +6677,21 @@
       <p:cxnSp>
         <p:nvCxnSpPr>
           <p:cNvPr id="21" name="Connector 20"/>
-          <p:cNvCxnSpPr/>
+          <p:cNvCxnSpPr>
+            <a:cxnSpLocks/>
+            <a:endCxn id="13" idx="0"/>
+          </p:cNvCxnSpPr>
           <p:nvPr/>
         </p:nvCxnSpPr>
         <p:spPr>
-          <a:xfrm>
-            <a:off x="3154680" y="4206240"/>
-            <a:ext cx="548640" cy="667512"/>
+          <a:xfrm rot="16200000" flipH="1">
+            <a:off x="3363620" y="4323741"/>
+            <a:ext cx="1005840" cy="130758"/>
           </a:xfrm>
           <a:prstGeom prst="bentConnector3">
-            <a:avLst/>
+            <a:avLst>
+              <a:gd name="adj1" fmla="val 413"/>
+            </a:avLst>
           </a:prstGeom>
           <a:ln w="17780">
             <a:solidFill>
@@ -7255,6 +7229,49 @@
           </a:p>
         </p:txBody>
       </p:sp>
+      <p:cxnSp>
+        <p:nvCxnSpPr>
+          <p:cNvPr id="55" name="Straight Arrow Connector 54">
+            <a:extLst>
+              <a:ext uri="{FF2B5EF4-FFF2-40B4-BE49-F238E27FC236}">
+                <a16:creationId xmlns:a16="http://schemas.microsoft.com/office/drawing/2014/main" id="{A2743890-040E-83D2-683B-F2CE4D1356C2}"/>
+              </a:ext>
+            </a:extLst>
+          </p:cNvPr>
+          <p:cNvCxnSpPr/>
+          <p:nvPr/>
+        </p:nvCxnSpPr>
+        <p:spPr>
+          <a:xfrm>
+            <a:off x="2971799" y="3017520"/>
+            <a:ext cx="0" cy="621792"/>
+          </a:xfrm>
+          <a:prstGeom prst="straightConnector1">
+            <a:avLst/>
+          </a:prstGeom>
+          <a:ln w="17780">
+            <a:solidFill>
+              <a:srgbClr val="6C7B88"/>
+            </a:solidFill>
+            <a:tailEnd type="triangle" w="med" len="med"/>
+          </a:ln>
+          <a:effectLst/>
+        </p:spPr>
+        <p:style>
+          <a:lnRef idx="2">
+            <a:schemeClr val="accent1"/>
+          </a:lnRef>
+          <a:fillRef idx="0">
+            <a:schemeClr val="accent1"/>
+          </a:fillRef>
+          <a:effectRef idx="1">
+            <a:schemeClr val="accent1"/>
+          </a:effectRef>
+          <a:fontRef idx="minor">
+            <a:schemeClr val="tx1"/>
+          </a:fontRef>
+        </p:style>
+      </p:cxnSp>
     </p:spTree>
   </p:cSld>
   <p:clrMapOvr>
@@ -10830,8 +10847,8 @@
         </p:nvSpPr>
         <p:spPr>
           <a:xfrm>
-            <a:off x="7543800" y="2468880"/>
-            <a:ext cx="3687775" cy="1463040"/>
+            <a:off x="7342632" y="2468880"/>
+            <a:ext cx="3888943" cy="496418"/>
           </a:xfrm>
           <a:prstGeom prst="rect">
             <a:avLst/>
@@ -10850,7 +10867,7 @@
               </a:lnSpc>
             </a:pPr>
             <a:r>
-              <a:rPr sz="2800" b="1">
+              <a:rPr sz="2800" b="1" dirty="0">
                 <a:solidFill>
                   <a:srgbClr val="25313A"/>
                 </a:solidFill>
@@ -10859,7 +10876,7 @@
               <a:t>Gate the </a:t>
             </a:r>
             <a:r>
-              <a:rPr sz="2800" b="1">
+              <a:rPr sz="2800" b="1" dirty="0">
                 <a:solidFill>
                   <a:srgbClr val="B26B12"/>
                 </a:solidFill>
@@ -10868,7 +10885,7 @@
               <a:t>data</a:t>
             </a:r>
             <a:r>
-              <a:rPr sz="2800" b="1">
+              <a:rPr sz="2800" b="1" dirty="0">
                 <a:solidFill>
                   <a:srgbClr val="25313A"/>
                 </a:solidFill>
@@ -10887,7 +10904,7 @@
         </p:nvSpPr>
         <p:spPr>
           <a:xfrm>
-            <a:off x="7543800" y="3154680"/>
+            <a:off x="7342632" y="2880360"/>
             <a:ext cx="3687775" cy="1463040"/>
           </a:xfrm>
           <a:prstGeom prst="rect">
@@ -10907,7 +10924,7 @@
               </a:lnSpc>
             </a:pPr>
             <a:r>
-              <a:rPr sz="2800" b="1">
+              <a:rPr sz="2800" b="1" dirty="0">
                 <a:solidFill>
                   <a:srgbClr val="25313A"/>
                 </a:solidFill>

</xml_diff>